<commit_message>
Alternate dark and white backgrounds across the deck
Slides 3 to 13 now alternate between the road layout and the white
Standard_Light layout. On white, text turns navy, lime gives way to Tenneco
blue and panels become a soft navy tint. The 4M results slide stays dark so
its lime numbers lead.

Co-Authored-By: Claude Opus 5.5 <noreply@anthropic.com>
Claude-Session: https://claude.ai/code/session_012Ye9scek5k3HGgfD9p6dky
</commit_message>
<xml_diff>
--- a/presentations/Tenneco_Robotics_Setter_Diego_de_Leon.pptx
+++ b/presentations/Tenneco_Robotics_Setter_Diego_de_Leon.pptx
@@ -17038,7 +17038,7 @@
             <a:r>
               <a:rPr sz="2800" b="1">
                 <a:solidFill>
-                  <a:srgbClr val="FFFFFF"/>
+                  <a:srgbClr val="051C2C"/>
                 </a:solidFill>
                 <a:latin typeface="Segoe UI"/>
               </a:rPr>
@@ -17065,7 +17065,7 @@
             <a:r>
               <a:rPr sz="1300" b="0">
                 <a:solidFill>
-                  <a:srgbClr val="D5FB00"/>
+                  <a:srgbClr val="0033A0"/>
                 </a:solidFill>
                 <a:latin typeface="Segoe UI"/>
               </a:rPr>
@@ -17074,22 +17074,12 @@
           </a:p>
         </p:txBody>
       </p:sp>
-      <p:pic>
-        <p:nvPicPr>
-          <p:cNvPr id="4" name="!! Card 1" descr="Decorative glass panel"/>
-          <p:cNvPicPr>
-            <a:picLocks noChangeAspect="1"/>
-          </p:cNvPicPr>
+      <p:sp>
+        <p:nvSpPr>
+          <p:cNvPr id="4" name="!! Card 1"/>
+          <p:cNvSpPr/>
           <p:nvPr/>
-        </p:nvPicPr>
-        <p:blipFill>
-          <a:blip r:embed="rId2">
-            <a:alphaModFix amt="50000"/>
-          </a:blip>
-          <a:stretch>
-            <a:fillRect/>
-          </a:stretch>
-        </p:blipFill>
+        </p:nvSpPr>
         <p:spPr>
           <a:xfrm>
             <a:off x="256032" y="1691640"/>
@@ -17098,27 +17088,15 @@
           <a:prstGeom prst="rect">
             <a:avLst/>
           </a:prstGeom>
-        </p:spPr>
-      </p:pic>
-      <p:sp>
-        <p:nvSpPr>
-          <p:cNvPr id="5" name="!! Card 1 rim"/>
-          <p:cNvSpPr/>
-          <p:nvPr/>
-        </p:nvSpPr>
-        <p:spPr>
-          <a:xfrm>
-            <a:off x="256032" y="1691640"/>
-            <a:ext cx="3703320" cy="3063240"/>
-          </a:xfrm>
-          <a:prstGeom prst="rect">
-            <a:avLst/>
-          </a:prstGeom>
-          <a:noFill/>
+          <a:solidFill>
+            <a:srgbClr val="051C2C">
+              <a:alpha val="4000"/>
+            </a:srgbClr>
+          </a:solidFill>
           <a:ln w="9525">
             <a:solidFill>
-              <a:srgbClr val="FFFFFF">
-                <a:alpha val="16000"/>
+              <a:srgbClr val="051C2C">
+                <a:alpha val="12000"/>
               </a:srgbClr>
             </a:solidFill>
           </a:ln>
@@ -17133,14 +17111,56 @@
       </p:sp>
       <p:sp>
         <p:nvSpPr>
+          <p:cNvPr id="5" name="TextBox 4"/>
+          <p:cNvSpPr txBox="1"/>
+          <p:nvPr/>
+        </p:nvSpPr>
+        <p:spPr>
+          <a:xfrm>
+            <a:off x="585216" y="1965960"/>
+            <a:ext cx="3017520" cy="502920"/>
+          </a:xfrm>
+          <a:prstGeom prst="rect">
+            <a:avLst/>
+          </a:prstGeom>
+          <a:noFill/>
+        </p:spPr>
+        <p:txBody>
+          <a:bodyPr wrap="square" lIns="0" rIns="0" tIns="0" bIns="0" anchor="t">
+            <a:spAutoFit/>
+          </a:bodyPr>
+          <a:lstStyle/>
+          <a:p>
+            <a:pPr algn="l">
+              <a:spcBef>
+                <a:spcPts val="0"/>
+              </a:spcBef>
+              <a:spcAft>
+                <a:spcPts val="0"/>
+              </a:spcAft>
+            </a:pPr>
+            <a:r>
+              <a:rPr sz="3000" b="1" i="0">
+                <a:solidFill>
+                  <a:srgbClr val="0033A0"/>
+                </a:solidFill>
+                <a:latin typeface="Segoe UI"/>
+              </a:rPr>
+              <a:t>01</a:t>
+            </a:r>
+          </a:p>
+        </p:txBody>
+      </p:sp>
+      <p:sp>
+        <p:nvSpPr>
           <p:cNvPr id="6" name="TextBox 5"/>
           <p:cNvSpPr txBox="1"/>
           <p:nvPr/>
         </p:nvSpPr>
         <p:spPr>
           <a:xfrm>
-            <a:off x="585216" y="1965960"/>
-            <a:ext cx="3017520" cy="502920"/>
+            <a:off x="585216" y="2651760"/>
+            <a:ext cx="3017520" cy="320040"/>
           </a:xfrm>
           <a:prstGeom prst="rect">
             <a:avLst/>
@@ -17162,51 +17182,9 @@
               </a:spcAft>
             </a:pPr>
             <a:r>
-              <a:rPr sz="3000" b="1" i="0">
-                <a:solidFill>
-                  <a:srgbClr val="D5FB00"/>
-                </a:solidFill>
-                <a:latin typeface="Segoe UI"/>
-              </a:rPr>
-              <a:t>01</a:t>
-            </a:r>
-          </a:p>
-        </p:txBody>
-      </p:sp>
-      <p:sp>
-        <p:nvSpPr>
-          <p:cNvPr id="7" name="TextBox 6"/>
-          <p:cNvSpPr txBox="1"/>
-          <p:nvPr/>
-        </p:nvSpPr>
-        <p:spPr>
-          <a:xfrm>
-            <a:off x="585216" y="2651760"/>
-            <a:ext cx="3017520" cy="320040"/>
-          </a:xfrm>
-          <a:prstGeom prst="rect">
-            <a:avLst/>
-          </a:prstGeom>
-          <a:noFill/>
-        </p:spPr>
-        <p:txBody>
-          <a:bodyPr wrap="square" lIns="0" rIns="0" tIns="0" bIns="0" anchor="t">
-            <a:spAutoFit/>
-          </a:bodyPr>
-          <a:lstStyle/>
-          <a:p>
-            <a:pPr algn="l">
-              <a:spcBef>
-                <a:spcPts val="0"/>
-              </a:spcBef>
-              <a:spcAft>
-                <a:spcPts val="0"/>
-              </a:spcAft>
-            </a:pPr>
-            <a:r>
               <a:rPr sz="1600" b="1" i="0">
                 <a:solidFill>
-                  <a:srgbClr val="FFFFFF"/>
+                  <a:srgbClr val="051C2C"/>
                 </a:solidFill>
                 <a:latin typeface="Segoe UI"/>
               </a:rPr>
@@ -17217,7 +17195,7 @@
       </p:sp>
       <p:sp>
         <p:nvSpPr>
-          <p:cNvPr id="8" name="TextBox 7"/>
+          <p:cNvPr id="7" name="TextBox 6"/>
           <p:cNvSpPr txBox="1"/>
           <p:nvPr/>
         </p:nvSpPr>
@@ -17251,7 +17229,7 @@
             <a:r>
               <a:rPr sz="1200" b="0" i="0">
                 <a:solidFill>
-                  <a:srgbClr val="C6CDD1"/>
+                  <a:srgbClr val="6B7A83"/>
                 </a:solidFill>
                 <a:latin typeface="Segoe UI"/>
               </a:rPr>
@@ -17260,22 +17238,12 @@
           </a:p>
         </p:txBody>
       </p:sp>
-      <p:pic>
-        <p:nvPicPr>
-          <p:cNvPr id="9" name="!! Card 2" descr="Decorative glass panel"/>
-          <p:cNvPicPr>
-            <a:picLocks noChangeAspect="1"/>
-          </p:cNvPicPr>
+      <p:sp>
+        <p:nvSpPr>
+          <p:cNvPr id="8" name="!! Card 2"/>
+          <p:cNvSpPr/>
           <p:nvPr/>
-        </p:nvPicPr>
-        <p:blipFill>
-          <a:blip r:embed="rId3">
-            <a:alphaModFix amt="50000"/>
-          </a:blip>
-          <a:stretch>
-            <a:fillRect/>
-          </a:stretch>
-        </p:blipFill>
+        </p:nvSpPr>
         <p:spPr>
           <a:xfrm>
             <a:off x="4251960" y="1691640"/>
@@ -17284,27 +17252,15 @@
           <a:prstGeom prst="rect">
             <a:avLst/>
           </a:prstGeom>
-        </p:spPr>
-      </p:pic>
-      <p:sp>
-        <p:nvSpPr>
-          <p:cNvPr id="10" name="!! Card 2 rim"/>
-          <p:cNvSpPr/>
-          <p:nvPr/>
-        </p:nvSpPr>
-        <p:spPr>
-          <a:xfrm>
-            <a:off x="4251960" y="1691640"/>
-            <a:ext cx="3703320" cy="3063240"/>
-          </a:xfrm>
-          <a:prstGeom prst="rect">
-            <a:avLst/>
-          </a:prstGeom>
-          <a:noFill/>
+          <a:solidFill>
+            <a:srgbClr val="051C2C">
+              <a:alpha val="4000"/>
+            </a:srgbClr>
+          </a:solidFill>
           <a:ln w="9525">
             <a:solidFill>
-              <a:srgbClr val="FFFFFF">
-                <a:alpha val="16000"/>
+              <a:srgbClr val="051C2C">
+                <a:alpha val="12000"/>
               </a:srgbClr>
             </a:solidFill>
           </a:ln>
@@ -17319,7 +17275,7 @@
       </p:sp>
       <p:sp>
         <p:nvSpPr>
-          <p:cNvPr id="11" name="TextBox 10"/>
+          <p:cNvPr id="9" name="TextBox 8"/>
           <p:cNvSpPr txBox="1"/>
           <p:nvPr/>
         </p:nvSpPr>
@@ -17350,7 +17306,7 @@
             <a:r>
               <a:rPr sz="3000" b="1" i="0">
                 <a:solidFill>
-                  <a:srgbClr val="D5FB00"/>
+                  <a:srgbClr val="0033A0"/>
                 </a:solidFill>
                 <a:latin typeface="Segoe UI"/>
               </a:rPr>
@@ -17361,7 +17317,7 @@
       </p:sp>
       <p:sp>
         <p:nvSpPr>
-          <p:cNvPr id="12" name="TextBox 11"/>
+          <p:cNvPr id="10" name="TextBox 9"/>
           <p:cNvSpPr txBox="1"/>
           <p:nvPr/>
         </p:nvSpPr>
@@ -17392,7 +17348,7 @@
             <a:r>
               <a:rPr sz="1600" b="1" i="0">
                 <a:solidFill>
-                  <a:srgbClr val="FFFFFF"/>
+                  <a:srgbClr val="051C2C"/>
                 </a:solidFill>
                 <a:latin typeface="Segoe UI"/>
               </a:rPr>
@@ -17403,7 +17359,7 @@
       </p:sp>
       <p:sp>
         <p:nvSpPr>
-          <p:cNvPr id="13" name="TextBox 12"/>
+          <p:cNvPr id="11" name="TextBox 10"/>
           <p:cNvSpPr txBox="1"/>
           <p:nvPr/>
         </p:nvSpPr>
@@ -17437,7 +17393,7 @@
             <a:r>
               <a:rPr sz="1200" b="0" i="0">
                 <a:solidFill>
-                  <a:srgbClr val="C6CDD1"/>
+                  <a:srgbClr val="6B7A83"/>
                 </a:solidFill>
                 <a:latin typeface="Segoe UI"/>
               </a:rPr>
@@ -17446,22 +17402,12 @@
           </a:p>
         </p:txBody>
       </p:sp>
-      <p:pic>
-        <p:nvPicPr>
-          <p:cNvPr id="14" name="!! Card 3" descr="Decorative glass panel"/>
-          <p:cNvPicPr>
-            <a:picLocks noChangeAspect="1"/>
-          </p:cNvPicPr>
+      <p:sp>
+        <p:nvSpPr>
+          <p:cNvPr id="12" name="!! Card 3"/>
+          <p:cNvSpPr/>
           <p:nvPr/>
-        </p:nvPicPr>
-        <p:blipFill>
-          <a:blip r:embed="rId4">
-            <a:alphaModFix amt="50000"/>
-          </a:blip>
-          <a:stretch>
-            <a:fillRect/>
-          </a:stretch>
-        </p:blipFill>
+        </p:nvSpPr>
         <p:spPr>
           <a:xfrm>
             <a:off x="8247888" y="1691640"/>
@@ -17470,27 +17416,15 @@
           <a:prstGeom prst="rect">
             <a:avLst/>
           </a:prstGeom>
-        </p:spPr>
-      </p:pic>
-      <p:sp>
-        <p:nvSpPr>
-          <p:cNvPr id="15" name="!! Card 3 rim"/>
-          <p:cNvSpPr/>
-          <p:nvPr/>
-        </p:nvSpPr>
-        <p:spPr>
-          <a:xfrm>
-            <a:off x="8247888" y="1691640"/>
-            <a:ext cx="3703320" cy="3063240"/>
-          </a:xfrm>
-          <a:prstGeom prst="rect">
-            <a:avLst/>
-          </a:prstGeom>
-          <a:noFill/>
+          <a:solidFill>
+            <a:srgbClr val="051C2C">
+              <a:alpha val="4000"/>
+            </a:srgbClr>
+          </a:solidFill>
           <a:ln w="9525">
             <a:solidFill>
-              <a:srgbClr val="FFFFFF">
-                <a:alpha val="16000"/>
+              <a:srgbClr val="051C2C">
+                <a:alpha val="12000"/>
               </a:srgbClr>
             </a:solidFill>
           </a:ln>
@@ -17505,7 +17439,7 @@
       </p:sp>
       <p:sp>
         <p:nvSpPr>
-          <p:cNvPr id="16" name="TextBox 15"/>
+          <p:cNvPr id="13" name="TextBox 12"/>
           <p:cNvSpPr txBox="1"/>
           <p:nvPr/>
         </p:nvSpPr>
@@ -17536,7 +17470,7 @@
             <a:r>
               <a:rPr sz="3000" b="1" i="0">
                 <a:solidFill>
-                  <a:srgbClr val="D5FB00"/>
+                  <a:srgbClr val="0033A0"/>
                 </a:solidFill>
                 <a:latin typeface="Segoe UI"/>
               </a:rPr>
@@ -17547,7 +17481,7 @@
       </p:sp>
       <p:sp>
         <p:nvSpPr>
-          <p:cNvPr id="17" name="TextBox 16"/>
+          <p:cNvPr id="14" name="TextBox 13"/>
           <p:cNvSpPr txBox="1"/>
           <p:nvPr/>
         </p:nvSpPr>
@@ -17578,7 +17512,7 @@
             <a:r>
               <a:rPr sz="1600" b="1" i="0">
                 <a:solidFill>
-                  <a:srgbClr val="FFFFFF"/>
+                  <a:srgbClr val="051C2C"/>
                 </a:solidFill>
                 <a:latin typeface="Segoe UI"/>
               </a:rPr>
@@ -17589,7 +17523,7 @@
       </p:sp>
       <p:sp>
         <p:nvSpPr>
-          <p:cNvPr id="18" name="TextBox 17"/>
+          <p:cNvPr id="15" name="TextBox 14"/>
           <p:cNvSpPr txBox="1"/>
           <p:nvPr/>
         </p:nvSpPr>
@@ -17623,7 +17557,7 @@
             <a:r>
               <a:rPr sz="1200" b="0" i="0">
                 <a:solidFill>
-                  <a:srgbClr val="C6CDD1"/>
+                  <a:srgbClr val="6B7A83"/>
                 </a:solidFill>
                 <a:latin typeface="Segoe UI"/>
               </a:rPr>
@@ -17632,22 +17566,12 @@
           </a:p>
         </p:txBody>
       </p:sp>
-      <p:pic>
-        <p:nvPicPr>
-          <p:cNvPr id="19" name="!! Strip" descr="Decorative glass panel"/>
-          <p:cNvPicPr>
-            <a:picLocks noChangeAspect="1"/>
-          </p:cNvPicPr>
+      <p:sp>
+        <p:nvSpPr>
+          <p:cNvPr id="16" name="!! Strip"/>
+          <p:cNvSpPr/>
           <p:nvPr/>
-        </p:nvPicPr>
-        <p:blipFill>
-          <a:blip r:embed="rId5">
-            <a:alphaModFix amt="50000"/>
-          </a:blip>
-          <a:stretch>
-            <a:fillRect/>
-          </a:stretch>
-        </p:blipFill>
+        </p:nvSpPr>
         <p:spPr>
           <a:xfrm>
             <a:off x="256032" y="4956048"/>
@@ -17656,27 +17580,15 @@
           <a:prstGeom prst="rect">
             <a:avLst/>
           </a:prstGeom>
-        </p:spPr>
-      </p:pic>
-      <p:sp>
-        <p:nvSpPr>
-          <p:cNvPr id="20" name="!! Strip rim"/>
-          <p:cNvSpPr/>
-          <p:nvPr/>
-        </p:nvSpPr>
-        <p:spPr>
-          <a:xfrm>
-            <a:off x="256032" y="4956048"/>
-            <a:ext cx="11676888" cy="566928"/>
-          </a:xfrm>
-          <a:prstGeom prst="rect">
-            <a:avLst/>
-          </a:prstGeom>
-          <a:noFill/>
+          <a:solidFill>
+            <a:srgbClr val="051C2C">
+              <a:alpha val="4000"/>
+            </a:srgbClr>
+          </a:solidFill>
           <a:ln w="9525">
             <a:solidFill>
-              <a:srgbClr val="FFFFFF">
-                <a:alpha val="16000"/>
+              <a:srgbClr val="051C2C">
+                <a:alpha val="12000"/>
               </a:srgbClr>
             </a:solidFill>
           </a:ln>
@@ -17691,7 +17603,7 @@
       </p:sp>
       <p:sp>
         <p:nvSpPr>
-          <p:cNvPr id="21" name="TextBox 20"/>
+          <p:cNvPr id="17" name="TextBox 16"/>
           <p:cNvSpPr txBox="1"/>
           <p:nvPr/>
         </p:nvSpPr>
@@ -17722,7 +17634,7 @@
             <a:r>
               <a:rPr sz="1100" b="1" i="0">
                 <a:solidFill>
-                  <a:srgbClr val="D5FB00"/>
+                  <a:srgbClr val="0033A0"/>
                 </a:solidFill>
                 <a:latin typeface="Segoe UI"/>
               </a:rPr>
@@ -17733,7 +17645,7 @@
       </p:sp>
       <p:sp>
         <p:nvSpPr>
-          <p:cNvPr id="22" name="TextBox 21"/>
+          <p:cNvPr id="18" name="TextBox 17"/>
           <p:cNvSpPr txBox="1"/>
           <p:nvPr/>
         </p:nvSpPr>
@@ -17764,7 +17676,7 @@
             <a:r>
               <a:rPr sz="1200" b="0" i="0">
                 <a:solidFill>
-                  <a:srgbClr val="FFFFFF"/>
+                  <a:srgbClr val="051C2C"/>
                 </a:solidFill>
                 <a:latin typeface="Segoe UI"/>
               </a:rPr>
@@ -18756,7 +18668,7 @@
             <a:r>
               <a:rPr sz="2800" b="1">
                 <a:solidFill>
-                  <a:srgbClr val="FFFFFF"/>
+                  <a:srgbClr val="051C2C"/>
                 </a:solidFill>
                 <a:latin typeface="Segoe UI"/>
               </a:rPr>
@@ -18783,7 +18695,7 @@
             <a:r>
               <a:rPr sz="1300" b="0">
                 <a:solidFill>
-                  <a:srgbClr val="D5FB00"/>
+                  <a:srgbClr val="0033A0"/>
                 </a:solidFill>
                 <a:latin typeface="Segoe UI"/>
               </a:rPr>
@@ -18792,22 +18704,12 @@
           </a:p>
         </p:txBody>
       </p:sp>
-      <p:pic>
-        <p:nvPicPr>
-          <p:cNvPr id="4" name="!! Glass A" descr="Decorative glass panel"/>
-          <p:cNvPicPr>
-            <a:picLocks noChangeAspect="1"/>
-          </p:cNvPicPr>
+      <p:sp>
+        <p:nvSpPr>
+          <p:cNvPr id="4" name="!! Glass A"/>
+          <p:cNvSpPr/>
           <p:nvPr/>
-        </p:nvPicPr>
-        <p:blipFill>
-          <a:blip r:embed="rId2">
-            <a:alphaModFix amt="50000"/>
-          </a:blip>
-          <a:stretch>
-            <a:fillRect/>
-          </a:stretch>
-        </p:blipFill>
+        </p:nvSpPr>
         <p:spPr>
           <a:xfrm>
             <a:off x="256032" y="1600200"/>
@@ -18816,27 +18718,15 @@
           <a:prstGeom prst="rect">
             <a:avLst/>
           </a:prstGeom>
-        </p:spPr>
-      </p:pic>
-      <p:sp>
-        <p:nvSpPr>
-          <p:cNvPr id="5" name="!! Glass A rim"/>
-          <p:cNvSpPr/>
-          <p:nvPr/>
-        </p:nvSpPr>
-        <p:spPr>
-          <a:xfrm>
-            <a:off x="256032" y="1600200"/>
-            <a:ext cx="5806440" cy="3703320"/>
-          </a:xfrm>
-          <a:prstGeom prst="rect">
-            <a:avLst/>
-          </a:prstGeom>
-          <a:noFill/>
+          <a:solidFill>
+            <a:srgbClr val="051C2C">
+              <a:alpha val="4000"/>
+            </a:srgbClr>
+          </a:solidFill>
           <a:ln w="9525">
             <a:solidFill>
-              <a:srgbClr val="FFFFFF">
-                <a:alpha val="16000"/>
+              <a:srgbClr val="051C2C">
+                <a:alpha val="12000"/>
               </a:srgbClr>
             </a:solidFill>
           </a:ln>
@@ -18851,7 +18741,7 @@
       </p:sp>
       <p:sp>
         <p:nvSpPr>
-          <p:cNvPr id="6" name="TextBox 5"/>
+          <p:cNvPr id="5" name="TextBox 4"/>
           <p:cNvSpPr txBox="1"/>
           <p:nvPr/>
         </p:nvSpPr>
@@ -18882,7 +18772,7 @@
             <a:r>
               <a:rPr sz="1600" b="1" i="0">
                 <a:solidFill>
-                  <a:srgbClr val="D5FB00"/>
+                  <a:srgbClr val="0033A0"/>
                 </a:solidFill>
                 <a:latin typeface="Segoe UI"/>
               </a:rPr>
@@ -18891,22 +18781,12 @@
           </a:p>
         </p:txBody>
       </p:sp>
-      <p:pic>
-        <p:nvPicPr>
-          <p:cNvPr id="7" name="!! Glass B" descr="Decorative glass panel"/>
-          <p:cNvPicPr>
-            <a:picLocks noChangeAspect="1"/>
-          </p:cNvPicPr>
+      <p:sp>
+        <p:nvSpPr>
+          <p:cNvPr id="6" name="!! Glass B"/>
+          <p:cNvSpPr/>
           <p:nvPr/>
-        </p:nvPicPr>
-        <p:blipFill>
-          <a:blip r:embed="rId3">
-            <a:alphaModFix amt="50000"/>
-          </a:blip>
-          <a:stretch>
-            <a:fillRect/>
-          </a:stretch>
-        </p:blipFill>
+        </p:nvSpPr>
         <p:spPr>
           <a:xfrm>
             <a:off x="6382512" y="1600200"/>
@@ -18915,27 +18795,15 @@
           <a:prstGeom prst="rect">
             <a:avLst/>
           </a:prstGeom>
-        </p:spPr>
-      </p:pic>
-      <p:sp>
-        <p:nvSpPr>
-          <p:cNvPr id="8" name="!! Glass B rim"/>
-          <p:cNvSpPr/>
-          <p:nvPr/>
-        </p:nvSpPr>
-        <p:spPr>
-          <a:xfrm>
-            <a:off x="6382512" y="1600200"/>
-            <a:ext cx="5550408" cy="3703320"/>
-          </a:xfrm>
-          <a:prstGeom prst="rect">
-            <a:avLst/>
-          </a:prstGeom>
-          <a:noFill/>
+          <a:solidFill>
+            <a:srgbClr val="051C2C">
+              <a:alpha val="4000"/>
+            </a:srgbClr>
+          </a:solidFill>
           <a:ln w="9525">
             <a:solidFill>
-              <a:srgbClr val="FFFFFF">
-                <a:alpha val="16000"/>
+              <a:srgbClr val="051C2C">
+                <a:alpha val="12000"/>
               </a:srgbClr>
             </a:solidFill>
           </a:ln>
@@ -18950,14 +18818,98 @@
       </p:sp>
       <p:sp>
         <p:nvSpPr>
+          <p:cNvPr id="7" name="TextBox 6"/>
+          <p:cNvSpPr txBox="1"/>
+          <p:nvPr/>
+        </p:nvSpPr>
+        <p:spPr>
+          <a:xfrm>
+            <a:off x="6748272" y="1901952"/>
+            <a:ext cx="5486400" cy="274320"/>
+          </a:xfrm>
+          <a:prstGeom prst="rect">
+            <a:avLst/>
+          </a:prstGeom>
+          <a:noFill/>
+        </p:spPr>
+        <p:txBody>
+          <a:bodyPr wrap="square" lIns="0" rIns="0" tIns="0" bIns="0" anchor="t">
+            <a:spAutoFit/>
+          </a:bodyPr>
+          <a:lstStyle/>
+          <a:p>
+            <a:pPr algn="l">
+              <a:spcBef>
+                <a:spcPts val="0"/>
+              </a:spcBef>
+              <a:spcAft>
+                <a:spcPts val="0"/>
+              </a:spcAft>
+            </a:pPr>
+            <a:r>
+              <a:rPr sz="1600" b="1" i="0">
+                <a:solidFill>
+                  <a:srgbClr val="0033A0"/>
+                </a:solidFill>
+                <a:latin typeface="Segoe UI"/>
+              </a:rPr>
+              <a:t>NEXT</a:t>
+            </a:r>
+          </a:p>
+        </p:txBody>
+      </p:sp>
+      <p:sp>
+        <p:nvSpPr>
+          <p:cNvPr id="8" name="TextBox 7"/>
+          <p:cNvSpPr txBox="1"/>
+          <p:nvPr/>
+        </p:nvSpPr>
+        <p:spPr>
+          <a:xfrm>
+            <a:off x="621792" y="2395728"/>
+            <a:ext cx="5074920" cy="731520"/>
+          </a:xfrm>
+          <a:prstGeom prst="rect">
+            <a:avLst/>
+          </a:prstGeom>
+          <a:noFill/>
+        </p:spPr>
+        <p:txBody>
+          <a:bodyPr wrap="square" lIns="0" rIns="0" tIns="0" bIns="0" anchor="t">
+            <a:spAutoFit/>
+          </a:bodyPr>
+          <a:lstStyle/>
+          <a:p>
+            <a:pPr algn="l">
+              <a:spcBef>
+                <a:spcPts val="0"/>
+              </a:spcBef>
+              <a:spcAft>
+                <a:spcPts val="0"/>
+              </a:spcAft>
+            </a:pPr>
+            <a:r>
+              <a:rPr sz="1400" b="0" i="0">
+                <a:solidFill>
+                  <a:srgbClr val="051C2C"/>
+                </a:solidFill>
+                <a:latin typeface="Segoe UI"/>
+              </a:rPr>
+              <a:t>Level I studied in full, and four skills done on my own.</a:t>
+            </a:r>
+          </a:p>
+        </p:txBody>
+      </p:sp>
+      <p:sp>
+        <p:nvSpPr>
           <p:cNvPr id="9" name="TextBox 8"/>
           <p:cNvSpPr txBox="1"/>
           <p:nvPr/>
         </p:nvSpPr>
         <p:spPr>
           <a:xfrm>
-            <a:off x="6748272" y="1901952"/>
-            <a:ext cx="5486400" cy="274320"/>
+            <a:off x="621792" y="3310128"/>
+            <a:ext cx="5074920" cy="731520"/>
           </a:xfrm>
           <a:prstGeom prst="rect">
             <a:avLst/>
@@ -18979,13 +18931,13 @@
               </a:spcAft>
             </a:pPr>
             <a:r>
-              <a:rPr sz="1600" b="1" i="0">
-                <a:solidFill>
-                  <a:srgbClr val="D5FB00"/>
+              <a:rPr sz="1400" b="0" i="0">
+                <a:solidFill>
+                  <a:srgbClr val="051C2C"/>
                 </a:solidFill>
                 <a:latin typeface="Segoe UI"/>
               </a:rPr>
-              <a:t>NEXT</a:t>
+              <a:t>A manual weld moved to the 4M robotic cell: 47% less cycle time, less strain.</a:t>
             </a:r>
           </a:p>
         </p:txBody>
@@ -18998,7 +18950,7 @@
         </p:nvSpPr>
         <p:spPr>
           <a:xfrm>
-            <a:off x="621792" y="2395728"/>
+            <a:off x="621792" y="4224528"/>
             <a:ext cx="5074920" cy="731520"/>
           </a:xfrm>
           <a:prstGeom prst="rect">
@@ -19023,11 +18975,11 @@
             <a:r>
               <a:rPr sz="1400" b="0" i="0">
                 <a:solidFill>
-                  <a:srgbClr val="FFFFFF"/>
+                  <a:srgbClr val="051C2C"/>
                 </a:solidFill>
                 <a:latin typeface="Segoe UI"/>
               </a:rPr>
-              <a:t>Level I studied in full, and four skills done on my own.</a:t>
+              <a:t>A reviewed study path, and a schedule that shows plan versus reality.</a:t>
             </a:r>
           </a:p>
         </p:txBody>
@@ -19040,8 +18992,8 @@
         </p:nvSpPr>
         <p:spPr>
           <a:xfrm>
-            <a:off x="621792" y="3310128"/>
-            <a:ext cx="5074920" cy="731520"/>
+            <a:off x="6748272" y="2395728"/>
+            <a:ext cx="4818888" cy="731520"/>
           </a:xfrm>
           <a:prstGeom prst="rect">
             <a:avLst/>
@@ -19065,11 +19017,11 @@
             <a:r>
               <a:rPr sz="1400" b="0" i="0">
                 <a:solidFill>
-                  <a:srgbClr val="FFFFFF"/>
+                  <a:srgbClr val="051C2C"/>
                 </a:solidFill>
                 <a:latin typeface="Segoe UI"/>
               </a:rPr>
-              <a:t>A manual weld moved to the 4M robotic cell: 47% less cycle time, less strain.</a:t>
+              <a:t>Pass the Level I exam in October.</a:t>
             </a:r>
           </a:p>
         </p:txBody>
@@ -19082,8 +19034,8 @@
         </p:nvSpPr>
         <p:spPr>
           <a:xfrm>
-            <a:off x="621792" y="4224528"/>
-            <a:ext cx="5074920" cy="731520"/>
+            <a:off x="6748272" y="3310128"/>
+            <a:ext cx="4818888" cy="731520"/>
           </a:xfrm>
           <a:prstGeom prst="rect">
             <a:avLst/>
@@ -19107,11 +19059,11 @@
             <a:r>
               <a:rPr sz="1400" b="0" i="0">
                 <a:solidFill>
-                  <a:srgbClr val="FFFFFF"/>
+                  <a:srgbClr val="051C2C"/>
                 </a:solidFill>
                 <a:latin typeface="Segoe UI"/>
               </a:rPr>
-              <a:t>A reviewed study path, and a schedule that shows plan versus reality.</a:t>
+              <a:t>Reach Levels L and U before January.</a:t>
             </a:r>
           </a:p>
         </p:txBody>
@@ -19124,7 +19076,7 @@
         </p:nvSpPr>
         <p:spPr>
           <a:xfrm>
-            <a:off x="6748272" y="2395728"/>
+            <a:off x="6748272" y="4224528"/>
             <a:ext cx="4818888" cy="731520"/>
           </a:xfrm>
           <a:prstGeom prst="rect">
@@ -19149,11 +19101,11 @@
             <a:r>
               <a:rPr sz="1400" b="0" i="0">
                 <a:solidFill>
-                  <a:srgbClr val="FFFFFF"/>
+                  <a:srgbClr val="051C2C"/>
                 </a:solidFill>
                 <a:latin typeface="Segoe UI"/>
               </a:rPr>
-              <a:t>Pass the Level I exam in October.</a:t>
+              <a:t>Keep measuring 4M, and find the next weld to automate.</a:t>
             </a:r>
           </a:p>
         </p:txBody>
@@ -19166,8 +19118,8 @@
         </p:nvSpPr>
         <p:spPr>
           <a:xfrm>
-            <a:off x="6748272" y="3310128"/>
-            <a:ext cx="4818888" cy="731520"/>
+            <a:off x="621792" y="5715000"/>
+            <a:ext cx="8778240" cy="365760"/>
           </a:xfrm>
           <a:prstGeom prst="rect">
             <a:avLst/>
@@ -19189,93 +19141,9 @@
               </a:spcAft>
             </a:pPr>
             <a:r>
-              <a:rPr sz="1400" b="0" i="0">
-                <a:solidFill>
-                  <a:srgbClr val="FFFFFF"/>
-                </a:solidFill>
-                <a:latin typeface="Segoe UI"/>
-              </a:rPr>
-              <a:t>Reach Levels L and U before January.</a:t>
-            </a:r>
-          </a:p>
-        </p:txBody>
-      </p:sp>
-      <p:sp>
-        <p:nvSpPr>
-          <p:cNvPr id="15" name="TextBox 14"/>
-          <p:cNvSpPr txBox="1"/>
-          <p:nvPr/>
-        </p:nvSpPr>
-        <p:spPr>
-          <a:xfrm>
-            <a:off x="6748272" y="4224528"/>
-            <a:ext cx="4818888" cy="731520"/>
-          </a:xfrm>
-          <a:prstGeom prst="rect">
-            <a:avLst/>
-          </a:prstGeom>
-          <a:noFill/>
-        </p:spPr>
-        <p:txBody>
-          <a:bodyPr wrap="square" lIns="0" rIns="0" tIns="0" bIns="0" anchor="t">
-            <a:spAutoFit/>
-          </a:bodyPr>
-          <a:lstStyle/>
-          <a:p>
-            <a:pPr algn="l">
-              <a:spcBef>
-                <a:spcPts val="0"/>
-              </a:spcBef>
-              <a:spcAft>
-                <a:spcPts val="0"/>
-              </a:spcAft>
-            </a:pPr>
-            <a:r>
-              <a:rPr sz="1400" b="0" i="0">
-                <a:solidFill>
-                  <a:srgbClr val="FFFFFF"/>
-                </a:solidFill>
-                <a:latin typeface="Segoe UI"/>
-              </a:rPr>
-              <a:t>Keep measuring 4M, and find the next weld to automate.</a:t>
-            </a:r>
-          </a:p>
-        </p:txBody>
-      </p:sp>
-      <p:sp>
-        <p:nvSpPr>
-          <p:cNvPr id="16" name="TextBox 15"/>
-          <p:cNvSpPr txBox="1"/>
-          <p:nvPr/>
-        </p:nvSpPr>
-        <p:spPr>
-          <a:xfrm>
-            <a:off x="3108960" y="5715000"/>
-            <a:ext cx="8778240" cy="365760"/>
-          </a:xfrm>
-          <a:prstGeom prst="rect">
-            <a:avLst/>
-          </a:prstGeom>
-          <a:noFill/>
-        </p:spPr>
-        <p:txBody>
-          <a:bodyPr wrap="square" lIns="0" rIns="0" tIns="0" bIns="0" anchor="t">
-            <a:spAutoFit/>
-          </a:bodyPr>
-          <a:lstStyle/>
-          <a:p>
-            <a:pPr algn="l">
-              <a:spcBef>
-                <a:spcPts val="0"/>
-              </a:spcBef>
-              <a:spcAft>
-                <a:spcPts val="0"/>
-              </a:spcAft>
-            </a:pPr>
-            <a:r>
               <a:rPr sz="1500" b="1" i="0">
                 <a:solidFill>
-                  <a:srgbClr val="D5FB00"/>
+                  <a:srgbClr val="0033A0"/>
                 </a:solidFill>
                 <a:latin typeface="Segoe UI"/>
               </a:rPr>
@@ -19707,7 +19575,7 @@
             <a:r>
               <a:rPr sz="2800" b="1">
                 <a:solidFill>
-                  <a:srgbClr val="FFFFFF"/>
+                  <a:srgbClr val="051C2C"/>
                 </a:solidFill>
                 <a:latin typeface="Segoe UI"/>
               </a:rPr>
@@ -19734,7 +19602,7 @@
             <a:r>
               <a:rPr sz="1300" b="0">
                 <a:solidFill>
-                  <a:srgbClr val="D5FB00"/>
+                  <a:srgbClr val="0033A0"/>
                 </a:solidFill>
                 <a:latin typeface="Segoe UI"/>
               </a:rPr>
@@ -19743,22 +19611,12 @@
           </a:p>
         </p:txBody>
       </p:sp>
-      <p:pic>
-        <p:nvPicPr>
-          <p:cNvPr id="4" name="!! Glass A" descr="Decorative glass panel"/>
-          <p:cNvPicPr>
-            <a:picLocks noChangeAspect="1"/>
-          </p:cNvPicPr>
+      <p:sp>
+        <p:nvSpPr>
+          <p:cNvPr id="4" name="!! Glass A"/>
+          <p:cNvSpPr/>
           <p:nvPr/>
-        </p:nvPicPr>
-        <p:blipFill>
-          <a:blip r:embed="rId2">
-            <a:alphaModFix amt="50000"/>
-          </a:blip>
-          <a:stretch>
-            <a:fillRect/>
-          </a:stretch>
-        </p:blipFill>
+        </p:nvSpPr>
         <p:spPr>
           <a:xfrm>
             <a:off x="256032" y="1600200"/>
@@ -19767,27 +19625,15 @@
           <a:prstGeom prst="rect">
             <a:avLst/>
           </a:prstGeom>
-        </p:spPr>
-      </p:pic>
-      <p:sp>
-        <p:nvSpPr>
-          <p:cNvPr id="5" name="!! Glass A rim"/>
-          <p:cNvSpPr/>
-          <p:nvPr/>
-        </p:nvSpPr>
-        <p:spPr>
-          <a:xfrm>
-            <a:off x="256032" y="1600200"/>
-            <a:ext cx="7223760" cy="3886200"/>
-          </a:xfrm>
-          <a:prstGeom prst="rect">
-            <a:avLst/>
-          </a:prstGeom>
-          <a:noFill/>
+          <a:solidFill>
+            <a:srgbClr val="051C2C">
+              <a:alpha val="4000"/>
+            </a:srgbClr>
+          </a:solidFill>
           <a:ln w="9525">
             <a:solidFill>
-              <a:srgbClr val="FFFFFF">
-                <a:alpha val="16000"/>
+              <a:srgbClr val="051C2C">
+                <a:alpha val="12000"/>
               </a:srgbClr>
             </a:solidFill>
           </a:ln>
@@ -19802,14 +19648,56 @@
       </p:sp>
       <p:sp>
         <p:nvSpPr>
+          <p:cNvPr id="5" name="TextBox 4"/>
+          <p:cNvSpPr txBox="1"/>
+          <p:nvPr/>
+        </p:nvSpPr>
+        <p:spPr>
+          <a:xfrm>
+            <a:off x="621792" y="1938528"/>
+            <a:ext cx="5486400" cy="274320"/>
+          </a:xfrm>
+          <a:prstGeom prst="rect">
+            <a:avLst/>
+          </a:prstGeom>
+          <a:noFill/>
+        </p:spPr>
+        <p:txBody>
+          <a:bodyPr wrap="square" lIns="0" rIns="0" tIns="0" bIns="0" anchor="t">
+            <a:spAutoFit/>
+          </a:bodyPr>
+          <a:lstStyle/>
+          <a:p>
+            <a:pPr algn="l">
+              <a:spcBef>
+                <a:spcPts val="0"/>
+              </a:spcBef>
+              <a:spcAft>
+                <a:spcPts val="0"/>
+              </a:spcAft>
+            </a:pPr>
+            <a:r>
+              <a:rPr sz="1600" b="1" i="0">
+                <a:solidFill>
+                  <a:srgbClr val="0033A0"/>
+                </a:solidFill>
+                <a:latin typeface="Segoe UI"/>
+              </a:rPr>
+              <a:t>OBJECTIVE</a:t>
+            </a:r>
+          </a:p>
+        </p:txBody>
+      </p:sp>
+      <p:sp>
+        <p:nvSpPr>
           <p:cNvPr id="6" name="TextBox 5"/>
           <p:cNvSpPr txBox="1"/>
           <p:nvPr/>
         </p:nvSpPr>
         <p:spPr>
           <a:xfrm>
-            <a:off x="621792" y="1938528"/>
-            <a:ext cx="5486400" cy="274320"/>
+            <a:off x="621792" y="2331720"/>
+            <a:ext cx="6492240" cy="822960"/>
           </a:xfrm>
           <a:prstGeom prst="rect">
             <a:avLst/>
@@ -19831,51 +19719,9 @@
               </a:spcAft>
             </a:pPr>
             <a:r>
-              <a:rPr sz="1600" b="1" i="0">
-                <a:solidFill>
-                  <a:srgbClr val="D5FB00"/>
-                </a:solidFill>
-                <a:latin typeface="Segoe UI"/>
-              </a:rPr>
-              <a:t>OBJECTIVE</a:t>
-            </a:r>
-          </a:p>
-        </p:txBody>
-      </p:sp>
-      <p:sp>
-        <p:nvSpPr>
-          <p:cNvPr id="7" name="TextBox 6"/>
-          <p:cNvSpPr txBox="1"/>
-          <p:nvPr/>
-        </p:nvSpPr>
-        <p:spPr>
-          <a:xfrm>
-            <a:off x="621792" y="2331720"/>
-            <a:ext cx="6492240" cy="822960"/>
-          </a:xfrm>
-          <a:prstGeom prst="rect">
-            <a:avLst/>
-          </a:prstGeom>
-          <a:noFill/>
-        </p:spPr>
-        <p:txBody>
-          <a:bodyPr wrap="square" lIns="0" rIns="0" tIns="0" bIns="0" anchor="t">
-            <a:spAutoFit/>
-          </a:bodyPr>
-          <a:lstStyle/>
-          <a:p>
-            <a:pPr algn="l">
-              <a:spcBef>
-                <a:spcPts val="0"/>
-              </a:spcBef>
-              <a:spcAft>
-                <a:spcPts val="0"/>
-              </a:spcAft>
-            </a:pPr>
-            <a:r>
               <a:rPr sz="1700" b="0" i="0">
                 <a:solidFill>
-                  <a:srgbClr val="FFFFFF"/>
+                  <a:srgbClr val="051C2C"/>
                 </a:solidFill>
                 <a:latin typeface="Segoe UI"/>
               </a:rPr>
@@ -19886,7 +19732,7 @@
       </p:sp>
       <p:sp>
         <p:nvSpPr>
-          <p:cNvPr id="8" name="Rectangle 7"/>
+          <p:cNvPr id="7" name="Rectangle 6"/>
           <p:cNvSpPr/>
           <p:nvPr/>
         </p:nvSpPr>
@@ -19899,7 +19745,7 @@
             <a:avLst/>
           </a:prstGeom>
           <a:solidFill>
-            <a:srgbClr val="D5FB00"/>
+            <a:srgbClr val="0033A0"/>
           </a:solidFill>
           <a:ln>
             <a:noFill/>
@@ -19915,7 +19761,7 @@
       </p:sp>
       <p:sp>
         <p:nvSpPr>
-          <p:cNvPr id="9" name="TextBox 8"/>
+          <p:cNvPr id="8" name="TextBox 7"/>
           <p:cNvSpPr txBox="1"/>
           <p:nvPr/>
         </p:nvSpPr>
@@ -19946,7 +19792,7 @@
             <a:r>
               <a:rPr sz="1600" b="1" i="0">
                 <a:solidFill>
-                  <a:srgbClr val="D5FB00"/>
+                  <a:srgbClr val="0033A0"/>
                 </a:solidFill>
                 <a:latin typeface="Segoe UI"/>
               </a:rPr>
@@ -19957,7 +19803,7 @@
       </p:sp>
       <p:sp>
         <p:nvSpPr>
-          <p:cNvPr id="10" name="TextBox 9"/>
+          <p:cNvPr id="9" name="TextBox 8"/>
           <p:cNvSpPr txBox="1"/>
           <p:nvPr/>
         </p:nvSpPr>
@@ -19991,7 +19837,7 @@
             <a:r>
               <a:rPr sz="1400" b="0" i="0">
                 <a:solidFill>
-                  <a:srgbClr val="C6CDD1"/>
+                  <a:srgbClr val="6B7A83"/>
                 </a:solidFill>
                 <a:latin typeface="Segoe UI"/>
               </a:rPr>
@@ -20000,22 +19846,12 @@
           </a:p>
         </p:txBody>
       </p:sp>
-      <p:pic>
-        <p:nvPicPr>
-          <p:cNvPr id="11" name="!! Glass B" descr="Decorative glass panel"/>
-          <p:cNvPicPr>
-            <a:picLocks noChangeAspect="1"/>
-          </p:cNvPicPr>
+      <p:sp>
+        <p:nvSpPr>
+          <p:cNvPr id="10" name="!! Glass B"/>
+          <p:cNvSpPr/>
           <p:nvPr/>
-        </p:nvPicPr>
-        <p:blipFill>
-          <a:blip r:embed="rId3">
-            <a:alphaModFix amt="50000"/>
-          </a:blip>
-          <a:stretch>
-            <a:fillRect/>
-          </a:stretch>
-        </p:blipFill>
+        </p:nvSpPr>
         <p:spPr>
           <a:xfrm>
             <a:off x="7818120" y="1600200"/>
@@ -20024,27 +19860,15 @@
           <a:prstGeom prst="rect">
             <a:avLst/>
           </a:prstGeom>
-        </p:spPr>
-      </p:pic>
-      <p:sp>
-        <p:nvSpPr>
-          <p:cNvPr id="12" name="!! Glass B rim"/>
-          <p:cNvSpPr/>
-          <p:nvPr/>
-        </p:nvSpPr>
-        <p:spPr>
-          <a:xfrm>
-            <a:off x="7818120" y="1600200"/>
-            <a:ext cx="4114800" cy="3886200"/>
-          </a:xfrm>
-          <a:prstGeom prst="rect">
-            <a:avLst/>
-          </a:prstGeom>
-          <a:noFill/>
+          <a:solidFill>
+            <a:srgbClr val="051C2C">
+              <a:alpha val="4000"/>
+            </a:srgbClr>
+          </a:solidFill>
           <a:ln w="9525">
             <a:solidFill>
-              <a:srgbClr val="FFFFFF">
-                <a:alpha val="16000"/>
+              <a:srgbClr val="051C2C">
+                <a:alpha val="12000"/>
               </a:srgbClr>
             </a:solidFill>
           </a:ln>
@@ -20059,7 +19883,7 @@
       </p:sp>
       <p:sp>
         <p:nvSpPr>
-          <p:cNvPr id="13" name="TextBox 12"/>
+          <p:cNvPr id="11" name="TextBox 10"/>
           <p:cNvSpPr txBox="1"/>
           <p:nvPr/>
         </p:nvSpPr>
@@ -20090,7 +19914,7 @@
             <a:r>
               <a:rPr sz="1600" b="1" i="0">
                 <a:solidFill>
-                  <a:srgbClr val="D5FB00"/>
+                  <a:srgbClr val="0033A0"/>
                 </a:solidFill>
                 <a:latin typeface="Segoe UI"/>
               </a:rPr>
@@ -20101,7 +19925,7 @@
       </p:sp>
       <p:sp>
         <p:nvSpPr>
-          <p:cNvPr id="14" name="TextBox 13"/>
+          <p:cNvPr id="12" name="TextBox 11"/>
           <p:cNvSpPr txBox="1"/>
           <p:nvPr/>
         </p:nvSpPr>
@@ -20132,7 +19956,7 @@
             <a:r>
               <a:rPr sz="1400" b="1" i="0">
                 <a:solidFill>
-                  <a:srgbClr val="FFFFFF"/>
+                  <a:srgbClr val="051C2C"/>
                 </a:solidFill>
                 <a:latin typeface="Segoe UI"/>
               </a:rPr>
@@ -20151,7 +19975,7 @@
             <a:r>
               <a:rPr sz="1200" b="0" i="0">
                 <a:solidFill>
-                  <a:srgbClr val="C6CDD1"/>
+                  <a:srgbClr val="6B7A83"/>
                 </a:solidFill>
                 <a:latin typeface="Segoe UI"/>
               </a:rPr>
@@ -20170,7 +19994,7 @@
             <a:r>
               <a:rPr sz="1200" b="0" i="0">
                 <a:solidFill>
-                  <a:srgbClr val="D5FB00"/>
+                  <a:srgbClr val="0033A0"/>
                 </a:solidFill>
                 <a:latin typeface="Segoe UI"/>
               </a:rPr>
@@ -20189,7 +20013,7 @@
             <a:r>
               <a:rPr sz="1400" b="1" i="0">
                 <a:solidFill>
-                  <a:srgbClr val="FFFFFF"/>
+                  <a:srgbClr val="051C2C"/>
                 </a:solidFill>
                 <a:latin typeface="Segoe UI"/>
               </a:rPr>
@@ -20208,7 +20032,7 @@
             <a:r>
               <a:rPr sz="1200" b="0" i="0">
                 <a:solidFill>
-                  <a:srgbClr val="C6CDD1"/>
+                  <a:srgbClr val="6B7A83"/>
                 </a:solidFill>
                 <a:latin typeface="Segoe UI"/>
               </a:rPr>
@@ -20227,7 +20051,7 @@
             <a:r>
               <a:rPr sz="1200" b="0" i="0">
                 <a:solidFill>
-                  <a:srgbClr val="D5FB00"/>
+                  <a:srgbClr val="0033A0"/>
                 </a:solidFill>
                 <a:latin typeface="Segoe UI"/>
               </a:rPr>
@@ -21253,7 +21077,7 @@
             <a:r>
               <a:rPr sz="2800" b="1">
                 <a:solidFill>
-                  <a:srgbClr val="FFFFFF"/>
+                  <a:srgbClr val="051C2C"/>
                 </a:solidFill>
                 <a:latin typeface="Segoe UI"/>
               </a:rPr>
@@ -21280,7 +21104,7 @@
             <a:r>
               <a:rPr sz="1300" b="0">
                 <a:solidFill>
-                  <a:srgbClr val="D5FB00"/>
+                  <a:srgbClr val="0033A0"/>
                 </a:solidFill>
                 <a:latin typeface="Segoe UI"/>
               </a:rPr>
@@ -21289,22 +21113,12 @@
           </a:p>
         </p:txBody>
       </p:sp>
-      <p:pic>
-        <p:nvPicPr>
-          <p:cNvPr id="4" name="!! Glass A" descr="Decorative glass panel"/>
-          <p:cNvPicPr>
-            <a:picLocks noChangeAspect="1"/>
-          </p:cNvPicPr>
+      <p:sp>
+        <p:nvSpPr>
+          <p:cNvPr id="4" name="!! Glass A"/>
+          <p:cNvSpPr/>
           <p:nvPr/>
-        </p:nvPicPr>
-        <p:blipFill>
-          <a:blip r:embed="rId2">
-            <a:alphaModFix amt="50000"/>
-          </a:blip>
-          <a:stretch>
-            <a:fillRect/>
-          </a:stretch>
-        </p:blipFill>
+        </p:nvSpPr>
         <p:spPr>
           <a:xfrm>
             <a:off x="603504" y="2157984"/>
@@ -21313,27 +21127,15 @@
           <a:prstGeom prst="rect">
             <a:avLst/>
           </a:prstGeom>
-        </p:spPr>
-      </p:pic>
-      <p:sp>
-        <p:nvSpPr>
-          <p:cNvPr id="5" name="!! Glass A rim"/>
-          <p:cNvSpPr/>
-          <p:nvPr/>
-        </p:nvSpPr>
-        <p:spPr>
-          <a:xfrm>
-            <a:off x="603504" y="2157984"/>
-            <a:ext cx="11210544" cy="2542032"/>
-          </a:xfrm>
-          <a:prstGeom prst="rect">
-            <a:avLst/>
-          </a:prstGeom>
-          <a:noFill/>
+          <a:solidFill>
+            <a:srgbClr val="051C2C">
+              <a:alpha val="4000"/>
+            </a:srgbClr>
+          </a:solidFill>
           <a:ln w="9525">
             <a:solidFill>
-              <a:srgbClr val="FFFFFF">
-                <a:alpha val="16000"/>
+              <a:srgbClr val="051C2C">
+                <a:alpha val="12000"/>
               </a:srgbClr>
             </a:solidFill>
           </a:ln>
@@ -21348,7 +21150,7 @@
       </p:sp>
       <p:sp>
         <p:nvSpPr>
-          <p:cNvPr id="6" name="Rectangle 5"/>
+          <p:cNvPr id="5" name="Rectangle 4"/>
           <p:cNvSpPr/>
           <p:nvPr/>
         </p:nvSpPr>
@@ -21361,7 +21163,7 @@
             <a:avLst/>
           </a:prstGeom>
           <a:solidFill>
-            <a:srgbClr val="C6CDD1">
+            <a:srgbClr val="6B7A83">
               <a:alpha val="45000"/>
             </a:srgbClr>
           </a:solidFill>
@@ -21379,7 +21181,7 @@
       </p:sp>
       <p:sp>
         <p:nvSpPr>
-          <p:cNvPr id="7" name="Rectangle 6"/>
+          <p:cNvPr id="6" name="Rectangle 5"/>
           <p:cNvSpPr/>
           <p:nvPr/>
         </p:nvSpPr>
@@ -21392,7 +21194,7 @@
             <a:avLst/>
           </a:prstGeom>
           <a:solidFill>
-            <a:srgbClr val="D5FB00"/>
+            <a:srgbClr val="0033A0"/>
           </a:solidFill>
           <a:ln>
             <a:noFill/>
@@ -21408,7 +21210,7 @@
       </p:sp>
       <p:sp>
         <p:nvSpPr>
-          <p:cNvPr id="8" name="Oval 7"/>
+          <p:cNvPr id="7" name="Oval 6"/>
           <p:cNvSpPr/>
           <p:nvPr/>
         </p:nvSpPr>
@@ -21421,7 +21223,7 @@
             <a:avLst/>
           </a:prstGeom>
           <a:solidFill>
-            <a:srgbClr val="D5FB00"/>
+            <a:srgbClr val="0033A0"/>
           </a:solidFill>
           <a:ln>
             <a:noFill/>
@@ -21437,14 +21239,56 @@
       </p:sp>
       <p:sp>
         <p:nvSpPr>
+          <p:cNvPr id="8" name="TextBox 7"/>
+          <p:cNvSpPr txBox="1"/>
+          <p:nvPr/>
+        </p:nvSpPr>
+        <p:spPr>
+          <a:xfrm>
+            <a:off x="731520" y="2596896"/>
+            <a:ext cx="2103120" cy="411480"/>
+          </a:xfrm>
+          <a:prstGeom prst="rect">
+            <a:avLst/>
+          </a:prstGeom>
+          <a:noFill/>
+        </p:spPr>
+        <p:txBody>
+          <a:bodyPr wrap="square" lIns="0" rIns="0" tIns="0" bIns="0" anchor="t">
+            <a:spAutoFit/>
+          </a:bodyPr>
+          <a:lstStyle/>
+          <a:p>
+            <a:pPr algn="ctr">
+              <a:spcBef>
+                <a:spcPts val="0"/>
+              </a:spcBef>
+              <a:spcAft>
+                <a:spcPts val="0"/>
+              </a:spcAft>
+            </a:pPr>
+            <a:r>
+              <a:rPr sz="1900" b="1" i="0">
+                <a:solidFill>
+                  <a:srgbClr val="051C2C"/>
+                </a:solidFill>
+                <a:latin typeface="Segoe UI"/>
+              </a:rPr>
+              <a:t>Program start</a:t>
+            </a:r>
+          </a:p>
+        </p:txBody>
+      </p:sp>
+      <p:sp>
+        <p:nvSpPr>
           <p:cNvPr id="9" name="TextBox 8"/>
           <p:cNvSpPr txBox="1"/>
           <p:nvPr/>
         </p:nvSpPr>
         <p:spPr>
           <a:xfrm>
-            <a:off x="731520" y="2596896"/>
-            <a:ext cx="2103120" cy="411480"/>
+            <a:off x="731520" y="4087368"/>
+            <a:ext cx="2103120" cy="274320"/>
           </a:xfrm>
           <a:prstGeom prst="rect">
             <a:avLst/>
@@ -21466,51 +21310,9 @@
               </a:spcAft>
             </a:pPr>
             <a:r>
-              <a:rPr sz="1900" b="1" i="0">
-                <a:solidFill>
-                  <a:srgbClr val="FFFFFF"/>
-                </a:solidFill>
-                <a:latin typeface="Segoe UI"/>
-              </a:rPr>
-              <a:t>Program start</a:t>
-            </a:r>
-          </a:p>
-        </p:txBody>
-      </p:sp>
-      <p:sp>
-        <p:nvSpPr>
-          <p:cNvPr id="10" name="TextBox 9"/>
-          <p:cNvSpPr txBox="1"/>
-          <p:nvPr/>
-        </p:nvSpPr>
-        <p:spPr>
-          <a:xfrm>
-            <a:off x="731520" y="4087368"/>
-            <a:ext cx="2103120" cy="274320"/>
-          </a:xfrm>
-          <a:prstGeom prst="rect">
-            <a:avLst/>
-          </a:prstGeom>
-          <a:noFill/>
-        </p:spPr>
-        <p:txBody>
-          <a:bodyPr wrap="square" lIns="0" rIns="0" tIns="0" bIns="0" anchor="t">
-            <a:spAutoFit/>
-          </a:bodyPr>
-          <a:lstStyle/>
-          <a:p>
-            <a:pPr algn="ctr">
-              <a:spcBef>
-                <a:spcPts val="0"/>
-              </a:spcBef>
-              <a:spcAft>
-                <a:spcPts val="0"/>
-              </a:spcAft>
-            </a:pPr>
-            <a:r>
               <a:rPr sz="1400" b="0" i="0">
                 <a:solidFill>
-                  <a:srgbClr val="C6CDD1"/>
+                  <a:srgbClr val="6B7A83"/>
                 </a:solidFill>
                 <a:latin typeface="Segoe UI"/>
               </a:rPr>
@@ -21521,7 +21323,7 @@
       </p:sp>
       <p:sp>
         <p:nvSpPr>
-          <p:cNvPr id="11" name="Oval 10"/>
+          <p:cNvPr id="10" name="Oval 9"/>
           <p:cNvSpPr/>
           <p:nvPr/>
         </p:nvSpPr>
@@ -21534,7 +21336,7 @@
             <a:avLst/>
           </a:prstGeom>
           <a:solidFill>
-            <a:srgbClr val="D5FB00"/>
+            <a:srgbClr val="0033A0"/>
           </a:solidFill>
           <a:ln>
             <a:noFill/>
@@ -21550,14 +21352,56 @@
       </p:sp>
       <p:sp>
         <p:nvSpPr>
+          <p:cNvPr id="11" name="TextBox 10"/>
+          <p:cNvSpPr txBox="1"/>
+          <p:nvPr/>
+        </p:nvSpPr>
+        <p:spPr>
+          <a:xfrm>
+            <a:off x="2926079" y="2596896"/>
+            <a:ext cx="2103120" cy="411480"/>
+          </a:xfrm>
+          <a:prstGeom prst="rect">
+            <a:avLst/>
+          </a:prstGeom>
+          <a:noFill/>
+        </p:spPr>
+        <p:txBody>
+          <a:bodyPr wrap="square" lIns="0" rIns="0" tIns="0" bIns="0" anchor="t">
+            <a:spAutoFit/>
+          </a:bodyPr>
+          <a:lstStyle/>
+          <a:p>
+            <a:pPr algn="ctr">
+              <a:spcBef>
+                <a:spcPts val="0"/>
+              </a:spcBef>
+              <a:spcAft>
+                <a:spcPts val="0"/>
+              </a:spcAft>
+            </a:pPr>
+            <a:r>
+              <a:rPr sz="2400" b="1" i="0">
+                <a:solidFill>
+                  <a:srgbClr val="0033A0"/>
+                </a:solidFill>
+                <a:latin typeface="Segoe UI"/>
+              </a:rPr>
+              <a:t>Today</a:t>
+            </a:r>
+          </a:p>
+        </p:txBody>
+      </p:sp>
+      <p:sp>
+        <p:nvSpPr>
           <p:cNvPr id="12" name="TextBox 11"/>
           <p:cNvSpPr txBox="1"/>
           <p:nvPr/>
         </p:nvSpPr>
         <p:spPr>
           <a:xfrm>
-            <a:off x="2926079" y="2596896"/>
-            <a:ext cx="2103120" cy="411480"/>
+            <a:off x="2926079" y="4087368"/>
+            <a:ext cx="2103120" cy="274320"/>
           </a:xfrm>
           <a:prstGeom prst="rect">
             <a:avLst/>
@@ -21579,51 +21423,9 @@
               </a:spcAft>
             </a:pPr>
             <a:r>
-              <a:rPr sz="2400" b="1" i="0">
-                <a:solidFill>
-                  <a:srgbClr val="D5FB00"/>
-                </a:solidFill>
-                <a:latin typeface="Segoe UI"/>
-              </a:rPr>
-              <a:t>Today</a:t>
-            </a:r>
-          </a:p>
-        </p:txBody>
-      </p:sp>
-      <p:sp>
-        <p:nvSpPr>
-          <p:cNvPr id="13" name="TextBox 12"/>
-          <p:cNvSpPr txBox="1"/>
-          <p:nvPr/>
-        </p:nvSpPr>
-        <p:spPr>
-          <a:xfrm>
-            <a:off x="2926079" y="4087368"/>
-            <a:ext cx="2103120" cy="274320"/>
-          </a:xfrm>
-          <a:prstGeom prst="rect">
-            <a:avLst/>
-          </a:prstGeom>
-          <a:noFill/>
-        </p:spPr>
-        <p:txBody>
-          <a:bodyPr wrap="square" lIns="0" rIns="0" tIns="0" bIns="0" anchor="t">
-            <a:spAutoFit/>
-          </a:bodyPr>
-          <a:lstStyle/>
-          <a:p>
-            <a:pPr algn="ctr">
-              <a:spcBef>
-                <a:spcPts val="0"/>
-              </a:spcBef>
-              <a:spcAft>
-                <a:spcPts val="0"/>
-              </a:spcAft>
-            </a:pPr>
-            <a:r>
               <a:rPr sz="1400" b="1" i="0">
                 <a:solidFill>
-                  <a:srgbClr val="D5FB00"/>
+                  <a:srgbClr val="0033A0"/>
                 </a:solidFill>
                 <a:latin typeface="Segoe UI"/>
               </a:rPr>
@@ -21634,7 +21436,7 @@
       </p:sp>
       <p:sp>
         <p:nvSpPr>
-          <p:cNvPr id="14" name="Oval 13"/>
+          <p:cNvPr id="13" name="Oval 12"/>
           <p:cNvSpPr/>
           <p:nvPr/>
         </p:nvSpPr>
@@ -21647,7 +21449,7 @@
             <a:avLst/>
           </a:prstGeom>
           <a:solidFill>
-            <a:srgbClr val="FFFFFF"/>
+            <a:srgbClr val="051C2C"/>
           </a:solidFill>
           <a:ln>
             <a:noFill/>
@@ -21663,14 +21465,56 @@
       </p:sp>
       <p:sp>
         <p:nvSpPr>
+          <p:cNvPr id="14" name="TextBox 13"/>
+          <p:cNvSpPr txBox="1"/>
+          <p:nvPr/>
+        </p:nvSpPr>
+        <p:spPr>
+          <a:xfrm>
+            <a:off x="5120640" y="2596896"/>
+            <a:ext cx="2103120" cy="411480"/>
+          </a:xfrm>
+          <a:prstGeom prst="rect">
+            <a:avLst/>
+          </a:prstGeom>
+          <a:noFill/>
+        </p:spPr>
+        <p:txBody>
+          <a:bodyPr wrap="square" lIns="0" rIns="0" tIns="0" bIns="0" anchor="t">
+            <a:spAutoFit/>
+          </a:bodyPr>
+          <a:lstStyle/>
+          <a:p>
+            <a:pPr algn="ctr">
+              <a:spcBef>
+                <a:spcPts val="0"/>
+              </a:spcBef>
+              <a:spcAft>
+                <a:spcPts val="0"/>
+              </a:spcAft>
+            </a:pPr>
+            <a:r>
+              <a:rPr sz="1900" b="1" i="0">
+                <a:solidFill>
+                  <a:srgbClr val="051C2C"/>
+                </a:solidFill>
+                <a:latin typeface="Segoe UI"/>
+              </a:rPr>
+              <a:t>Level I exam</a:t>
+            </a:r>
+          </a:p>
+        </p:txBody>
+      </p:sp>
+      <p:sp>
+        <p:nvSpPr>
           <p:cNvPr id="15" name="TextBox 14"/>
           <p:cNvSpPr txBox="1"/>
           <p:nvPr/>
         </p:nvSpPr>
         <p:spPr>
           <a:xfrm>
-            <a:off x="5120640" y="2596896"/>
-            <a:ext cx="2103120" cy="411480"/>
+            <a:off x="5120640" y="4087368"/>
+            <a:ext cx="2103120" cy="274320"/>
           </a:xfrm>
           <a:prstGeom prst="rect">
             <a:avLst/>
@@ -21692,51 +21536,9 @@
               </a:spcAft>
             </a:pPr>
             <a:r>
-              <a:rPr sz="1900" b="1" i="0">
-                <a:solidFill>
-                  <a:srgbClr val="FFFFFF"/>
-                </a:solidFill>
-                <a:latin typeface="Segoe UI"/>
-              </a:rPr>
-              <a:t>Level I exam</a:t>
-            </a:r>
-          </a:p>
-        </p:txBody>
-      </p:sp>
-      <p:sp>
-        <p:nvSpPr>
-          <p:cNvPr id="16" name="TextBox 15"/>
-          <p:cNvSpPr txBox="1"/>
-          <p:nvPr/>
-        </p:nvSpPr>
-        <p:spPr>
-          <a:xfrm>
-            <a:off x="5120640" y="4087368"/>
-            <a:ext cx="2103120" cy="274320"/>
-          </a:xfrm>
-          <a:prstGeom prst="rect">
-            <a:avLst/>
-          </a:prstGeom>
-          <a:noFill/>
-        </p:spPr>
-        <p:txBody>
-          <a:bodyPr wrap="square" lIns="0" rIns="0" tIns="0" bIns="0" anchor="t">
-            <a:spAutoFit/>
-          </a:bodyPr>
-          <a:lstStyle/>
-          <a:p>
-            <a:pPr algn="ctr">
-              <a:spcBef>
-                <a:spcPts val="0"/>
-              </a:spcBef>
-              <a:spcAft>
-                <a:spcPts val="0"/>
-              </a:spcAft>
-            </a:pPr>
-            <a:r>
               <a:rPr sz="1400" b="0" i="0">
                 <a:solidFill>
-                  <a:srgbClr val="C6CDD1"/>
+                  <a:srgbClr val="6B7A83"/>
                 </a:solidFill>
                 <a:latin typeface="Segoe UI"/>
               </a:rPr>
@@ -21747,7 +21549,7 @@
       </p:sp>
       <p:sp>
         <p:nvSpPr>
-          <p:cNvPr id="17" name="Oval 16"/>
+          <p:cNvPr id="16" name="Oval 15"/>
           <p:cNvSpPr/>
           <p:nvPr/>
         </p:nvSpPr>
@@ -21760,7 +21562,7 @@
             <a:avLst/>
           </a:prstGeom>
           <a:solidFill>
-            <a:srgbClr val="FFFFFF"/>
+            <a:srgbClr val="051C2C"/>
           </a:solidFill>
           <a:ln>
             <a:noFill/>
@@ -21776,14 +21578,56 @@
       </p:sp>
       <p:sp>
         <p:nvSpPr>
+          <p:cNvPr id="17" name="TextBox 16"/>
+          <p:cNvSpPr txBox="1"/>
+          <p:nvPr/>
+        </p:nvSpPr>
+        <p:spPr>
+          <a:xfrm>
+            <a:off x="7315199" y="2596896"/>
+            <a:ext cx="2103120" cy="411480"/>
+          </a:xfrm>
+          <a:prstGeom prst="rect">
+            <a:avLst/>
+          </a:prstGeom>
+          <a:noFill/>
+        </p:spPr>
+        <p:txBody>
+          <a:bodyPr wrap="square" lIns="0" rIns="0" tIns="0" bIns="0" anchor="t">
+            <a:spAutoFit/>
+          </a:bodyPr>
+          <a:lstStyle/>
+          <a:p>
+            <a:pPr algn="ctr">
+              <a:spcBef>
+                <a:spcPts val="0"/>
+              </a:spcBef>
+              <a:spcAft>
+                <a:spcPts val="0"/>
+              </a:spcAft>
+            </a:pPr>
+            <a:r>
+              <a:rPr sz="1900" b="1" i="0">
+                <a:solidFill>
+                  <a:srgbClr val="051C2C"/>
+                </a:solidFill>
+                <a:latin typeface="Segoe UI"/>
+              </a:rPr>
+              <a:t>Levels L and U</a:t>
+            </a:r>
+          </a:p>
+        </p:txBody>
+      </p:sp>
+      <p:sp>
+        <p:nvSpPr>
           <p:cNvPr id="18" name="TextBox 17"/>
           <p:cNvSpPr txBox="1"/>
           <p:nvPr/>
         </p:nvSpPr>
         <p:spPr>
           <a:xfrm>
-            <a:off x="7315199" y="2596896"/>
-            <a:ext cx="2103120" cy="411480"/>
+            <a:off x="7315199" y="4087368"/>
+            <a:ext cx="2103120" cy="274320"/>
           </a:xfrm>
           <a:prstGeom prst="rect">
             <a:avLst/>
@@ -21805,51 +21649,9 @@
               </a:spcAft>
             </a:pPr>
             <a:r>
-              <a:rPr sz="1900" b="1" i="0">
-                <a:solidFill>
-                  <a:srgbClr val="FFFFFF"/>
-                </a:solidFill>
-                <a:latin typeface="Segoe UI"/>
-              </a:rPr>
-              <a:t>Levels L and U</a:t>
-            </a:r>
-          </a:p>
-        </p:txBody>
-      </p:sp>
-      <p:sp>
-        <p:nvSpPr>
-          <p:cNvPr id="19" name="TextBox 18"/>
-          <p:cNvSpPr txBox="1"/>
-          <p:nvPr/>
-        </p:nvSpPr>
-        <p:spPr>
-          <a:xfrm>
-            <a:off x="7315199" y="4087368"/>
-            <a:ext cx="2103120" cy="274320"/>
-          </a:xfrm>
-          <a:prstGeom prst="rect">
-            <a:avLst/>
-          </a:prstGeom>
-          <a:noFill/>
-        </p:spPr>
-        <p:txBody>
-          <a:bodyPr wrap="square" lIns="0" rIns="0" tIns="0" bIns="0" anchor="t">
-            <a:spAutoFit/>
-          </a:bodyPr>
-          <a:lstStyle/>
-          <a:p>
-            <a:pPr algn="ctr">
-              <a:spcBef>
-                <a:spcPts val="0"/>
-              </a:spcBef>
-              <a:spcAft>
-                <a:spcPts val="0"/>
-              </a:spcAft>
-            </a:pPr>
-            <a:r>
               <a:rPr sz="1400" b="0" i="0">
                 <a:solidFill>
-                  <a:srgbClr val="C6CDD1"/>
+                  <a:srgbClr val="6B7A83"/>
                 </a:solidFill>
                 <a:latin typeface="Segoe UI"/>
               </a:rPr>
@@ -21860,7 +21662,7 @@
       </p:sp>
       <p:sp>
         <p:nvSpPr>
-          <p:cNvPr id="20" name="Oval 19"/>
+          <p:cNvPr id="19" name="Oval 18"/>
           <p:cNvSpPr/>
           <p:nvPr/>
         </p:nvSpPr>
@@ -21873,7 +21675,7 @@
             <a:avLst/>
           </a:prstGeom>
           <a:solidFill>
-            <a:srgbClr val="FFFFFF"/>
+            <a:srgbClr val="051C2C"/>
           </a:solidFill>
           <a:ln>
             <a:noFill/>
@@ -21889,14 +21691,56 @@
       </p:sp>
       <p:sp>
         <p:nvSpPr>
+          <p:cNvPr id="20" name="TextBox 19"/>
+          <p:cNvSpPr txBox="1"/>
+          <p:nvPr/>
+        </p:nvSpPr>
+        <p:spPr>
+          <a:xfrm>
+            <a:off x="9509759" y="2596896"/>
+            <a:ext cx="2103120" cy="411480"/>
+          </a:xfrm>
+          <a:prstGeom prst="rect">
+            <a:avLst/>
+          </a:prstGeom>
+          <a:noFill/>
+        </p:spPr>
+        <p:txBody>
+          <a:bodyPr wrap="square" lIns="0" rIns="0" tIns="0" bIns="0" anchor="t">
+            <a:spAutoFit/>
+          </a:bodyPr>
+          <a:lstStyle/>
+          <a:p>
+            <a:pPr algn="ctr">
+              <a:spcBef>
+                <a:spcPts val="0"/>
+              </a:spcBef>
+              <a:spcAft>
+                <a:spcPts val="0"/>
+              </a:spcAft>
+            </a:pPr>
+            <a:r>
+              <a:rPr sz="1900" b="1" i="0">
+                <a:solidFill>
+                  <a:srgbClr val="051C2C"/>
+                </a:solidFill>
+                <a:latin typeface="Segoe UI"/>
+              </a:rPr>
+              <a:t>Program close</a:t>
+            </a:r>
+          </a:p>
+        </p:txBody>
+      </p:sp>
+      <p:sp>
+        <p:nvSpPr>
           <p:cNvPr id="21" name="TextBox 20"/>
           <p:cNvSpPr txBox="1"/>
           <p:nvPr/>
         </p:nvSpPr>
         <p:spPr>
           <a:xfrm>
-            <a:off x="9509759" y="2596896"/>
-            <a:ext cx="2103120" cy="411480"/>
+            <a:off x="9509759" y="4087368"/>
+            <a:ext cx="2103120" cy="274320"/>
           </a:xfrm>
           <a:prstGeom prst="rect">
             <a:avLst/>
@@ -21918,51 +21762,9 @@
               </a:spcAft>
             </a:pPr>
             <a:r>
-              <a:rPr sz="1900" b="1" i="0">
-                <a:solidFill>
-                  <a:srgbClr val="FFFFFF"/>
-                </a:solidFill>
-                <a:latin typeface="Segoe UI"/>
-              </a:rPr>
-              <a:t>Program close</a:t>
-            </a:r>
-          </a:p>
-        </p:txBody>
-      </p:sp>
-      <p:sp>
-        <p:nvSpPr>
-          <p:cNvPr id="22" name="TextBox 21"/>
-          <p:cNvSpPr txBox="1"/>
-          <p:nvPr/>
-        </p:nvSpPr>
-        <p:spPr>
-          <a:xfrm>
-            <a:off x="9509759" y="4087368"/>
-            <a:ext cx="2103120" cy="274320"/>
-          </a:xfrm>
-          <a:prstGeom prst="rect">
-            <a:avLst/>
-          </a:prstGeom>
-          <a:noFill/>
-        </p:spPr>
-        <p:txBody>
-          <a:bodyPr wrap="square" lIns="0" rIns="0" tIns="0" bIns="0" anchor="t">
-            <a:spAutoFit/>
-          </a:bodyPr>
-          <a:lstStyle/>
-          <a:p>
-            <a:pPr algn="ctr">
-              <a:spcBef>
-                <a:spcPts val="0"/>
-              </a:spcBef>
-              <a:spcAft>
-                <a:spcPts val="0"/>
-              </a:spcAft>
-            </a:pPr>
-            <a:r>
               <a:rPr sz="1400" b="0" i="0">
                 <a:solidFill>
-                  <a:srgbClr val="C6CDD1"/>
+                  <a:srgbClr val="6B7A83"/>
                 </a:solidFill>
                 <a:latin typeface="Segoe UI"/>
               </a:rPr>
@@ -23097,7 +22899,7 @@
             <a:r>
               <a:rPr sz="2800" b="1">
                 <a:solidFill>
-                  <a:srgbClr val="FFFFFF"/>
+                  <a:srgbClr val="051C2C"/>
                 </a:solidFill>
                 <a:latin typeface="Segoe UI"/>
               </a:rPr>
@@ -23124,7 +22926,7 @@
             <a:r>
               <a:rPr sz="1300" b="0">
                 <a:solidFill>
-                  <a:srgbClr val="D5FB00"/>
+                  <a:srgbClr val="0033A0"/>
                 </a:solidFill>
                 <a:latin typeface="Segoe UI"/>
               </a:rPr>
@@ -23133,22 +22935,12 @@
           </a:p>
         </p:txBody>
       </p:sp>
-      <p:pic>
-        <p:nvPicPr>
-          <p:cNvPr id="4" name="!! Glass A" descr="Decorative glass panel"/>
-          <p:cNvPicPr>
-            <a:picLocks noChangeAspect="1"/>
-          </p:cNvPicPr>
+      <p:sp>
+        <p:nvSpPr>
+          <p:cNvPr id="4" name="!! Glass A"/>
+          <p:cNvSpPr/>
           <p:nvPr/>
-        </p:nvPicPr>
-        <p:blipFill>
-          <a:blip r:embed="rId2">
-            <a:alphaModFix amt="50000"/>
-          </a:blip>
-          <a:stretch>
-            <a:fillRect/>
-          </a:stretch>
-        </p:blipFill>
+        </p:nvSpPr>
         <p:spPr>
           <a:xfrm>
             <a:off x="256032" y="1600200"/>
@@ -23157,27 +22949,15 @@
           <a:prstGeom prst="rect">
             <a:avLst/>
           </a:prstGeom>
-        </p:spPr>
-      </p:pic>
-      <p:sp>
-        <p:nvSpPr>
-          <p:cNvPr id="5" name="!! Glass A rim"/>
-          <p:cNvSpPr/>
-          <p:nvPr/>
-        </p:nvSpPr>
-        <p:spPr>
-          <a:xfrm>
-            <a:off x="256032" y="1600200"/>
-            <a:ext cx="7543800" cy="3886200"/>
-          </a:xfrm>
-          <a:prstGeom prst="rect">
-            <a:avLst/>
-          </a:prstGeom>
-          <a:noFill/>
+          <a:solidFill>
+            <a:srgbClr val="051C2C">
+              <a:alpha val="4000"/>
+            </a:srgbClr>
+          </a:solidFill>
           <a:ln w="9525">
             <a:solidFill>
-              <a:srgbClr val="FFFFFF">
-                <a:alpha val="16000"/>
+              <a:srgbClr val="051C2C">
+                <a:alpha val="12000"/>
               </a:srgbClr>
             </a:solidFill>
           </a:ln>
@@ -23192,14 +22972,56 @@
       </p:sp>
       <p:sp>
         <p:nvSpPr>
+          <p:cNvPr id="5" name="TextBox 4"/>
+          <p:cNvSpPr txBox="1"/>
+          <p:nvPr/>
+        </p:nvSpPr>
+        <p:spPr>
+          <a:xfrm>
+            <a:off x="621792" y="1883664"/>
+            <a:ext cx="457200" cy="457200"/>
+          </a:xfrm>
+          <a:prstGeom prst="rect">
+            <a:avLst/>
+          </a:prstGeom>
+          <a:noFill/>
+        </p:spPr>
+        <p:txBody>
+          <a:bodyPr wrap="square" lIns="0" rIns="0" tIns="0" bIns="0" anchor="t">
+            <a:spAutoFit/>
+          </a:bodyPr>
+          <a:lstStyle/>
+          <a:p>
+            <a:pPr algn="l">
+              <a:spcBef>
+                <a:spcPts val="0"/>
+              </a:spcBef>
+              <a:spcAft>
+                <a:spcPts val="0"/>
+              </a:spcAft>
+            </a:pPr>
+            <a:r>
+              <a:rPr sz="2400" b="1" i="0">
+                <a:solidFill>
+                  <a:srgbClr val="0033A0"/>
+                </a:solidFill>
+                <a:latin typeface="Segoe UI"/>
+              </a:rPr>
+              <a:t>I</a:t>
+            </a:r>
+          </a:p>
+        </p:txBody>
+      </p:sp>
+      <p:sp>
+        <p:nvSpPr>
           <p:cNvPr id="6" name="TextBox 5"/>
           <p:cNvSpPr txBox="1"/>
           <p:nvPr/>
         </p:nvSpPr>
         <p:spPr>
           <a:xfrm>
-            <a:off x="621792" y="1883664"/>
-            <a:ext cx="457200" cy="457200"/>
+            <a:off x="1115568" y="1929384"/>
+            <a:ext cx="2011680" cy="274320"/>
           </a:xfrm>
           <a:prstGeom prst="rect">
             <a:avLst/>
@@ -23221,13 +23043,13 @@
               </a:spcAft>
             </a:pPr>
             <a:r>
-              <a:rPr sz="2400" b="1" i="0">
-                <a:solidFill>
-                  <a:srgbClr val="D5FB00"/>
+              <a:rPr sz="1300" b="1" i="0">
+                <a:solidFill>
+                  <a:srgbClr val="051C2C"/>
                 </a:solidFill>
                 <a:latin typeface="Segoe UI"/>
               </a:rPr>
-              <a:t>I</a:t>
+              <a:t>Understands</a:t>
             </a:r>
           </a:p>
         </p:txBody>
@@ -23240,7 +23062,7 @@
         </p:nvSpPr>
         <p:spPr>
           <a:xfrm>
-            <a:off x="1115568" y="1929384"/>
+            <a:off x="1115568" y="2176272"/>
             <a:ext cx="2011680" cy="274320"/>
           </a:xfrm>
           <a:prstGeom prst="rect">
@@ -23263,51 +23085,9 @@
               </a:spcAft>
             </a:pPr>
             <a:r>
-              <a:rPr sz="1300" b="1" i="0">
-                <a:solidFill>
-                  <a:srgbClr val="FFFFFF"/>
-                </a:solidFill>
-                <a:latin typeface="Segoe UI"/>
-              </a:rPr>
-              <a:t>Understands</a:t>
-            </a:r>
-          </a:p>
-        </p:txBody>
-      </p:sp>
-      <p:sp>
-        <p:nvSpPr>
-          <p:cNvPr id="8" name="TextBox 7"/>
-          <p:cNvSpPr txBox="1"/>
-          <p:nvPr/>
-        </p:nvSpPr>
-        <p:spPr>
-          <a:xfrm>
-            <a:off x="1115568" y="2176272"/>
-            <a:ext cx="2011680" cy="274320"/>
-          </a:xfrm>
-          <a:prstGeom prst="rect">
-            <a:avLst/>
-          </a:prstGeom>
-          <a:noFill/>
-        </p:spPr>
-        <p:txBody>
-          <a:bodyPr wrap="square" lIns="0" rIns="0" tIns="0" bIns="0" anchor="t">
-            <a:spAutoFit/>
-          </a:bodyPr>
-          <a:lstStyle/>
-          <a:p>
-            <a:pPr algn="l">
-              <a:spcBef>
-                <a:spcPts val="0"/>
-              </a:spcBef>
-              <a:spcAft>
-                <a:spcPts val="0"/>
-              </a:spcAft>
-            </a:pPr>
-            <a:r>
               <a:rPr sz="1100" b="0" i="0">
                 <a:solidFill>
-                  <a:srgbClr val="8A9BA8"/>
+                  <a:srgbClr val="6B7A83"/>
                 </a:solidFill>
                 <a:latin typeface="Segoe UI"/>
               </a:rPr>
@@ -23318,7 +23098,7 @@
       </p:sp>
       <p:sp>
         <p:nvSpPr>
-          <p:cNvPr id="9" name="Oval 8"/>
+          <p:cNvPr id="8" name="Oval 7"/>
           <p:cNvSpPr/>
           <p:nvPr/>
         </p:nvSpPr>
@@ -23331,13 +23111,13 @@
             <a:avLst/>
           </a:prstGeom>
           <a:solidFill>
-            <a:srgbClr val="D5FB00">
+            <a:srgbClr val="0033A0">
               <a:alpha val="35000"/>
             </a:srgbClr>
           </a:solidFill>
           <a:ln w="15875">
             <a:solidFill>
-              <a:srgbClr val="D5FB00"/>
+              <a:srgbClr val="0033A0"/>
             </a:solidFill>
           </a:ln>
         </p:spPr>
@@ -23351,7 +23131,7 @@
       </p:sp>
       <p:sp>
         <p:nvSpPr>
-          <p:cNvPr id="10" name="Oval 9"/>
+          <p:cNvPr id="9" name="Oval 8"/>
           <p:cNvSpPr/>
           <p:nvPr/>
         </p:nvSpPr>
@@ -23364,13 +23144,13 @@
             <a:avLst/>
           </a:prstGeom>
           <a:solidFill>
-            <a:srgbClr val="D5FB00">
+            <a:srgbClr val="0033A0">
               <a:alpha val="35000"/>
             </a:srgbClr>
           </a:solidFill>
           <a:ln w="15875">
             <a:solidFill>
-              <a:srgbClr val="D5FB00"/>
+              <a:srgbClr val="0033A0"/>
             </a:solidFill>
           </a:ln>
         </p:spPr>
@@ -23384,7 +23164,7 @@
       </p:sp>
       <p:sp>
         <p:nvSpPr>
-          <p:cNvPr id="11" name="Oval 10"/>
+          <p:cNvPr id="10" name="Oval 9"/>
           <p:cNvSpPr/>
           <p:nvPr/>
         </p:nvSpPr>
@@ -23397,13 +23177,13 @@
             <a:avLst/>
           </a:prstGeom>
           <a:solidFill>
-            <a:srgbClr val="D5FB00">
+            <a:srgbClr val="0033A0">
               <a:alpha val="35000"/>
             </a:srgbClr>
           </a:solidFill>
           <a:ln w="15875">
             <a:solidFill>
-              <a:srgbClr val="D5FB00"/>
+              <a:srgbClr val="0033A0"/>
             </a:solidFill>
           </a:ln>
         </p:spPr>
@@ -23417,7 +23197,7 @@
       </p:sp>
       <p:sp>
         <p:nvSpPr>
-          <p:cNvPr id="12" name="Oval 11"/>
+          <p:cNvPr id="11" name="Oval 10"/>
           <p:cNvSpPr/>
           <p:nvPr/>
         </p:nvSpPr>
@@ -23430,13 +23210,13 @@
             <a:avLst/>
           </a:prstGeom>
           <a:solidFill>
-            <a:srgbClr val="D5FB00">
+            <a:srgbClr val="0033A0">
               <a:alpha val="35000"/>
             </a:srgbClr>
           </a:solidFill>
           <a:ln w="15875">
             <a:solidFill>
-              <a:srgbClr val="D5FB00"/>
+              <a:srgbClr val="0033A0"/>
             </a:solidFill>
           </a:ln>
         </p:spPr>
@@ -23450,7 +23230,7 @@
       </p:sp>
       <p:sp>
         <p:nvSpPr>
-          <p:cNvPr id="13" name="Oval 12"/>
+          <p:cNvPr id="12" name="Oval 11"/>
           <p:cNvSpPr/>
           <p:nvPr/>
         </p:nvSpPr>
@@ -23463,13 +23243,13 @@
             <a:avLst/>
           </a:prstGeom>
           <a:solidFill>
-            <a:srgbClr val="D5FB00">
+            <a:srgbClr val="0033A0">
               <a:alpha val="35000"/>
             </a:srgbClr>
           </a:solidFill>
           <a:ln w="15875">
             <a:solidFill>
-              <a:srgbClr val="D5FB00"/>
+              <a:srgbClr val="0033A0"/>
             </a:solidFill>
           </a:ln>
         </p:spPr>
@@ -23483,7 +23263,7 @@
       </p:sp>
       <p:sp>
         <p:nvSpPr>
-          <p:cNvPr id="14" name="Oval 13"/>
+          <p:cNvPr id="13" name="Oval 12"/>
           <p:cNvSpPr/>
           <p:nvPr/>
         </p:nvSpPr>
@@ -23496,13 +23276,13 @@
             <a:avLst/>
           </a:prstGeom>
           <a:solidFill>
-            <a:srgbClr val="D5FB00">
+            <a:srgbClr val="0033A0">
               <a:alpha val="35000"/>
             </a:srgbClr>
           </a:solidFill>
           <a:ln w="15875">
             <a:solidFill>
-              <a:srgbClr val="D5FB00"/>
+              <a:srgbClr val="0033A0"/>
             </a:solidFill>
           </a:ln>
         </p:spPr>
@@ -23516,7 +23296,7 @@
       </p:sp>
       <p:sp>
         <p:nvSpPr>
-          <p:cNvPr id="15" name="Oval 14"/>
+          <p:cNvPr id="14" name="Oval 13"/>
           <p:cNvSpPr/>
           <p:nvPr/>
         </p:nvSpPr>
@@ -23529,13 +23309,13 @@
             <a:avLst/>
           </a:prstGeom>
           <a:solidFill>
-            <a:srgbClr val="D5FB00">
+            <a:srgbClr val="0033A0">
               <a:alpha val="35000"/>
             </a:srgbClr>
           </a:solidFill>
           <a:ln w="15875">
             <a:solidFill>
-              <a:srgbClr val="D5FB00"/>
+              <a:srgbClr val="0033A0"/>
             </a:solidFill>
           </a:ln>
         </p:spPr>
@@ -23549,7 +23329,7 @@
       </p:sp>
       <p:sp>
         <p:nvSpPr>
-          <p:cNvPr id="16" name="Oval 15"/>
+          <p:cNvPr id="15" name="Oval 14"/>
           <p:cNvSpPr/>
           <p:nvPr/>
         </p:nvSpPr>
@@ -23562,13 +23342,13 @@
             <a:avLst/>
           </a:prstGeom>
           <a:solidFill>
-            <a:srgbClr val="D5FB00">
+            <a:srgbClr val="0033A0">
               <a:alpha val="35000"/>
             </a:srgbClr>
           </a:solidFill>
           <a:ln w="15875">
             <a:solidFill>
-              <a:srgbClr val="D5FB00"/>
+              <a:srgbClr val="0033A0"/>
             </a:solidFill>
           </a:ln>
         </p:spPr>
@@ -23582,7 +23362,7 @@
       </p:sp>
       <p:sp>
         <p:nvSpPr>
-          <p:cNvPr id="17" name="Oval 16"/>
+          <p:cNvPr id="16" name="Oval 15"/>
           <p:cNvSpPr/>
           <p:nvPr/>
         </p:nvSpPr>
@@ -23595,13 +23375,13 @@
             <a:avLst/>
           </a:prstGeom>
           <a:solidFill>
-            <a:srgbClr val="D5FB00">
+            <a:srgbClr val="0033A0">
               <a:alpha val="35000"/>
             </a:srgbClr>
           </a:solidFill>
           <a:ln w="15875">
             <a:solidFill>
-              <a:srgbClr val="D5FB00"/>
+              <a:srgbClr val="0033A0"/>
             </a:solidFill>
           </a:ln>
         </p:spPr>
@@ -23610,6 +23390,48 @@
           <a:lstStyle/>
           <a:p>
             <a:pPr algn="ctr"/>
+          </a:p>
+        </p:txBody>
+      </p:sp>
+      <p:sp>
+        <p:nvSpPr>
+          <p:cNvPr id="17" name="TextBox 16"/>
+          <p:cNvSpPr txBox="1"/>
+          <p:nvPr/>
+        </p:nvSpPr>
+        <p:spPr>
+          <a:xfrm>
+            <a:off x="621792" y="2651760"/>
+            <a:ext cx="457200" cy="457200"/>
+          </a:xfrm>
+          <a:prstGeom prst="rect">
+            <a:avLst/>
+          </a:prstGeom>
+          <a:noFill/>
+        </p:spPr>
+        <p:txBody>
+          <a:bodyPr wrap="square" lIns="0" rIns="0" tIns="0" bIns="0" anchor="t">
+            <a:spAutoFit/>
+          </a:bodyPr>
+          <a:lstStyle/>
+          <a:p>
+            <a:pPr algn="l">
+              <a:spcBef>
+                <a:spcPts val="0"/>
+              </a:spcBef>
+              <a:spcAft>
+                <a:spcPts val="0"/>
+              </a:spcAft>
+            </a:pPr>
+            <a:r>
+              <a:rPr sz="2400" b="1" i="0">
+                <a:solidFill>
+                  <a:srgbClr val="0033A0"/>
+                </a:solidFill>
+                <a:latin typeface="Segoe UI"/>
+              </a:rPr>
+              <a:t>L</a:t>
+            </a:r>
           </a:p>
         </p:txBody>
       </p:sp>
@@ -23621,8 +23443,8 @@
         </p:nvSpPr>
         <p:spPr>
           <a:xfrm>
-            <a:off x="621792" y="2651760"/>
-            <a:ext cx="457200" cy="457200"/>
+            <a:off x="1115568" y="2697480"/>
+            <a:ext cx="2011680" cy="274320"/>
           </a:xfrm>
           <a:prstGeom prst="rect">
             <a:avLst/>
@@ -23644,13 +23466,13 @@
               </a:spcAft>
             </a:pPr>
             <a:r>
-              <a:rPr sz="2400" b="1" i="0">
-                <a:solidFill>
-                  <a:srgbClr val="D5FB00"/>
+              <a:rPr sz="1300" b="1" i="0">
+                <a:solidFill>
+                  <a:srgbClr val="051C2C"/>
                 </a:solidFill>
                 <a:latin typeface="Segoe UI"/>
               </a:rPr>
-              <a:t>L</a:t>
+              <a:t>With support</a:t>
             </a:r>
           </a:p>
         </p:txBody>
@@ -23663,7 +23485,7 @@
         </p:nvSpPr>
         <p:spPr>
           <a:xfrm>
-            <a:off x="1115568" y="2697480"/>
+            <a:off x="1115568" y="2944368"/>
             <a:ext cx="2011680" cy="274320"/>
           </a:xfrm>
           <a:prstGeom prst="rect">
@@ -23686,51 +23508,9 @@
               </a:spcAft>
             </a:pPr>
             <a:r>
-              <a:rPr sz="1300" b="1" i="0">
-                <a:solidFill>
-                  <a:srgbClr val="FFFFFF"/>
-                </a:solidFill>
-                <a:latin typeface="Segoe UI"/>
-              </a:rPr>
-              <a:t>With support</a:t>
-            </a:r>
-          </a:p>
-        </p:txBody>
-      </p:sp>
-      <p:sp>
-        <p:nvSpPr>
-          <p:cNvPr id="20" name="TextBox 19"/>
-          <p:cNvSpPr txBox="1"/>
-          <p:nvPr/>
-        </p:nvSpPr>
-        <p:spPr>
-          <a:xfrm>
-            <a:off x="1115568" y="2944368"/>
-            <a:ext cx="2011680" cy="274320"/>
-          </a:xfrm>
-          <a:prstGeom prst="rect">
-            <a:avLst/>
-          </a:prstGeom>
-          <a:noFill/>
-        </p:spPr>
-        <p:txBody>
-          <a:bodyPr wrap="square" lIns="0" rIns="0" tIns="0" bIns="0" anchor="t">
-            <a:spAutoFit/>
-          </a:bodyPr>
-          <a:lstStyle/>
-          <a:p>
-            <a:pPr algn="l">
-              <a:spcBef>
-                <a:spcPts val="0"/>
-              </a:spcBef>
-              <a:spcAft>
-                <a:spcPts val="0"/>
-              </a:spcAft>
-            </a:pPr>
-            <a:r>
               <a:rPr sz="1100" b="0" i="0">
                 <a:solidFill>
-                  <a:srgbClr val="8A9BA8"/>
+                  <a:srgbClr val="6B7A83"/>
                 </a:solidFill>
                 <a:latin typeface="Segoe UI"/>
               </a:rPr>
@@ -23741,7 +23521,7 @@
       </p:sp>
       <p:sp>
         <p:nvSpPr>
-          <p:cNvPr id="21" name="Oval 20"/>
+          <p:cNvPr id="20" name="Oval 19"/>
           <p:cNvSpPr/>
           <p:nvPr/>
         </p:nvSpPr>
@@ -23754,7 +23534,7 @@
             <a:avLst/>
           </a:prstGeom>
           <a:solidFill>
-            <a:srgbClr val="D5FB00"/>
+            <a:srgbClr val="0033A0"/>
           </a:solidFill>
           <a:ln>
             <a:noFill/>
@@ -23770,7 +23550,7 @@
       </p:sp>
       <p:sp>
         <p:nvSpPr>
-          <p:cNvPr id="22" name="Oval 21"/>
+          <p:cNvPr id="21" name="Oval 20"/>
           <p:cNvSpPr/>
           <p:nvPr/>
         </p:nvSpPr>
@@ -23783,7 +23563,7 @@
             <a:avLst/>
           </a:prstGeom>
           <a:solidFill>
-            <a:srgbClr val="D5FB00"/>
+            <a:srgbClr val="0033A0"/>
           </a:solidFill>
           <a:ln>
             <a:noFill/>
@@ -23799,7 +23579,7 @@
       </p:sp>
       <p:sp>
         <p:nvSpPr>
-          <p:cNvPr id="23" name="Oval 22"/>
+          <p:cNvPr id="22" name="Oval 21"/>
           <p:cNvSpPr/>
           <p:nvPr/>
         </p:nvSpPr>
@@ -23812,7 +23592,7 @@
             <a:avLst/>
           </a:prstGeom>
           <a:solidFill>
-            <a:srgbClr val="D5FB00"/>
+            <a:srgbClr val="0033A0"/>
           </a:solidFill>
           <a:ln>
             <a:noFill/>
@@ -23828,7 +23608,7 @@
       </p:sp>
       <p:sp>
         <p:nvSpPr>
-          <p:cNvPr id="24" name="Oval 23"/>
+          <p:cNvPr id="23" name="Oval 22"/>
           <p:cNvSpPr/>
           <p:nvPr/>
         </p:nvSpPr>
@@ -23841,13 +23621,13 @@
             <a:avLst/>
           </a:prstGeom>
           <a:solidFill>
-            <a:srgbClr val="D5FB00">
+            <a:srgbClr val="0033A0">
               <a:alpha val="35000"/>
             </a:srgbClr>
           </a:solidFill>
           <a:ln w="15875">
             <a:solidFill>
-              <a:srgbClr val="D5FB00"/>
+              <a:srgbClr val="0033A0"/>
             </a:solidFill>
           </a:ln>
         </p:spPr>
@@ -23861,7 +23641,7 @@
       </p:sp>
       <p:sp>
         <p:nvSpPr>
-          <p:cNvPr id="25" name="Oval 24"/>
+          <p:cNvPr id="24" name="Oval 23"/>
           <p:cNvSpPr/>
           <p:nvPr/>
         </p:nvSpPr>
@@ -23874,13 +23654,13 @@
             <a:avLst/>
           </a:prstGeom>
           <a:solidFill>
-            <a:srgbClr val="D5FB00">
+            <a:srgbClr val="0033A0">
               <a:alpha val="35000"/>
             </a:srgbClr>
           </a:solidFill>
           <a:ln w="15875">
             <a:solidFill>
-              <a:srgbClr val="D5FB00"/>
+              <a:srgbClr val="0033A0"/>
             </a:solidFill>
           </a:ln>
         </p:spPr>
@@ -23889,6 +23669,48 @@
           <a:lstStyle/>
           <a:p>
             <a:pPr algn="ctr"/>
+          </a:p>
+        </p:txBody>
+      </p:sp>
+      <p:sp>
+        <p:nvSpPr>
+          <p:cNvPr id="25" name="TextBox 24"/>
+          <p:cNvSpPr txBox="1"/>
+          <p:nvPr/>
+        </p:nvSpPr>
+        <p:spPr>
+          <a:xfrm>
+            <a:off x="621792" y="3419856"/>
+            <a:ext cx="457200" cy="457200"/>
+          </a:xfrm>
+          <a:prstGeom prst="rect">
+            <a:avLst/>
+          </a:prstGeom>
+          <a:noFill/>
+        </p:spPr>
+        <p:txBody>
+          <a:bodyPr wrap="square" lIns="0" rIns="0" tIns="0" bIns="0" anchor="t">
+            <a:spAutoFit/>
+          </a:bodyPr>
+          <a:lstStyle/>
+          <a:p>
+            <a:pPr algn="l">
+              <a:spcBef>
+                <a:spcPts val="0"/>
+              </a:spcBef>
+              <a:spcAft>
+                <a:spcPts val="0"/>
+              </a:spcAft>
+            </a:pPr>
+            <a:r>
+              <a:rPr sz="2400" b="1" i="0">
+                <a:solidFill>
+                  <a:srgbClr val="0033A0"/>
+                </a:solidFill>
+                <a:latin typeface="Segoe UI"/>
+              </a:rPr>
+              <a:t>U</a:t>
+            </a:r>
           </a:p>
         </p:txBody>
       </p:sp>
@@ -23900,8 +23722,8 @@
         </p:nvSpPr>
         <p:spPr>
           <a:xfrm>
-            <a:off x="621792" y="3419856"/>
-            <a:ext cx="457200" cy="457200"/>
+            <a:off x="1115568" y="3465576"/>
+            <a:ext cx="2011680" cy="274320"/>
           </a:xfrm>
           <a:prstGeom prst="rect">
             <a:avLst/>
@@ -23923,13 +23745,13 @@
               </a:spcAft>
             </a:pPr>
             <a:r>
-              <a:rPr sz="2400" b="1" i="0">
-                <a:solidFill>
-                  <a:srgbClr val="D5FB00"/>
+              <a:rPr sz="1300" b="1" i="0">
+                <a:solidFill>
+                  <a:srgbClr val="051C2C"/>
                 </a:solidFill>
                 <a:latin typeface="Segoe UI"/>
               </a:rPr>
-              <a:t>U</a:t>
+              <a:t>Alone</a:t>
             </a:r>
           </a:p>
         </p:txBody>
@@ -23942,7 +23764,7 @@
         </p:nvSpPr>
         <p:spPr>
           <a:xfrm>
-            <a:off x="1115568" y="3465576"/>
+            <a:off x="1115568" y="3712463"/>
             <a:ext cx="2011680" cy="274320"/>
           </a:xfrm>
           <a:prstGeom prst="rect">
@@ -23965,51 +23787,9 @@
               </a:spcAft>
             </a:pPr>
             <a:r>
-              <a:rPr sz="1300" b="1" i="0">
-                <a:solidFill>
-                  <a:srgbClr val="FFFFFF"/>
-                </a:solidFill>
-                <a:latin typeface="Segoe UI"/>
-              </a:rPr>
-              <a:t>Alone</a:t>
-            </a:r>
-          </a:p>
-        </p:txBody>
-      </p:sp>
-      <p:sp>
-        <p:nvSpPr>
-          <p:cNvPr id="28" name="TextBox 27"/>
-          <p:cNvSpPr txBox="1"/>
-          <p:nvPr/>
-        </p:nvSpPr>
-        <p:spPr>
-          <a:xfrm>
-            <a:off x="1115568" y="3712463"/>
-            <a:ext cx="2011680" cy="274320"/>
-          </a:xfrm>
-          <a:prstGeom prst="rect">
-            <a:avLst/>
-          </a:prstGeom>
-          <a:noFill/>
-        </p:spPr>
-        <p:txBody>
-          <a:bodyPr wrap="square" lIns="0" rIns="0" tIns="0" bIns="0" anchor="t">
-            <a:spAutoFit/>
-          </a:bodyPr>
-          <a:lstStyle/>
-          <a:p>
-            <a:pPr algn="l">
-              <a:spcBef>
-                <a:spcPts val="0"/>
-              </a:spcBef>
-              <a:spcAft>
-                <a:spcPts val="0"/>
-              </a:spcAft>
-            </a:pPr>
-            <a:r>
               <a:rPr sz="1100" b="0" i="0">
                 <a:solidFill>
-                  <a:srgbClr val="8A9BA8"/>
+                  <a:srgbClr val="6B7A83"/>
                 </a:solidFill>
                 <a:latin typeface="Segoe UI"/>
               </a:rPr>
@@ -24020,7 +23800,7 @@
       </p:sp>
       <p:sp>
         <p:nvSpPr>
-          <p:cNvPr id="29" name="Oval 28"/>
+          <p:cNvPr id="28" name="Oval 27"/>
           <p:cNvSpPr/>
           <p:nvPr/>
         </p:nvSpPr>
@@ -24033,13 +23813,13 @@
             <a:avLst/>
           </a:prstGeom>
           <a:solidFill>
-            <a:srgbClr val="D5FB00">
+            <a:srgbClr val="0033A0">
               <a:alpha val="35000"/>
             </a:srgbClr>
           </a:solidFill>
           <a:ln w="15875">
             <a:solidFill>
-              <a:srgbClr val="D5FB00"/>
+              <a:srgbClr val="0033A0"/>
             </a:solidFill>
           </a:ln>
         </p:spPr>
@@ -24053,7 +23833,7 @@
       </p:sp>
       <p:sp>
         <p:nvSpPr>
-          <p:cNvPr id="30" name="Oval 29"/>
+          <p:cNvPr id="29" name="Oval 28"/>
           <p:cNvSpPr/>
           <p:nvPr/>
         </p:nvSpPr>
@@ -24068,7 +23848,7 @@
           <a:noFill/>
           <a:ln w="12700">
             <a:solidFill>
-              <a:srgbClr val="C6CDD1">
+              <a:srgbClr val="6B7A83">
                 <a:alpha val="60000"/>
               </a:srgbClr>
             </a:solidFill>
@@ -24084,7 +23864,7 @@
       </p:sp>
       <p:sp>
         <p:nvSpPr>
-          <p:cNvPr id="31" name="Oval 30"/>
+          <p:cNvPr id="30" name="Oval 29"/>
           <p:cNvSpPr/>
           <p:nvPr/>
         </p:nvSpPr>
@@ -24099,7 +23879,7 @@
           <a:noFill/>
           <a:ln w="12700">
             <a:solidFill>
-              <a:srgbClr val="C6CDD1">
+              <a:srgbClr val="6B7A83">
                 <a:alpha val="60000"/>
               </a:srgbClr>
             </a:solidFill>
@@ -24115,14 +23895,56 @@
       </p:sp>
       <p:sp>
         <p:nvSpPr>
+          <p:cNvPr id="31" name="TextBox 30"/>
+          <p:cNvSpPr txBox="1"/>
+          <p:nvPr/>
+        </p:nvSpPr>
+        <p:spPr>
+          <a:xfrm>
+            <a:off x="621792" y="4187952"/>
+            <a:ext cx="457200" cy="457200"/>
+          </a:xfrm>
+          <a:prstGeom prst="rect">
+            <a:avLst/>
+          </a:prstGeom>
+          <a:noFill/>
+        </p:spPr>
+        <p:txBody>
+          <a:bodyPr wrap="square" lIns="0" rIns="0" tIns="0" bIns="0" anchor="t">
+            <a:spAutoFit/>
+          </a:bodyPr>
+          <a:lstStyle/>
+          <a:p>
+            <a:pPr algn="l">
+              <a:spcBef>
+                <a:spcPts val="0"/>
+              </a:spcBef>
+              <a:spcAft>
+                <a:spcPts val="0"/>
+              </a:spcAft>
+            </a:pPr>
+            <a:r>
+              <a:rPr sz="2400" b="1" i="0">
+                <a:solidFill>
+                  <a:srgbClr val="0033A0"/>
+                </a:solidFill>
+                <a:latin typeface="Segoe UI"/>
+              </a:rPr>
+              <a:t>O</a:t>
+            </a:r>
+          </a:p>
+        </p:txBody>
+      </p:sp>
+      <p:sp>
+        <p:nvSpPr>
           <p:cNvPr id="32" name="TextBox 31"/>
           <p:cNvSpPr txBox="1"/>
           <p:nvPr/>
         </p:nvSpPr>
         <p:spPr>
           <a:xfrm>
-            <a:off x="621792" y="4187952"/>
-            <a:ext cx="457200" cy="457200"/>
+            <a:off x="1115568" y="4233672"/>
+            <a:ext cx="2011680" cy="274320"/>
           </a:xfrm>
           <a:prstGeom prst="rect">
             <a:avLst/>
@@ -24144,13 +23966,13 @@
               </a:spcAft>
             </a:pPr>
             <a:r>
-              <a:rPr sz="2400" b="1" i="0">
-                <a:solidFill>
-                  <a:srgbClr val="D5FB00"/>
+              <a:rPr sz="1300" b="1" i="0">
+                <a:solidFill>
+                  <a:srgbClr val="051C2C"/>
                 </a:solidFill>
                 <a:latin typeface="Segoe UI"/>
               </a:rPr>
-              <a:t>O</a:t>
+              <a:t>Improves</a:t>
             </a:r>
           </a:p>
         </p:txBody>
@@ -24163,7 +23985,7 @@
         </p:nvSpPr>
         <p:spPr>
           <a:xfrm>
-            <a:off x="1115568" y="4233672"/>
+            <a:off x="1115568" y="4480560"/>
             <a:ext cx="2011680" cy="274320"/>
           </a:xfrm>
           <a:prstGeom prst="rect">
@@ -24186,51 +24008,9 @@
               </a:spcAft>
             </a:pPr>
             <a:r>
-              <a:rPr sz="1300" b="1" i="0">
-                <a:solidFill>
-                  <a:srgbClr val="FFFFFF"/>
-                </a:solidFill>
-                <a:latin typeface="Segoe UI"/>
-              </a:rPr>
-              <a:t>Improves</a:t>
-            </a:r>
-          </a:p>
-        </p:txBody>
-      </p:sp>
-      <p:sp>
-        <p:nvSpPr>
-          <p:cNvPr id="34" name="TextBox 33"/>
-          <p:cNvSpPr txBox="1"/>
-          <p:nvPr/>
-        </p:nvSpPr>
-        <p:spPr>
-          <a:xfrm>
-            <a:off x="1115568" y="4480560"/>
-            <a:ext cx="2011680" cy="274320"/>
-          </a:xfrm>
-          <a:prstGeom prst="rect">
-            <a:avLst/>
-          </a:prstGeom>
-          <a:noFill/>
-        </p:spPr>
-        <p:txBody>
-          <a:bodyPr wrap="square" lIns="0" rIns="0" tIns="0" bIns="0" anchor="t">
-            <a:spAutoFit/>
-          </a:bodyPr>
-          <a:lstStyle/>
-          <a:p>
-            <a:pPr algn="l">
-              <a:spcBef>
-                <a:spcPts val="0"/>
-              </a:spcBef>
-              <a:spcAft>
-                <a:spcPts val="0"/>
-              </a:spcAft>
-            </a:pPr>
-            <a:r>
               <a:rPr sz="1100" b="0" i="0">
                 <a:solidFill>
-                  <a:srgbClr val="8A9BA8"/>
+                  <a:srgbClr val="6B7A83"/>
                 </a:solidFill>
                 <a:latin typeface="Segoe UI"/>
               </a:rPr>
@@ -24241,7 +24021,7 @@
       </p:sp>
       <p:sp>
         <p:nvSpPr>
-          <p:cNvPr id="35" name="Oval 34"/>
+          <p:cNvPr id="34" name="Oval 33"/>
           <p:cNvSpPr/>
           <p:nvPr/>
         </p:nvSpPr>
@@ -24254,7 +24034,7 @@
             <a:avLst/>
           </a:prstGeom>
           <a:solidFill>
-            <a:srgbClr val="D5FB00"/>
+            <a:srgbClr val="0033A0"/>
           </a:solidFill>
           <a:ln>
             <a:noFill/>
@@ -24270,7 +24050,7 @@
       </p:sp>
       <p:sp>
         <p:nvSpPr>
-          <p:cNvPr id="36" name="Oval 35"/>
+          <p:cNvPr id="35" name="Oval 34"/>
           <p:cNvSpPr/>
           <p:nvPr/>
         </p:nvSpPr>
@@ -24283,13 +24063,13 @@
             <a:avLst/>
           </a:prstGeom>
           <a:solidFill>
-            <a:srgbClr val="D5FB00">
+            <a:srgbClr val="0033A0">
               <a:alpha val="35000"/>
             </a:srgbClr>
           </a:solidFill>
           <a:ln w="15875">
             <a:solidFill>
-              <a:srgbClr val="D5FB00"/>
+              <a:srgbClr val="0033A0"/>
             </a:solidFill>
           </a:ln>
         </p:spPr>
@@ -24303,7 +24083,7 @@
       </p:sp>
       <p:sp>
         <p:nvSpPr>
-          <p:cNvPr id="37" name="Oval 36"/>
+          <p:cNvPr id="36" name="Oval 35"/>
           <p:cNvSpPr/>
           <p:nvPr/>
         </p:nvSpPr>
@@ -24318,7 +24098,7 @@
           <a:noFill/>
           <a:ln w="12700">
             <a:solidFill>
-              <a:srgbClr val="C6CDD1">
+              <a:srgbClr val="6B7A83">
                 <a:alpha val="60000"/>
               </a:srgbClr>
             </a:solidFill>
@@ -24334,7 +24114,7 @@
       </p:sp>
       <p:sp>
         <p:nvSpPr>
-          <p:cNvPr id="38" name="Oval 37"/>
+          <p:cNvPr id="37" name="Oval 36"/>
           <p:cNvSpPr/>
           <p:nvPr/>
         </p:nvSpPr>
@@ -24349,7 +24129,7 @@
           <a:noFill/>
           <a:ln w="12700">
             <a:solidFill>
-              <a:srgbClr val="C6CDD1">
+              <a:srgbClr val="6B7A83">
                 <a:alpha val="60000"/>
               </a:srgbClr>
             </a:solidFill>
@@ -24365,7 +24145,7 @@
       </p:sp>
       <p:sp>
         <p:nvSpPr>
-          <p:cNvPr id="39" name="Oval 38"/>
+          <p:cNvPr id="38" name="Oval 37"/>
           <p:cNvSpPr/>
           <p:nvPr/>
         </p:nvSpPr>
@@ -24380,7 +24160,7 @@
           <a:noFill/>
           <a:ln w="12700">
             <a:solidFill>
-              <a:srgbClr val="C6CDD1">
+              <a:srgbClr val="6B7A83">
                 <a:alpha val="60000"/>
               </a:srgbClr>
             </a:solidFill>
@@ -24396,7 +24176,7 @@
       </p:sp>
       <p:sp>
         <p:nvSpPr>
-          <p:cNvPr id="40" name="Oval 39"/>
+          <p:cNvPr id="39" name="Oval 38"/>
           <p:cNvSpPr/>
           <p:nvPr/>
         </p:nvSpPr>
@@ -24411,7 +24191,7 @@
           <a:noFill/>
           <a:ln w="12700">
             <a:solidFill>
-              <a:srgbClr val="C6CDD1">
+              <a:srgbClr val="6B7A83">
                 <a:alpha val="60000"/>
               </a:srgbClr>
             </a:solidFill>
@@ -24427,7 +24207,7 @@
       </p:sp>
       <p:sp>
         <p:nvSpPr>
-          <p:cNvPr id="41" name="Oval 40"/>
+          <p:cNvPr id="40" name="Oval 39"/>
           <p:cNvSpPr/>
           <p:nvPr/>
         </p:nvSpPr>
@@ -24440,7 +24220,7 @@
             <a:avLst/>
           </a:prstGeom>
           <a:solidFill>
-            <a:srgbClr val="D5FB00"/>
+            <a:srgbClr val="0033A0"/>
           </a:solidFill>
           <a:ln>
             <a:noFill/>
@@ -24456,7 +24236,7 @@
       </p:sp>
       <p:sp>
         <p:nvSpPr>
-          <p:cNvPr id="42" name="TextBox 41"/>
+          <p:cNvPr id="41" name="TextBox 40"/>
           <p:cNvSpPr txBox="1"/>
           <p:nvPr/>
         </p:nvSpPr>
@@ -24487,7 +24267,7 @@
             <a:r>
               <a:rPr sz="1100" b="0" i="0">
                 <a:solidFill>
-                  <a:srgbClr val="C6CDD1"/>
+                  <a:srgbClr val="6B7A83"/>
                 </a:solidFill>
                 <a:latin typeface="Segoe UI"/>
               </a:rPr>
@@ -24498,7 +24278,7 @@
       </p:sp>
       <p:sp>
         <p:nvSpPr>
-          <p:cNvPr id="43" name="Oval 42"/>
+          <p:cNvPr id="42" name="Oval 41"/>
           <p:cNvSpPr/>
           <p:nvPr/>
         </p:nvSpPr>
@@ -24511,13 +24291,13 @@
             <a:avLst/>
           </a:prstGeom>
           <a:solidFill>
-            <a:srgbClr val="D5FB00">
+            <a:srgbClr val="0033A0">
               <a:alpha val="35000"/>
             </a:srgbClr>
           </a:solidFill>
           <a:ln w="15875">
             <a:solidFill>
-              <a:srgbClr val="D5FB00"/>
+              <a:srgbClr val="0033A0"/>
             </a:solidFill>
           </a:ln>
         </p:spPr>
@@ -24531,7 +24311,7 @@
       </p:sp>
       <p:sp>
         <p:nvSpPr>
-          <p:cNvPr id="44" name="TextBox 43"/>
+          <p:cNvPr id="43" name="TextBox 42"/>
           <p:cNvSpPr txBox="1"/>
           <p:nvPr/>
         </p:nvSpPr>
@@ -24562,7 +24342,7 @@
             <a:r>
               <a:rPr sz="1100" b="0" i="0">
                 <a:solidFill>
-                  <a:srgbClr val="C6CDD1"/>
+                  <a:srgbClr val="6B7A83"/>
                 </a:solidFill>
                 <a:latin typeface="Segoe UI"/>
               </a:rPr>
@@ -24573,7 +24353,7 @@
       </p:sp>
       <p:sp>
         <p:nvSpPr>
-          <p:cNvPr id="45" name="Oval 44"/>
+          <p:cNvPr id="44" name="Oval 43"/>
           <p:cNvSpPr/>
           <p:nvPr/>
         </p:nvSpPr>
@@ -24588,7 +24368,7 @@
           <a:noFill/>
           <a:ln w="12700">
             <a:solidFill>
-              <a:srgbClr val="C6CDD1">
+              <a:srgbClr val="6B7A83">
                 <a:alpha val="60000"/>
               </a:srgbClr>
             </a:solidFill>
@@ -24604,7 +24384,7 @@
       </p:sp>
       <p:sp>
         <p:nvSpPr>
-          <p:cNvPr id="46" name="TextBox 45"/>
+          <p:cNvPr id="45" name="TextBox 44"/>
           <p:cNvSpPr txBox="1"/>
           <p:nvPr/>
         </p:nvSpPr>
@@ -24635,7 +24415,7 @@
             <a:r>
               <a:rPr sz="1100" b="0" i="0">
                 <a:solidFill>
-                  <a:srgbClr val="C6CDD1"/>
+                  <a:srgbClr val="6B7A83"/>
                 </a:solidFill>
                 <a:latin typeface="Segoe UI"/>
               </a:rPr>
@@ -24644,22 +24424,12 @@
           </a:p>
         </p:txBody>
       </p:sp>
-      <p:pic>
-        <p:nvPicPr>
-          <p:cNvPr id="47" name="!! Glass B" descr="Decorative glass panel"/>
-          <p:cNvPicPr>
-            <a:picLocks noChangeAspect="1"/>
-          </p:cNvPicPr>
+      <p:sp>
+        <p:nvSpPr>
+          <p:cNvPr id="46" name="!! Glass B"/>
+          <p:cNvSpPr/>
           <p:nvPr/>
-        </p:nvPicPr>
-        <p:blipFill>
-          <a:blip r:embed="rId3">
-            <a:alphaModFix amt="50000"/>
-          </a:blip>
-          <a:stretch>
-            <a:fillRect/>
-          </a:stretch>
-        </p:blipFill>
+        </p:nvSpPr>
         <p:spPr>
           <a:xfrm>
             <a:off x="8092440" y="1600200"/>
@@ -24668,27 +24438,15 @@
           <a:prstGeom prst="rect">
             <a:avLst/>
           </a:prstGeom>
-        </p:spPr>
-      </p:pic>
-      <p:sp>
-        <p:nvSpPr>
-          <p:cNvPr id="48" name="!! Glass B rim"/>
-          <p:cNvSpPr/>
-          <p:nvPr/>
-        </p:nvSpPr>
-        <p:spPr>
-          <a:xfrm>
-            <a:off x="8092440" y="1600200"/>
-            <a:ext cx="3840480" cy="3886200"/>
-          </a:xfrm>
-          <a:prstGeom prst="rect">
-            <a:avLst/>
-          </a:prstGeom>
-          <a:noFill/>
+          <a:solidFill>
+            <a:srgbClr val="051C2C">
+              <a:alpha val="4000"/>
+            </a:srgbClr>
+          </a:solidFill>
           <a:ln w="9525">
             <a:solidFill>
-              <a:srgbClr val="FFFFFF">
-                <a:alpha val="16000"/>
+              <a:srgbClr val="051C2C">
+                <a:alpha val="12000"/>
               </a:srgbClr>
             </a:solidFill>
           </a:ln>
@@ -24703,7 +24461,7 @@
       </p:sp>
       <p:sp>
         <p:nvSpPr>
-          <p:cNvPr id="49" name="TextBox 48"/>
+          <p:cNvPr id="47" name="TextBox 46"/>
           <p:cNvSpPr txBox="1"/>
           <p:nvPr/>
         </p:nvSpPr>
@@ -24734,7 +24492,7 @@
             <a:r>
               <a:rPr sz="1600" b="1" i="0">
                 <a:solidFill>
-                  <a:srgbClr val="D5FB00"/>
+                  <a:srgbClr val="0033A0"/>
                 </a:solidFill>
                 <a:latin typeface="Segoe UI"/>
               </a:rPr>
@@ -24745,7 +24503,7 @@
       </p:sp>
       <p:sp>
         <p:nvSpPr>
-          <p:cNvPr id="50" name="Chevron 49"/>
+          <p:cNvPr id="48" name="Chevron 47"/>
           <p:cNvSpPr/>
           <p:nvPr/>
         </p:nvSpPr>
@@ -24758,7 +24516,7 @@
             <a:avLst/>
           </a:prstGeom>
           <a:solidFill>
-            <a:srgbClr val="D5FB00"/>
+            <a:srgbClr val="0033A0"/>
           </a:solidFill>
           <a:ln>
             <a:noFill/>
@@ -24774,7 +24532,7 @@
       </p:sp>
       <p:sp>
         <p:nvSpPr>
-          <p:cNvPr id="51" name="TextBox 50"/>
+          <p:cNvPr id="49" name="TextBox 48"/>
           <p:cNvSpPr txBox="1"/>
           <p:nvPr/>
         </p:nvSpPr>
@@ -24805,7 +24563,7 @@
             <a:r>
               <a:rPr sz="1400" b="0" i="0">
                 <a:solidFill>
-                  <a:srgbClr val="FFFFFF"/>
+                  <a:srgbClr val="051C2C"/>
                 </a:solidFill>
                 <a:latin typeface="Segoe UI"/>
               </a:rPr>
@@ -24816,7 +24574,7 @@
       </p:sp>
       <p:sp>
         <p:nvSpPr>
-          <p:cNvPr id="52" name="Chevron 51"/>
+          <p:cNvPr id="50" name="Chevron 49"/>
           <p:cNvSpPr/>
           <p:nvPr/>
         </p:nvSpPr>
@@ -24829,7 +24587,7 @@
             <a:avLst/>
           </a:prstGeom>
           <a:solidFill>
-            <a:srgbClr val="D5FB00"/>
+            <a:srgbClr val="0033A0"/>
           </a:solidFill>
           <a:ln>
             <a:noFill/>
@@ -24845,7 +24603,7 @@
       </p:sp>
       <p:sp>
         <p:nvSpPr>
-          <p:cNvPr id="53" name="TextBox 52"/>
+          <p:cNvPr id="51" name="TextBox 50"/>
           <p:cNvSpPr txBox="1"/>
           <p:nvPr/>
         </p:nvSpPr>
@@ -24876,7 +24634,7 @@
             <a:r>
               <a:rPr sz="1400" b="0" i="0">
                 <a:solidFill>
-                  <a:srgbClr val="FFFFFF"/>
+                  <a:srgbClr val="051C2C"/>
                 </a:solidFill>
                 <a:latin typeface="Segoe UI"/>
               </a:rPr>
@@ -24887,7 +24645,7 @@
       </p:sp>
       <p:sp>
         <p:nvSpPr>
-          <p:cNvPr id="54" name="Chevron 53"/>
+          <p:cNvPr id="52" name="Chevron 51"/>
           <p:cNvSpPr/>
           <p:nvPr/>
         </p:nvSpPr>
@@ -24900,7 +24658,7 @@
             <a:avLst/>
           </a:prstGeom>
           <a:solidFill>
-            <a:srgbClr val="D5FB00"/>
+            <a:srgbClr val="0033A0"/>
           </a:solidFill>
           <a:ln>
             <a:noFill/>
@@ -24916,7 +24674,7 @@
       </p:sp>
       <p:sp>
         <p:nvSpPr>
-          <p:cNvPr id="55" name="TextBox 54"/>
+          <p:cNvPr id="53" name="TextBox 52"/>
           <p:cNvSpPr txBox="1"/>
           <p:nvPr/>
         </p:nvSpPr>
@@ -24947,7 +24705,7 @@
             <a:r>
               <a:rPr sz="1400" b="0" i="0">
                 <a:solidFill>
-                  <a:srgbClr val="FFFFFF"/>
+                  <a:srgbClr val="051C2C"/>
                 </a:solidFill>
                 <a:latin typeface="Segoe UI"/>
               </a:rPr>
@@ -24958,7 +24716,7 @@
       </p:sp>
       <p:sp>
         <p:nvSpPr>
-          <p:cNvPr id="56" name="Chevron 55"/>
+          <p:cNvPr id="54" name="Chevron 53"/>
           <p:cNvSpPr/>
           <p:nvPr/>
         </p:nvSpPr>
@@ -24971,7 +24729,7 @@
             <a:avLst/>
           </a:prstGeom>
           <a:solidFill>
-            <a:srgbClr val="D5FB00"/>
+            <a:srgbClr val="0033A0"/>
           </a:solidFill>
           <a:ln>
             <a:noFill/>
@@ -24987,7 +24745,7 @@
       </p:sp>
       <p:sp>
         <p:nvSpPr>
-          <p:cNvPr id="57" name="TextBox 56"/>
+          <p:cNvPr id="55" name="TextBox 54"/>
           <p:cNvSpPr txBox="1"/>
           <p:nvPr/>
         </p:nvSpPr>
@@ -25018,7 +24776,7 @@
             <a:r>
               <a:rPr sz="1400" b="0" i="0">
                 <a:solidFill>
-                  <a:srgbClr val="FFFFFF"/>
+                  <a:srgbClr val="051C2C"/>
                 </a:solidFill>
                 <a:latin typeface="Segoe UI"/>
               </a:rPr>
@@ -25029,7 +24787,7 @@
       </p:sp>
       <p:sp>
         <p:nvSpPr>
-          <p:cNvPr id="58" name="TextBox 57"/>
+          <p:cNvPr id="56" name="TextBox 55"/>
           <p:cNvSpPr txBox="1"/>
           <p:nvPr/>
         </p:nvSpPr>
@@ -25060,7 +24818,7 @@
             <a:r>
               <a:rPr sz="1200" b="1" i="0">
                 <a:solidFill>
-                  <a:srgbClr val="D5FB00"/>
+                  <a:srgbClr val="0033A0"/>
                 </a:solidFill>
                 <a:latin typeface="Segoe UI"/>
               </a:rPr>
@@ -25746,7 +25504,7 @@
             <a:r>
               <a:rPr sz="2800" b="1">
                 <a:solidFill>
-                  <a:srgbClr val="FFFFFF"/>
+                  <a:srgbClr val="051C2C"/>
                 </a:solidFill>
                 <a:latin typeface="Segoe UI"/>
               </a:rPr>
@@ -25773,7 +25531,7 @@
             <a:r>
               <a:rPr sz="1300" b="0">
                 <a:solidFill>
-                  <a:srgbClr val="D5FB00"/>
+                  <a:srgbClr val="0033A0"/>
                 </a:solidFill>
                 <a:latin typeface="Segoe UI"/>
               </a:rPr>
@@ -25782,22 +25540,12 @@
           </a:p>
         </p:txBody>
       </p:sp>
-      <p:pic>
-        <p:nvPicPr>
-          <p:cNvPr id="4" name="!! Glass A" descr="Decorative glass panel"/>
-          <p:cNvPicPr>
-            <a:picLocks noChangeAspect="1"/>
-          </p:cNvPicPr>
+      <p:sp>
+        <p:nvSpPr>
+          <p:cNvPr id="4" name="!! Glass A"/>
+          <p:cNvSpPr/>
           <p:nvPr/>
-        </p:nvPicPr>
-        <p:blipFill>
-          <a:blip r:embed="rId2">
-            <a:alphaModFix amt="50000"/>
-          </a:blip>
-          <a:stretch>
-            <a:fillRect/>
-          </a:stretch>
-        </p:blipFill>
+        </p:nvSpPr>
         <p:spPr>
           <a:xfrm>
             <a:off x="256032" y="1600200"/>
@@ -25806,27 +25554,15 @@
           <a:prstGeom prst="rect">
             <a:avLst/>
           </a:prstGeom>
-        </p:spPr>
-      </p:pic>
-      <p:sp>
-        <p:nvSpPr>
-          <p:cNvPr id="5" name="!! Glass A rim"/>
-          <p:cNvSpPr/>
-          <p:nvPr/>
-        </p:nvSpPr>
-        <p:spPr>
-          <a:xfrm>
-            <a:off x="256032" y="1600200"/>
-            <a:ext cx="5806440" cy="3886200"/>
-          </a:xfrm>
-          <a:prstGeom prst="rect">
-            <a:avLst/>
-          </a:prstGeom>
-          <a:noFill/>
+          <a:solidFill>
+            <a:srgbClr val="051C2C">
+              <a:alpha val="4000"/>
+            </a:srgbClr>
+          </a:solidFill>
           <a:ln w="9525">
             <a:solidFill>
-              <a:srgbClr val="FFFFFF">
-                <a:alpha val="16000"/>
+              <a:srgbClr val="051C2C">
+                <a:alpha val="12000"/>
               </a:srgbClr>
             </a:solidFill>
           </a:ln>
@@ -25841,7 +25577,7 @@
       </p:sp>
       <p:sp>
         <p:nvSpPr>
-          <p:cNvPr id="6" name="TextBox 5"/>
+          <p:cNvPr id="5" name="TextBox 4"/>
           <p:cNvSpPr txBox="1"/>
           <p:nvPr/>
         </p:nvSpPr>
@@ -25872,7 +25608,7 @@
             <a:r>
               <a:rPr sz="1600" b="1" i="0">
                 <a:solidFill>
-                  <a:srgbClr val="D5FB00"/>
+                  <a:srgbClr val="0033A0"/>
                 </a:solidFill>
                 <a:latin typeface="Segoe UI"/>
               </a:rPr>
@@ -25883,7 +25619,7 @@
       </p:sp>
       <p:sp>
         <p:nvSpPr>
-          <p:cNvPr id="7" name="TextBox 6"/>
+          <p:cNvPr id="6" name="TextBox 5"/>
           <p:cNvSpPr txBox="1"/>
           <p:nvPr/>
         </p:nvSpPr>
@@ -25917,7 +25653,7 @@
             <a:r>
               <a:rPr sz="1400" b="0" i="0">
                 <a:solidFill>
-                  <a:srgbClr val="FFFFFF"/>
+                  <a:srgbClr val="051C2C"/>
                 </a:solidFill>
                 <a:latin typeface="Segoe UI"/>
               </a:rPr>
@@ -25928,7 +25664,7 @@
       </p:sp>
       <p:sp>
         <p:nvSpPr>
-          <p:cNvPr id="8" name="TextBox 7"/>
+          <p:cNvPr id="7" name="TextBox 6"/>
           <p:cNvSpPr txBox="1"/>
           <p:nvPr/>
         </p:nvSpPr>
@@ -25959,7 +25695,7 @@
             <a:r>
               <a:rPr sz="1600" b="1" i="0">
                 <a:solidFill>
-                  <a:srgbClr val="D5FB00"/>
+                  <a:srgbClr val="0033A0"/>
                 </a:solidFill>
                 <a:latin typeface="Segoe UI"/>
               </a:rPr>
@@ -25970,7 +25706,7 @@
       </p:sp>
       <p:sp>
         <p:nvSpPr>
-          <p:cNvPr id="9" name="TextBox 8"/>
+          <p:cNvPr id="8" name="TextBox 7"/>
           <p:cNvSpPr txBox="1"/>
           <p:nvPr/>
         </p:nvSpPr>
@@ -26004,7 +25740,7 @@
             <a:r>
               <a:rPr sz="1400" b="0" i="0">
                 <a:solidFill>
-                  <a:srgbClr val="FFFFFF"/>
+                  <a:srgbClr val="051C2C"/>
                 </a:solidFill>
                 <a:latin typeface="Segoe UI"/>
               </a:rPr>
@@ -26015,7 +25751,7 @@
       </p:sp>
       <p:sp>
         <p:nvSpPr>
-          <p:cNvPr id="10" name="Rectangle 9"/>
+          <p:cNvPr id="9" name="Rectangle 8"/>
           <p:cNvSpPr/>
           <p:nvPr/>
         </p:nvSpPr>
@@ -26028,7 +25764,7 @@
             <a:avLst/>
           </a:prstGeom>
           <a:solidFill>
-            <a:srgbClr val="D5FB00"/>
+            <a:srgbClr val="0033A0"/>
           </a:solidFill>
           <a:ln>
             <a:noFill/>
@@ -26044,7 +25780,7 @@
       </p:sp>
       <p:sp>
         <p:nvSpPr>
-          <p:cNvPr id="11" name="TextBox 10"/>
+          <p:cNvPr id="10" name="TextBox 9"/>
           <p:cNvSpPr txBox="1"/>
           <p:nvPr/>
         </p:nvSpPr>
@@ -26075,7 +25811,7 @@
             <a:r>
               <a:rPr sz="1600" b="1" i="0">
                 <a:solidFill>
-                  <a:srgbClr val="D5FB00"/>
+                  <a:srgbClr val="0033A0"/>
                 </a:solidFill>
                 <a:latin typeface="Segoe UI"/>
               </a:rPr>
@@ -26086,7 +25822,7 @@
       </p:sp>
       <p:sp>
         <p:nvSpPr>
-          <p:cNvPr id="12" name="TextBox 11"/>
+          <p:cNvPr id="11" name="TextBox 10"/>
           <p:cNvSpPr txBox="1"/>
           <p:nvPr/>
         </p:nvSpPr>
@@ -26120,7 +25856,7 @@
             <a:r>
               <a:rPr sz="1400" b="1" i="0">
                 <a:solidFill>
-                  <a:srgbClr val="D5FB00"/>
+                  <a:srgbClr val="0033A0"/>
                 </a:solidFill>
                 <a:latin typeface="Segoe UI"/>
               </a:rPr>
@@ -26129,22 +25865,12 @@
           </a:p>
         </p:txBody>
       </p:sp>
-      <p:pic>
-        <p:nvPicPr>
-          <p:cNvPr id="13" name="!! Glass B" descr="Decorative glass panel"/>
-          <p:cNvPicPr>
-            <a:picLocks noChangeAspect="1"/>
-          </p:cNvPicPr>
+      <p:sp>
+        <p:nvSpPr>
+          <p:cNvPr id="12" name="!! Glass B"/>
+          <p:cNvSpPr/>
           <p:nvPr/>
-        </p:nvPicPr>
-        <p:blipFill>
-          <a:blip r:embed="rId3">
-            <a:alphaModFix amt="50000"/>
-          </a:blip>
-          <a:stretch>
-            <a:fillRect/>
-          </a:stretch>
-        </p:blipFill>
+        </p:nvSpPr>
         <p:spPr>
           <a:xfrm>
             <a:off x="6382512" y="1600200"/>
@@ -26153,18 +25879,37 @@
           <a:prstGeom prst="rect">
             <a:avLst/>
           </a:prstGeom>
-        </p:spPr>
-      </p:pic>
-      <p:sp>
-        <p:nvSpPr>
-          <p:cNvPr id="14" name="!! Glass B rim"/>
+          <a:solidFill>
+            <a:srgbClr val="051C2C">
+              <a:alpha val="4000"/>
+            </a:srgbClr>
+          </a:solidFill>
+          <a:ln w="9525">
+            <a:solidFill>
+              <a:srgbClr val="051C2C">
+                <a:alpha val="12000"/>
+              </a:srgbClr>
+            </a:solidFill>
+          </a:ln>
+        </p:spPr>
+        <p:txBody>
+          <a:bodyPr rtlCol="0" anchor="ctr" wrap="square" lIns="0" rIns="0" tIns="0" bIns="0"/>
+          <a:lstStyle/>
+          <a:p>
+            <a:pPr algn="ctr"/>
+          </a:p>
+        </p:txBody>
+      </p:sp>
+      <p:sp>
+        <p:nvSpPr>
+          <p:cNvPr id="13" name="Rectangle 12"/>
           <p:cNvSpPr/>
           <p:nvPr/>
         </p:nvSpPr>
         <p:spPr>
           <a:xfrm>
-            <a:off x="6382512" y="1600200"/>
-            <a:ext cx="5550408" cy="1847088"/>
+            <a:off x="6547104" y="1764792"/>
+            <a:ext cx="5221224" cy="1517904"/>
           </a:xfrm>
           <a:prstGeom prst="rect">
             <a:avLst/>
@@ -26172,38 +25917,7 @@
           <a:noFill/>
           <a:ln w="9525">
             <a:solidFill>
-              <a:srgbClr val="FFFFFF">
-                <a:alpha val="16000"/>
-              </a:srgbClr>
-            </a:solidFill>
-          </a:ln>
-        </p:spPr>
-        <p:txBody>
-          <a:bodyPr rtlCol="0" anchor="ctr" wrap="square" lIns="0" rIns="0" tIns="0" bIns="0"/>
-          <a:lstStyle/>
-          <a:p>
-            <a:pPr algn="ctr"/>
-          </a:p>
-        </p:txBody>
-      </p:sp>
-      <p:sp>
-        <p:nvSpPr>
-          <p:cNvPr id="15" name="Rectangle 14"/>
-          <p:cNvSpPr/>
-          <p:nvPr/>
-        </p:nvSpPr>
-        <p:spPr>
-          <a:xfrm>
-            <a:off x="6547104" y="1764792"/>
-            <a:ext cx="5221224" cy="1517904"/>
-          </a:xfrm>
-          <a:prstGeom prst="rect">
-            <a:avLst/>
-          </a:prstGeom>
-          <a:noFill/>
-          <a:ln w="9525">
-            <a:solidFill>
-              <a:srgbClr val="C6CDD1">
+              <a:srgbClr val="6B7A83">
                 <a:alpha val="35000"/>
               </a:srgbClr>
             </a:solidFill>
@@ -26219,7 +25933,7 @@
       </p:sp>
       <p:sp>
         <p:nvSpPr>
-          <p:cNvPr id="16" name="TextBox 15"/>
+          <p:cNvPr id="14" name="TextBox 13"/>
           <p:cNvSpPr txBox="1"/>
           <p:nvPr/>
         </p:nvSpPr>
@@ -26250,7 +25964,7 @@
             <a:r>
               <a:rPr sz="1100" b="1" i="0">
                 <a:solidFill>
-                  <a:srgbClr val="D5FB00"/>
+                  <a:srgbClr val="0033A0"/>
                 </a:solidFill>
                 <a:latin typeface="Segoe UI"/>
               </a:rPr>
@@ -26269,7 +25983,7 @@
             <a:r>
               <a:rPr sz="1200" b="0" i="0">
                 <a:solidFill>
-                  <a:srgbClr val="C6CDD1"/>
+                  <a:srgbClr val="6B7A83"/>
                 </a:solidFill>
                 <a:latin typeface="Segoe UI"/>
               </a:rPr>
@@ -26278,22 +25992,12 @@
           </a:p>
         </p:txBody>
       </p:sp>
-      <p:pic>
-        <p:nvPicPr>
-          <p:cNvPr id="17" name="!! Glass C" descr="Decorative glass panel"/>
-          <p:cNvPicPr>
-            <a:picLocks noChangeAspect="1"/>
-          </p:cNvPicPr>
+      <p:sp>
+        <p:nvSpPr>
+          <p:cNvPr id="15" name="!! Glass C"/>
+          <p:cNvSpPr/>
           <p:nvPr/>
-        </p:nvPicPr>
-        <p:blipFill>
-          <a:blip r:embed="rId4">
-            <a:alphaModFix amt="50000"/>
-          </a:blip>
-          <a:stretch>
-            <a:fillRect/>
-          </a:stretch>
-        </p:blipFill>
+        </p:nvSpPr>
         <p:spPr>
           <a:xfrm>
             <a:off x="6382512" y="3639312"/>
@@ -26302,18 +26006,37 @@
           <a:prstGeom prst="rect">
             <a:avLst/>
           </a:prstGeom>
-        </p:spPr>
-      </p:pic>
-      <p:sp>
-        <p:nvSpPr>
-          <p:cNvPr id="18" name="!! Glass C rim"/>
+          <a:solidFill>
+            <a:srgbClr val="051C2C">
+              <a:alpha val="4000"/>
+            </a:srgbClr>
+          </a:solidFill>
+          <a:ln w="9525">
+            <a:solidFill>
+              <a:srgbClr val="051C2C">
+                <a:alpha val="12000"/>
+              </a:srgbClr>
+            </a:solidFill>
+          </a:ln>
+        </p:spPr>
+        <p:txBody>
+          <a:bodyPr rtlCol="0" anchor="ctr" wrap="square" lIns="0" rIns="0" tIns="0" bIns="0"/>
+          <a:lstStyle/>
+          <a:p>
+            <a:pPr algn="ctr"/>
+          </a:p>
+        </p:txBody>
+      </p:sp>
+      <p:sp>
+        <p:nvSpPr>
+          <p:cNvPr id="16" name="Rectangle 15"/>
           <p:cNvSpPr/>
           <p:nvPr/>
         </p:nvSpPr>
         <p:spPr>
           <a:xfrm>
-            <a:off x="6382512" y="3639312"/>
-            <a:ext cx="5550408" cy="1847088"/>
+            <a:off x="6547104" y="3803904"/>
+            <a:ext cx="5221224" cy="1517904"/>
           </a:xfrm>
           <a:prstGeom prst="rect">
             <a:avLst/>
@@ -26321,38 +26044,7 @@
           <a:noFill/>
           <a:ln w="9525">
             <a:solidFill>
-              <a:srgbClr val="FFFFFF">
-                <a:alpha val="16000"/>
-              </a:srgbClr>
-            </a:solidFill>
-          </a:ln>
-        </p:spPr>
-        <p:txBody>
-          <a:bodyPr rtlCol="0" anchor="ctr" wrap="square" lIns="0" rIns="0" tIns="0" bIns="0"/>
-          <a:lstStyle/>
-          <a:p>
-            <a:pPr algn="ctr"/>
-          </a:p>
-        </p:txBody>
-      </p:sp>
-      <p:sp>
-        <p:nvSpPr>
-          <p:cNvPr id="19" name="Rectangle 18"/>
-          <p:cNvSpPr/>
-          <p:nvPr/>
-        </p:nvSpPr>
-        <p:spPr>
-          <a:xfrm>
-            <a:off x="6547104" y="3803904"/>
-            <a:ext cx="5221224" cy="1517904"/>
-          </a:xfrm>
-          <a:prstGeom prst="rect">
-            <a:avLst/>
-          </a:prstGeom>
-          <a:noFill/>
-          <a:ln w="9525">
-            <a:solidFill>
-              <a:srgbClr val="C6CDD1">
+              <a:srgbClr val="6B7A83">
                 <a:alpha val="35000"/>
               </a:srgbClr>
             </a:solidFill>
@@ -26368,7 +26060,7 @@
       </p:sp>
       <p:sp>
         <p:nvSpPr>
-          <p:cNvPr id="20" name="TextBox 19"/>
+          <p:cNvPr id="17" name="TextBox 16"/>
           <p:cNvSpPr txBox="1"/>
           <p:nvPr/>
         </p:nvSpPr>
@@ -26399,7 +26091,7 @@
             <a:r>
               <a:rPr sz="1100" b="1" i="0">
                 <a:solidFill>
-                  <a:srgbClr val="D5FB00"/>
+                  <a:srgbClr val="0033A0"/>
                 </a:solidFill>
                 <a:latin typeface="Segoe UI"/>
               </a:rPr>
@@ -26418,7 +26110,7 @@
             <a:r>
               <a:rPr sz="1200" b="0" i="0">
                 <a:solidFill>
-                  <a:srgbClr val="C6CDD1"/>
+                  <a:srgbClr val="6B7A83"/>
                 </a:solidFill>
                 <a:latin typeface="Segoe UI"/>
               </a:rPr>

</xml_diff>

<commit_message>
Make every glass panel a single shape so Morph can pair it
Morph only pairs objects of the same kind. The dark slides drew each panel
as a picture plus a separate rim, and the white slides as a rectangle, so
with the backgrounds alternating no panel ever had a partner. Each panel is
now one rectangle whose fill is the copied background (dark) or a tint
(white), and the outer cards on slides 4 and 11 reuse the panel names.

Co-Authored-By: Claude Opus 5.5 <noreply@anthropic.com>
Claude-Session: https://claude.ai/code/session_012Ye9scek5k3HGgfD9p6dky
</commit_message>
<xml_diff>
--- a/presentations/Tenneco_Robotics_Setter_Diego_de_Leon.pptx
+++ b/presentations/Tenneco_Robotics_Setter_Diego_de_Leon.pptx
@@ -15875,22 +15875,12 @@
           </a:p>
         </p:txBody>
       </p:sp>
-      <p:pic>
-        <p:nvPicPr>
-          <p:cNvPr id="4" name="!! Glass A" descr="Decorative glass panel"/>
-          <p:cNvPicPr>
-            <a:picLocks noChangeAspect="1"/>
-          </p:cNvPicPr>
+      <p:sp>
+        <p:nvSpPr>
+          <p:cNvPr id="4" name="!! Glass A"/>
+          <p:cNvSpPr/>
           <p:nvPr/>
-        </p:nvPicPr>
-        <p:blipFill>
-          <a:blip r:embed="rId2">
-            <a:alphaModFix amt="50000"/>
-          </a:blip>
-          <a:stretch>
-            <a:fillRect/>
-          </a:stretch>
-        </p:blipFill>
+        </p:nvSpPr>
         <p:spPr>
           <a:xfrm>
             <a:off x="256032" y="1600200"/>
@@ -15899,23 +15889,14 @@
           <a:prstGeom prst="rect">
             <a:avLst/>
           </a:prstGeom>
-        </p:spPr>
-      </p:pic>
-      <p:sp>
-        <p:nvSpPr>
-          <p:cNvPr id="5" name="!! Glass A rim"/>
-          <p:cNvSpPr/>
-          <p:nvPr/>
-        </p:nvSpPr>
-        <p:spPr>
-          <a:xfrm>
-            <a:off x="256032" y="1600200"/>
-            <a:ext cx="7543800" cy="3886200"/>
-          </a:xfrm>
-          <a:prstGeom prst="rect">
-            <a:avLst/>
-          </a:prstGeom>
-          <a:noFill/>
+          <a:blipFill rotWithShape="1">
+            <a:blip r:embed="rId2">
+              <a:alphaModFix amt="50000"/>
+            </a:blip>
+            <a:stretch>
+              <a:fillRect/>
+            </a:stretch>
+          </a:blipFill>
           <a:ln w="9525">
             <a:solidFill>
               <a:srgbClr val="FFFFFF">
@@ -15934,14 +15915,56 @@
       </p:sp>
       <p:sp>
         <p:nvSpPr>
+          <p:cNvPr id="5" name="TextBox 4"/>
+          <p:cNvSpPr txBox="1"/>
+          <p:nvPr/>
+        </p:nvSpPr>
+        <p:spPr>
+          <a:xfrm>
+            <a:off x="621792" y="1901952"/>
+            <a:ext cx="5486400" cy="274320"/>
+          </a:xfrm>
+          <a:prstGeom prst="rect">
+            <a:avLst/>
+          </a:prstGeom>
+          <a:noFill/>
+        </p:spPr>
+        <p:txBody>
+          <a:bodyPr wrap="square" lIns="0" rIns="0" tIns="0" bIns="0" anchor="t">
+            <a:spAutoFit/>
+          </a:bodyPr>
+          <a:lstStyle/>
+          <a:p>
+            <a:pPr algn="l">
+              <a:spcBef>
+                <a:spcPts val="0"/>
+              </a:spcBef>
+              <a:spcAft>
+                <a:spcPts val="0"/>
+              </a:spcAft>
+            </a:pPr>
+            <a:r>
+              <a:rPr sz="1600" b="1" i="0">
+                <a:solidFill>
+                  <a:srgbClr val="D5FB00"/>
+                </a:solidFill>
+                <a:latin typeface="Segoe UI"/>
+              </a:rPr>
+              <a:t>CYCLE TIME PER PART</a:t>
+            </a:r>
+          </a:p>
+        </p:txBody>
+      </p:sp>
+      <p:sp>
+        <p:nvSpPr>
           <p:cNvPr id="6" name="TextBox 5"/>
           <p:cNvSpPr txBox="1"/>
           <p:nvPr/>
         </p:nvSpPr>
         <p:spPr>
           <a:xfrm>
-            <a:off x="621792" y="1901952"/>
-            <a:ext cx="5486400" cy="274320"/>
+            <a:off x="621792" y="2395728"/>
+            <a:ext cx="3657600" cy="274320"/>
           </a:xfrm>
           <a:prstGeom prst="rect">
             <a:avLst/>
@@ -15963,48 +15986,6 @@
               </a:spcAft>
             </a:pPr>
             <a:r>
-              <a:rPr sz="1600" b="1" i="0">
-                <a:solidFill>
-                  <a:srgbClr val="D5FB00"/>
-                </a:solidFill>
-                <a:latin typeface="Segoe UI"/>
-              </a:rPr>
-              <a:t>CYCLE TIME PER PART</a:t>
-            </a:r>
-          </a:p>
-        </p:txBody>
-      </p:sp>
-      <p:sp>
-        <p:nvSpPr>
-          <p:cNvPr id="7" name="TextBox 6"/>
-          <p:cNvSpPr txBox="1"/>
-          <p:nvPr/>
-        </p:nvSpPr>
-        <p:spPr>
-          <a:xfrm>
-            <a:off x="621792" y="2395728"/>
-            <a:ext cx="3657600" cy="274320"/>
-          </a:xfrm>
-          <a:prstGeom prst="rect">
-            <a:avLst/>
-          </a:prstGeom>
-          <a:noFill/>
-        </p:spPr>
-        <p:txBody>
-          <a:bodyPr wrap="square" lIns="0" rIns="0" tIns="0" bIns="0" anchor="t">
-            <a:spAutoFit/>
-          </a:bodyPr>
-          <a:lstStyle/>
-          <a:p>
-            <a:pPr algn="l">
-              <a:spcBef>
-                <a:spcPts val="0"/>
-              </a:spcBef>
-              <a:spcAft>
-                <a:spcPts val="0"/>
-              </a:spcAft>
-            </a:pPr>
-            <a:r>
               <a:rPr sz="1400" b="1" i="0">
                 <a:solidFill>
                   <a:srgbClr val="FFFFFF"/>
@@ -16018,7 +15999,7 @@
       </p:sp>
       <p:sp>
         <p:nvSpPr>
-          <p:cNvPr id="8" name="Rectangle 7"/>
+          <p:cNvPr id="7" name="Rectangle 6"/>
           <p:cNvSpPr/>
           <p:nvPr/>
         </p:nvSpPr>
@@ -16065,7 +16046,7 @@
       </p:sp>
       <p:sp>
         <p:nvSpPr>
-          <p:cNvPr id="9" name="Rectangle 8"/>
+          <p:cNvPr id="8" name="Rectangle 7"/>
           <p:cNvSpPr/>
           <p:nvPr/>
         </p:nvSpPr>
@@ -16112,7 +16093,7 @@
       </p:sp>
       <p:sp>
         <p:nvSpPr>
-          <p:cNvPr id="10" name="Rectangle 9"/>
+          <p:cNvPr id="9" name="Rectangle 8"/>
           <p:cNvSpPr/>
           <p:nvPr/>
         </p:nvSpPr>
@@ -16159,14 +16140,56 @@
       </p:sp>
       <p:sp>
         <p:nvSpPr>
+          <p:cNvPr id="10" name="TextBox 9"/>
+          <p:cNvSpPr txBox="1"/>
+          <p:nvPr/>
+        </p:nvSpPr>
+        <p:spPr>
+          <a:xfrm>
+            <a:off x="6217920" y="2779776"/>
+            <a:ext cx="1188720" cy="365760"/>
+          </a:xfrm>
+          <a:prstGeom prst="rect">
+            <a:avLst/>
+          </a:prstGeom>
+          <a:noFill/>
+        </p:spPr>
+        <p:txBody>
+          <a:bodyPr wrap="square" lIns="0" rIns="0" tIns="0" bIns="0" anchor="t">
+            <a:spAutoFit/>
+          </a:bodyPr>
+          <a:lstStyle/>
+          <a:p>
+            <a:pPr algn="l">
+              <a:spcBef>
+                <a:spcPts val="0"/>
+              </a:spcBef>
+              <a:spcAft>
+                <a:spcPts val="0"/>
+              </a:spcAft>
+            </a:pPr>
+            <a:r>
+              <a:rPr sz="2000" b="1" i="0">
+                <a:solidFill>
+                  <a:srgbClr val="FFFFFF"/>
+                </a:solidFill>
+                <a:latin typeface="Segoe UI"/>
+              </a:rPr>
+              <a:t>174 s</a:t>
+            </a:r>
+          </a:p>
+        </p:txBody>
+      </p:sp>
+      <p:sp>
+        <p:nvSpPr>
           <p:cNvPr id="11" name="TextBox 10"/>
           <p:cNvSpPr txBox="1"/>
           <p:nvPr/>
         </p:nvSpPr>
         <p:spPr>
           <a:xfrm>
-            <a:off x="6217920" y="2779776"/>
-            <a:ext cx="1188720" cy="365760"/>
+            <a:off x="621792" y="3511296"/>
+            <a:ext cx="3657600" cy="274320"/>
           </a:xfrm>
           <a:prstGeom prst="rect">
             <a:avLst/>
@@ -16188,48 +16211,6 @@
               </a:spcAft>
             </a:pPr>
             <a:r>
-              <a:rPr sz="2000" b="1" i="0">
-                <a:solidFill>
-                  <a:srgbClr val="FFFFFF"/>
-                </a:solidFill>
-                <a:latin typeface="Segoe UI"/>
-              </a:rPr>
-              <a:t>174 s</a:t>
-            </a:r>
-          </a:p>
-        </p:txBody>
-      </p:sp>
-      <p:sp>
-        <p:nvSpPr>
-          <p:cNvPr id="12" name="TextBox 11"/>
-          <p:cNvSpPr txBox="1"/>
-          <p:nvPr/>
-        </p:nvSpPr>
-        <p:spPr>
-          <a:xfrm>
-            <a:off x="621792" y="3511296"/>
-            <a:ext cx="3657600" cy="274320"/>
-          </a:xfrm>
-          <a:prstGeom prst="rect">
-            <a:avLst/>
-          </a:prstGeom>
-          <a:noFill/>
-        </p:spPr>
-        <p:txBody>
-          <a:bodyPr wrap="square" lIns="0" rIns="0" tIns="0" bIns="0" anchor="t">
-            <a:spAutoFit/>
-          </a:bodyPr>
-          <a:lstStyle/>
-          <a:p>
-            <a:pPr algn="l">
-              <a:spcBef>
-                <a:spcPts val="0"/>
-              </a:spcBef>
-              <a:spcAft>
-                <a:spcPts val="0"/>
-              </a:spcAft>
-            </a:pPr>
-            <a:r>
               <a:rPr sz="1400" b="1" i="0">
                 <a:solidFill>
                   <a:srgbClr val="FFFFFF"/>
@@ -16243,7 +16224,7 @@
       </p:sp>
       <p:sp>
         <p:nvSpPr>
-          <p:cNvPr id="13" name="Rectangle 12"/>
+          <p:cNvPr id="12" name="Rectangle 11"/>
           <p:cNvSpPr/>
           <p:nvPr/>
         </p:nvSpPr>
@@ -16290,7 +16271,7 @@
       </p:sp>
       <p:sp>
         <p:nvSpPr>
-          <p:cNvPr id="14" name="Rectangle 13"/>
+          <p:cNvPr id="13" name="Rectangle 12"/>
           <p:cNvSpPr/>
           <p:nvPr/>
         </p:nvSpPr>
@@ -16335,7 +16316,7 @@
       </p:sp>
       <p:sp>
         <p:nvSpPr>
-          <p:cNvPr id="15" name="Rectangle 14"/>
+          <p:cNvPr id="14" name="Rectangle 13"/>
           <p:cNvSpPr/>
           <p:nvPr/>
         </p:nvSpPr>
@@ -16382,7 +16363,7 @@
       </p:sp>
       <p:sp>
         <p:nvSpPr>
-          <p:cNvPr id="16" name="TextBox 15"/>
+          <p:cNvPr id="15" name="TextBox 14"/>
           <p:cNvSpPr txBox="1"/>
           <p:nvPr/>
         </p:nvSpPr>
@@ -16424,7 +16405,7 @@
       </p:sp>
       <p:sp>
         <p:nvSpPr>
-          <p:cNvPr id="17" name="Rectangle 16"/>
+          <p:cNvPr id="16" name="Rectangle 15"/>
           <p:cNvSpPr/>
           <p:nvPr/>
         </p:nvSpPr>
@@ -16455,7 +16436,7 @@
       </p:sp>
       <p:sp>
         <p:nvSpPr>
-          <p:cNvPr id="18" name="TextBox 17"/>
+          <p:cNvPr id="17" name="TextBox 16"/>
           <p:cNvSpPr txBox="1"/>
           <p:nvPr/>
         </p:nvSpPr>
@@ -16497,7 +16478,7 @@
       </p:sp>
       <p:sp>
         <p:nvSpPr>
-          <p:cNvPr id="19" name="Rectangle 18"/>
+          <p:cNvPr id="18" name="Rectangle 17"/>
           <p:cNvSpPr/>
           <p:nvPr/>
         </p:nvSpPr>
@@ -16528,7 +16509,7 @@
       </p:sp>
       <p:sp>
         <p:nvSpPr>
-          <p:cNvPr id="20" name="TextBox 19"/>
+          <p:cNvPr id="19" name="TextBox 18"/>
           <p:cNvSpPr txBox="1"/>
           <p:nvPr/>
         </p:nvSpPr>
@@ -16570,7 +16551,7 @@
       </p:sp>
       <p:sp>
         <p:nvSpPr>
-          <p:cNvPr id="21" name="Rectangle 20"/>
+          <p:cNvPr id="20" name="Rectangle 19"/>
           <p:cNvSpPr/>
           <p:nvPr/>
         </p:nvSpPr>
@@ -16599,14 +16580,56 @@
       </p:sp>
       <p:sp>
         <p:nvSpPr>
+          <p:cNvPr id="21" name="TextBox 20"/>
+          <p:cNvSpPr txBox="1"/>
+          <p:nvPr/>
+        </p:nvSpPr>
+        <p:spPr>
+          <a:xfrm>
+            <a:off x="4718304" y="4654296"/>
+            <a:ext cx="1645920" cy="228600"/>
+          </a:xfrm>
+          <a:prstGeom prst="rect">
+            <a:avLst/>
+          </a:prstGeom>
+          <a:noFill/>
+        </p:spPr>
+        <p:txBody>
+          <a:bodyPr wrap="square" lIns="0" rIns="0" tIns="0" bIns="0" anchor="t">
+            <a:spAutoFit/>
+          </a:bodyPr>
+          <a:lstStyle/>
+          <a:p>
+            <a:pPr algn="l">
+              <a:spcBef>
+                <a:spcPts val="0"/>
+              </a:spcBef>
+              <a:spcAft>
+                <a:spcPts val="0"/>
+              </a:spcAft>
+            </a:pPr>
+            <a:r>
+              <a:rPr sz="1100" b="0" i="0">
+                <a:solidFill>
+                  <a:srgbClr val="C6CDD1"/>
+                </a:solidFill>
+                <a:latin typeface="Segoe UI"/>
+              </a:rPr>
+              <a:t>Welding by robot</a:t>
+            </a:r>
+          </a:p>
+        </p:txBody>
+      </p:sp>
+      <p:sp>
+        <p:nvSpPr>
           <p:cNvPr id="22" name="TextBox 21"/>
           <p:cNvSpPr txBox="1"/>
           <p:nvPr/>
         </p:nvSpPr>
         <p:spPr>
           <a:xfrm>
-            <a:off x="4718304" y="4654296"/>
-            <a:ext cx="1645920" cy="228600"/>
+            <a:off x="621792" y="5010912"/>
+            <a:ext cx="6858000" cy="274320"/>
           </a:xfrm>
           <a:prstGeom prst="rect">
             <a:avLst/>
@@ -16630,48 +16653,6 @@
             <a:r>
               <a:rPr sz="1100" b="0" i="0">
                 <a:solidFill>
-                  <a:srgbClr val="C6CDD1"/>
-                </a:solidFill>
-                <a:latin typeface="Segoe UI"/>
-              </a:rPr>
-              <a:t>Welding by robot</a:t>
-            </a:r>
-          </a:p>
-        </p:txBody>
-      </p:sp>
-      <p:sp>
-        <p:nvSpPr>
-          <p:cNvPr id="23" name="TextBox 22"/>
-          <p:cNvSpPr txBox="1"/>
-          <p:nvPr/>
-        </p:nvSpPr>
-        <p:spPr>
-          <a:xfrm>
-            <a:off x="621792" y="5010912"/>
-            <a:ext cx="6858000" cy="274320"/>
-          </a:xfrm>
-          <a:prstGeom prst="rect">
-            <a:avLst/>
-          </a:prstGeom>
-          <a:noFill/>
-        </p:spPr>
-        <p:txBody>
-          <a:bodyPr wrap="square" lIns="0" rIns="0" tIns="0" bIns="0" anchor="t">
-            <a:spAutoFit/>
-          </a:bodyPr>
-          <a:lstStyle/>
-          <a:p>
-            <a:pPr algn="l">
-              <a:spcBef>
-                <a:spcPts val="0"/>
-              </a:spcBef>
-              <a:spcAft>
-                <a:spcPts val="0"/>
-              </a:spcAft>
-            </a:pPr>
-            <a:r>
-              <a:rPr sz="1100" b="0" i="0">
-                <a:solidFill>
                   <a:srgbClr val="8A9BA8"/>
                 </a:solidFill>
                 <a:latin typeface="Segoe UI"/>
@@ -16681,22 +16662,12 @@
           </a:p>
         </p:txBody>
       </p:sp>
-      <p:pic>
-        <p:nvPicPr>
-          <p:cNvPr id="24" name="!! Glass B" descr="Decorative glass panel"/>
-          <p:cNvPicPr>
-            <a:picLocks noChangeAspect="1"/>
-          </p:cNvPicPr>
+      <p:sp>
+        <p:nvSpPr>
+          <p:cNvPr id="23" name="!! Glass B"/>
+          <p:cNvSpPr/>
           <p:nvPr/>
-        </p:nvPicPr>
-        <p:blipFill>
-          <a:blip r:embed="rId3">
-            <a:alphaModFix amt="50000"/>
-          </a:blip>
-          <a:stretch>
-            <a:fillRect/>
-          </a:stretch>
-        </p:blipFill>
+        </p:nvSpPr>
         <p:spPr>
           <a:xfrm>
             <a:off x="8092440" y="1600200"/>
@@ -16705,23 +16676,14 @@
           <a:prstGeom prst="rect">
             <a:avLst/>
           </a:prstGeom>
-        </p:spPr>
-      </p:pic>
-      <p:sp>
-        <p:nvSpPr>
-          <p:cNvPr id="25" name="!! Glass B rim"/>
-          <p:cNvSpPr/>
-          <p:nvPr/>
-        </p:nvSpPr>
-        <p:spPr>
-          <a:xfrm>
-            <a:off x="8092440" y="1600200"/>
-            <a:ext cx="3840480" cy="3886200"/>
-          </a:xfrm>
-          <a:prstGeom prst="rect">
-            <a:avLst/>
-          </a:prstGeom>
-          <a:noFill/>
+          <a:blipFill rotWithShape="1">
+            <a:blip r:embed="rId3">
+              <a:alphaModFix amt="50000"/>
+            </a:blip>
+            <a:stretch>
+              <a:fillRect/>
+            </a:stretch>
+          </a:blipFill>
           <a:ln w="9525">
             <a:solidFill>
               <a:srgbClr val="FFFFFF">
@@ -16740,13 +16702,97 @@
       </p:sp>
       <p:sp>
         <p:nvSpPr>
+          <p:cNvPr id="24" name="TextBox 23"/>
+          <p:cNvSpPr txBox="1"/>
+          <p:nvPr/>
+        </p:nvSpPr>
+        <p:spPr>
+          <a:xfrm>
+            <a:off x="8458200" y="1847088"/>
+            <a:ext cx="3291840" cy="548640"/>
+          </a:xfrm>
+          <a:prstGeom prst="rect">
+            <a:avLst/>
+          </a:prstGeom>
+          <a:noFill/>
+        </p:spPr>
+        <p:txBody>
+          <a:bodyPr wrap="square" lIns="0" rIns="0" tIns="0" bIns="0" anchor="t">
+            <a:spAutoFit/>
+          </a:bodyPr>
+          <a:lstStyle/>
+          <a:p>
+            <a:pPr algn="l">
+              <a:spcBef>
+                <a:spcPts val="0"/>
+              </a:spcBef>
+              <a:spcAft>
+                <a:spcPts val="0"/>
+              </a:spcAft>
+            </a:pPr>
+            <a:r>
+              <a:rPr sz="3200" b="1" i="0">
+                <a:solidFill>
+                  <a:srgbClr val="D5FB00"/>
+                </a:solidFill>
+                <a:latin typeface="Segoe UI"/>
+              </a:rPr>
+              <a:t>−47%</a:t>
+            </a:r>
+          </a:p>
+        </p:txBody>
+      </p:sp>
+      <p:sp>
+        <p:nvSpPr>
+          <p:cNvPr id="25" name="TextBox 24"/>
+          <p:cNvSpPr txBox="1"/>
+          <p:nvPr/>
+        </p:nvSpPr>
+        <p:spPr>
+          <a:xfrm>
+            <a:off x="8458200" y="2450592"/>
+            <a:ext cx="3291840" cy="274320"/>
+          </a:xfrm>
+          <a:prstGeom prst="rect">
+            <a:avLst/>
+          </a:prstGeom>
+          <a:noFill/>
+        </p:spPr>
+        <p:txBody>
+          <a:bodyPr wrap="square" lIns="0" rIns="0" tIns="0" bIns="0" anchor="t">
+            <a:spAutoFit/>
+          </a:bodyPr>
+          <a:lstStyle/>
+          <a:p>
+            <a:pPr algn="l">
+              <a:spcBef>
+                <a:spcPts val="0"/>
+              </a:spcBef>
+              <a:spcAft>
+                <a:spcPts val="0"/>
+              </a:spcAft>
+            </a:pPr>
+            <a:r>
+              <a:rPr sz="1200" b="0" i="0">
+                <a:solidFill>
+                  <a:srgbClr val="C6CDD1"/>
+                </a:solidFill>
+                <a:latin typeface="Segoe UI"/>
+              </a:rPr>
+              <a:t>cycle time, 174 s to 93 s</a:t>
+            </a:r>
+          </a:p>
+        </p:txBody>
+      </p:sp>
+      <p:sp>
+        <p:nvSpPr>
           <p:cNvPr id="26" name="TextBox 25"/>
           <p:cNvSpPr txBox="1"/>
           <p:nvPr/>
         </p:nvSpPr>
         <p:spPr>
           <a:xfrm>
-            <a:off x="8458200" y="1847088"/>
+            <a:off x="8458200" y="3035808"/>
             <a:ext cx="3291840" cy="548640"/>
           </a:xfrm>
           <a:prstGeom prst="rect">
@@ -16775,7 +16821,7 @@
                 </a:solidFill>
                 <a:latin typeface="Segoe UI"/>
               </a:rPr>
-              <a:t>−47%</a:t>
+              <a:t>−56%</a:t>
             </a:r>
           </a:p>
         </p:txBody>
@@ -16788,7 +16834,7 @@
         </p:nvSpPr>
         <p:spPr>
           <a:xfrm>
-            <a:off x="8458200" y="2450592"/>
+            <a:off x="8458200" y="3639312"/>
             <a:ext cx="3291840" cy="274320"/>
           </a:xfrm>
           <a:prstGeom prst="rect">
@@ -16817,7 +16863,7 @@
                 </a:solidFill>
                 <a:latin typeface="Segoe UI"/>
               </a:rPr>
-              <a:t>cycle time, 174 s to 93 s</a:t>
+              <a:t>welding time, 146 s to 65 s</a:t>
             </a:r>
           </a:p>
         </p:txBody>
@@ -16830,7 +16876,7 @@
         </p:nvSpPr>
         <p:spPr>
           <a:xfrm>
-            <a:off x="8458200" y="3035808"/>
+            <a:off x="8458200" y="4224528"/>
             <a:ext cx="3291840" cy="548640"/>
           </a:xfrm>
           <a:prstGeom prst="rect">
@@ -16859,7 +16905,7 @@
                 </a:solidFill>
                 <a:latin typeface="Segoe UI"/>
               </a:rPr>
-              <a:t>−56%</a:t>
+              <a:t>81 s</a:t>
             </a:r>
           </a:p>
         </p:txBody>
@@ -16867,90 +16913,6 @@
       <p:sp>
         <p:nvSpPr>
           <p:cNvPr id="29" name="TextBox 28"/>
-          <p:cNvSpPr txBox="1"/>
-          <p:nvPr/>
-        </p:nvSpPr>
-        <p:spPr>
-          <a:xfrm>
-            <a:off x="8458200" y="3639312"/>
-            <a:ext cx="3291840" cy="274320"/>
-          </a:xfrm>
-          <a:prstGeom prst="rect">
-            <a:avLst/>
-          </a:prstGeom>
-          <a:noFill/>
-        </p:spPr>
-        <p:txBody>
-          <a:bodyPr wrap="square" lIns="0" rIns="0" tIns="0" bIns="0" anchor="t">
-            <a:spAutoFit/>
-          </a:bodyPr>
-          <a:lstStyle/>
-          <a:p>
-            <a:pPr algn="l">
-              <a:spcBef>
-                <a:spcPts val="0"/>
-              </a:spcBef>
-              <a:spcAft>
-                <a:spcPts val="0"/>
-              </a:spcAft>
-            </a:pPr>
-            <a:r>
-              <a:rPr sz="1200" b="0" i="0">
-                <a:solidFill>
-                  <a:srgbClr val="C6CDD1"/>
-                </a:solidFill>
-                <a:latin typeface="Segoe UI"/>
-              </a:rPr>
-              <a:t>welding time, 146 s to 65 s</a:t>
-            </a:r>
-          </a:p>
-        </p:txBody>
-      </p:sp>
-      <p:sp>
-        <p:nvSpPr>
-          <p:cNvPr id="30" name="TextBox 29"/>
-          <p:cNvSpPr txBox="1"/>
-          <p:nvPr/>
-        </p:nvSpPr>
-        <p:spPr>
-          <a:xfrm>
-            <a:off x="8458200" y="4224528"/>
-            <a:ext cx="3291840" cy="548640"/>
-          </a:xfrm>
-          <a:prstGeom prst="rect">
-            <a:avLst/>
-          </a:prstGeom>
-          <a:noFill/>
-        </p:spPr>
-        <p:txBody>
-          <a:bodyPr wrap="square" lIns="0" rIns="0" tIns="0" bIns="0" anchor="t">
-            <a:spAutoFit/>
-          </a:bodyPr>
-          <a:lstStyle/>
-          <a:p>
-            <a:pPr algn="l">
-              <a:spcBef>
-                <a:spcPts val="0"/>
-              </a:spcBef>
-              <a:spcAft>
-                <a:spcPts val="0"/>
-              </a:spcAft>
-            </a:pPr>
-            <a:r>
-              <a:rPr sz="3200" b="1" i="0">
-                <a:solidFill>
-                  <a:srgbClr val="D5FB00"/>
-                </a:solidFill>
-                <a:latin typeface="Segoe UI"/>
-              </a:rPr>
-              <a:t>81 s</a:t>
-            </a:r>
-          </a:p>
-        </p:txBody>
-      </p:sp>
-      <p:sp>
-        <p:nvSpPr>
-          <p:cNvPr id="31" name="TextBox 30"/>
           <p:cNvSpPr txBox="1"/>
           <p:nvPr/>
         </p:nvSpPr>
@@ -17076,7 +17038,7 @@
       </p:sp>
       <p:sp>
         <p:nvSpPr>
-          <p:cNvPr id="4" name="!! Card 1"/>
+          <p:cNvPr id="4" name="!! Glass A"/>
           <p:cNvSpPr/>
           <p:nvPr/>
         </p:nvSpPr>
@@ -17404,7 +17366,7 @@
       </p:sp>
       <p:sp>
         <p:nvSpPr>
-          <p:cNvPr id="12" name="!! Card 3"/>
+          <p:cNvPr id="12" name="!! Glass B"/>
           <p:cNvSpPr/>
           <p:nvPr/>
         </p:nvSpPr>
@@ -17769,22 +17731,12 @@
           </a:p>
         </p:txBody>
       </p:sp>
-      <p:pic>
-        <p:nvPicPr>
-          <p:cNvPr id="4" name="!! Glass A" descr="Decorative glass panel"/>
-          <p:cNvPicPr>
-            <a:picLocks noChangeAspect="1"/>
-          </p:cNvPicPr>
+      <p:sp>
+        <p:nvSpPr>
+          <p:cNvPr id="4" name="!! Glass A"/>
+          <p:cNvSpPr/>
           <p:nvPr/>
-        </p:nvPicPr>
-        <p:blipFill>
-          <a:blip r:embed="rId2">
-            <a:alphaModFix amt="50000"/>
-          </a:blip>
-          <a:stretch>
-            <a:fillRect/>
-          </a:stretch>
-        </p:blipFill>
+        </p:nvSpPr>
         <p:spPr>
           <a:xfrm>
             <a:off x="256032" y="1600200"/>
@@ -17793,23 +17745,14 @@
           <a:prstGeom prst="rect">
             <a:avLst/>
           </a:prstGeom>
-        </p:spPr>
-      </p:pic>
-      <p:sp>
-        <p:nvSpPr>
-          <p:cNvPr id="5" name="!! Glass A rim"/>
-          <p:cNvSpPr/>
-          <p:nvPr/>
-        </p:nvSpPr>
-        <p:spPr>
-          <a:xfrm>
-            <a:off x="256032" y="1600200"/>
-            <a:ext cx="7223760" cy="3886200"/>
-          </a:xfrm>
-          <a:prstGeom prst="rect">
-            <a:avLst/>
-          </a:prstGeom>
-          <a:noFill/>
+          <a:blipFill rotWithShape="1">
+            <a:blip r:embed="rId2">
+              <a:alphaModFix amt="50000"/>
+            </a:blip>
+            <a:stretch>
+              <a:fillRect/>
+            </a:stretch>
+          </a:blipFill>
           <a:ln w="9525">
             <a:solidFill>
               <a:srgbClr val="FFFFFF">
@@ -17828,14 +17771,56 @@
       </p:sp>
       <p:sp>
         <p:nvSpPr>
+          <p:cNvPr id="5" name="TextBox 4"/>
+          <p:cNvSpPr txBox="1"/>
+          <p:nvPr/>
+        </p:nvSpPr>
+        <p:spPr>
+          <a:xfrm>
+            <a:off x="621792" y="1901952"/>
+            <a:ext cx="5486400" cy="274320"/>
+          </a:xfrm>
+          <a:prstGeom prst="rect">
+            <a:avLst/>
+          </a:prstGeom>
+          <a:noFill/>
+        </p:spPr>
+        <p:txBody>
+          <a:bodyPr wrap="square" lIns="0" rIns="0" tIns="0" bIns="0" anchor="t">
+            <a:spAutoFit/>
+          </a:bodyPr>
+          <a:lstStyle/>
+          <a:p>
+            <a:pPr algn="l">
+              <a:spcBef>
+                <a:spcPts val="0"/>
+              </a:spcBef>
+              <a:spcAft>
+                <a:spcPts val="0"/>
+              </a:spcAft>
+            </a:pPr>
+            <a:r>
+              <a:rPr sz="1600" b="1" i="0">
+                <a:solidFill>
+                  <a:srgbClr val="D5FB00"/>
+                </a:solidFill>
+                <a:latin typeface="Segoe UI"/>
+              </a:rPr>
+              <a:t>NEXT LEVELS</a:t>
+            </a:r>
+          </a:p>
+        </p:txBody>
+      </p:sp>
+      <p:sp>
+        <p:nvSpPr>
           <p:cNvPr id="6" name="TextBox 5"/>
           <p:cNvSpPr txBox="1"/>
           <p:nvPr/>
         </p:nvSpPr>
         <p:spPr>
           <a:xfrm>
-            <a:off x="621792" y="1901952"/>
-            <a:ext cx="5486400" cy="274320"/>
+            <a:off x="621792" y="2359152"/>
+            <a:ext cx="457200" cy="457200"/>
           </a:xfrm>
           <a:prstGeom prst="rect">
             <a:avLst/>
@@ -17857,13 +17842,13 @@
               </a:spcAft>
             </a:pPr>
             <a:r>
-              <a:rPr sz="1600" b="1" i="0">
+              <a:rPr sz="2400" b="1" i="0">
                 <a:solidFill>
                   <a:srgbClr val="D5FB00"/>
                 </a:solidFill>
                 <a:latin typeface="Segoe UI"/>
               </a:rPr>
-              <a:t>NEXT LEVELS</a:t>
+              <a:t>L</a:t>
             </a:r>
           </a:p>
         </p:txBody>
@@ -17876,8 +17861,8 @@
         </p:nvSpPr>
         <p:spPr>
           <a:xfrm>
-            <a:off x="621792" y="2359152"/>
-            <a:ext cx="457200" cy="457200"/>
+            <a:off x="1143000" y="2395728"/>
+            <a:ext cx="5943600" cy="320040"/>
           </a:xfrm>
           <a:prstGeom prst="rect">
             <a:avLst/>
@@ -17899,13 +17884,13 @@
               </a:spcAft>
             </a:pPr>
             <a:r>
-              <a:rPr sz="2400" b="1" i="0">
-                <a:solidFill>
-                  <a:srgbClr val="D5FB00"/>
+              <a:rPr sz="1400" b="0" i="0">
+                <a:solidFill>
+                  <a:srgbClr val="FFFFFF"/>
                 </a:solidFill>
                 <a:latin typeface="Segoe UI"/>
               </a:rPr>
-              <a:t>L</a:t>
+              <a:t>Validate settings and find defects at the cell, with support.</a:t>
             </a:r>
           </a:p>
         </p:txBody>
@@ -17918,8 +17903,8 @@
         </p:nvSpPr>
         <p:spPr>
           <a:xfrm>
-            <a:off x="1143000" y="2395728"/>
-            <a:ext cx="5943600" cy="320040"/>
+            <a:off x="1143000" y="2724912"/>
+            <a:ext cx="5943600" cy="274320"/>
           </a:xfrm>
           <a:prstGeom prst="rect">
             <a:avLst/>
@@ -17941,48 +17926,6 @@
               </a:spcAft>
             </a:pPr>
             <a:r>
-              <a:rPr sz="1400" b="0" i="0">
-                <a:solidFill>
-                  <a:srgbClr val="FFFFFF"/>
-                </a:solidFill>
-                <a:latin typeface="Segoe UI"/>
-              </a:rPr>
-              <a:t>Validate settings and find defects at the cell, with support.</a:t>
-            </a:r>
-          </a:p>
-        </p:txBody>
-      </p:sp>
-      <p:sp>
-        <p:nvSpPr>
-          <p:cNvPr id="9" name="TextBox 8"/>
-          <p:cNvSpPr txBox="1"/>
-          <p:nvPr/>
-        </p:nvSpPr>
-        <p:spPr>
-          <a:xfrm>
-            <a:off x="1143000" y="2724912"/>
-            <a:ext cx="5943600" cy="274320"/>
-          </a:xfrm>
-          <a:prstGeom prst="rect">
-            <a:avLst/>
-          </a:prstGeom>
-          <a:noFill/>
-        </p:spPr>
-        <p:txBody>
-          <a:bodyPr wrap="square" lIns="0" rIns="0" tIns="0" bIns="0" anchor="t">
-            <a:spAutoFit/>
-          </a:bodyPr>
-          <a:lstStyle/>
-          <a:p>
-            <a:pPr algn="l">
-              <a:spcBef>
-                <a:spcPts val="0"/>
-              </a:spcBef>
-              <a:spcAft>
-                <a:spcPts val="0"/>
-              </a:spcAft>
-            </a:pPr>
-            <a:r>
               <a:rPr sz="1200" b="0" i="0">
                 <a:solidFill>
                   <a:srgbClr val="C6CDD1"/>
@@ -17996,7 +17939,7 @@
       </p:sp>
       <p:sp>
         <p:nvSpPr>
-          <p:cNvPr id="10" name="Rectangle 9"/>
+          <p:cNvPr id="9" name="Rectangle 8"/>
           <p:cNvSpPr/>
           <p:nvPr/>
         </p:nvSpPr>
@@ -18027,14 +17970,56 @@
       </p:sp>
       <p:sp>
         <p:nvSpPr>
+          <p:cNvPr id="10" name="TextBox 9"/>
+          <p:cNvSpPr txBox="1"/>
+          <p:nvPr/>
+        </p:nvSpPr>
+        <p:spPr>
+          <a:xfrm>
+            <a:off x="621792" y="3319272"/>
+            <a:ext cx="457200" cy="457200"/>
+          </a:xfrm>
+          <a:prstGeom prst="rect">
+            <a:avLst/>
+          </a:prstGeom>
+          <a:noFill/>
+        </p:spPr>
+        <p:txBody>
+          <a:bodyPr wrap="square" lIns="0" rIns="0" tIns="0" bIns="0" anchor="t">
+            <a:spAutoFit/>
+          </a:bodyPr>
+          <a:lstStyle/>
+          <a:p>
+            <a:pPr algn="l">
+              <a:spcBef>
+                <a:spcPts val="0"/>
+              </a:spcBef>
+              <a:spcAft>
+                <a:spcPts val="0"/>
+              </a:spcAft>
+            </a:pPr>
+            <a:r>
+              <a:rPr sz="2400" b="1" i="0">
+                <a:solidFill>
+                  <a:srgbClr val="D5FB00"/>
+                </a:solidFill>
+                <a:latin typeface="Segoe UI"/>
+              </a:rPr>
+              <a:t>U</a:t>
+            </a:r>
+          </a:p>
+        </p:txBody>
+      </p:sp>
+      <p:sp>
+        <p:nvSpPr>
           <p:cNvPr id="11" name="TextBox 10"/>
           <p:cNvSpPr txBox="1"/>
           <p:nvPr/>
         </p:nvSpPr>
         <p:spPr>
           <a:xfrm>
-            <a:off x="621792" y="3319272"/>
-            <a:ext cx="457200" cy="457200"/>
+            <a:off x="1143000" y="3355848"/>
+            <a:ext cx="5943600" cy="320040"/>
           </a:xfrm>
           <a:prstGeom prst="rect">
             <a:avLst/>
@@ -18056,13 +18041,13 @@
               </a:spcAft>
             </a:pPr>
             <a:r>
-              <a:rPr sz="2400" b="1" i="0">
-                <a:solidFill>
-                  <a:srgbClr val="D5FB00"/>
+              <a:rPr sz="1400" b="0" i="0">
+                <a:solidFill>
+                  <a:srgbClr val="FFFFFF"/>
                 </a:solidFill>
                 <a:latin typeface="Segoe UI"/>
               </a:rPr>
-              <a:t>U</a:t>
+              <a:t>Create and set up robot programs on my own (SKS).</a:t>
             </a:r>
           </a:p>
         </p:txBody>
@@ -18075,8 +18060,8 @@
         </p:nvSpPr>
         <p:spPr>
           <a:xfrm>
-            <a:off x="1143000" y="3355848"/>
-            <a:ext cx="5943600" cy="320040"/>
+            <a:off x="1143000" y="3685032"/>
+            <a:ext cx="5943600" cy="274320"/>
           </a:xfrm>
           <a:prstGeom prst="rect">
             <a:avLst/>
@@ -18098,48 +18083,6 @@
               </a:spcAft>
             </a:pPr>
             <a:r>
-              <a:rPr sz="1400" b="0" i="0">
-                <a:solidFill>
-                  <a:srgbClr val="FFFFFF"/>
-                </a:solidFill>
-                <a:latin typeface="Segoe UI"/>
-              </a:rPr>
-              <a:t>Create and set up robot programs on my own (SKS).</a:t>
-            </a:r>
-          </a:p>
-        </p:txBody>
-      </p:sp>
-      <p:sp>
-        <p:nvSpPr>
-          <p:cNvPr id="13" name="TextBox 12"/>
-          <p:cNvSpPr txBox="1"/>
-          <p:nvPr/>
-        </p:nvSpPr>
-        <p:spPr>
-          <a:xfrm>
-            <a:off x="1143000" y="3685032"/>
-            <a:ext cx="5943600" cy="274320"/>
-          </a:xfrm>
-          <a:prstGeom prst="rect">
-            <a:avLst/>
-          </a:prstGeom>
-          <a:noFill/>
-        </p:spPr>
-        <p:txBody>
-          <a:bodyPr wrap="square" lIns="0" rIns="0" tIns="0" bIns="0" anchor="t">
-            <a:spAutoFit/>
-          </a:bodyPr>
-          <a:lstStyle/>
-          <a:p>
-            <a:pPr algn="l">
-              <a:spcBef>
-                <a:spcPts val="0"/>
-              </a:spcBef>
-              <a:spcAft>
-                <a:spcPts val="0"/>
-              </a:spcAft>
-            </a:pPr>
-            <a:r>
               <a:rPr sz="1200" b="0" i="0">
                 <a:solidFill>
                   <a:srgbClr val="C6CDD1"/>
@@ -18153,7 +18096,7 @@
       </p:sp>
       <p:sp>
         <p:nvSpPr>
-          <p:cNvPr id="14" name="Rectangle 13"/>
+          <p:cNvPr id="13" name="Rectangle 12"/>
           <p:cNvSpPr/>
           <p:nvPr/>
         </p:nvSpPr>
@@ -18184,14 +18127,56 @@
       </p:sp>
       <p:sp>
         <p:nvSpPr>
+          <p:cNvPr id="14" name="TextBox 13"/>
+          <p:cNvSpPr txBox="1"/>
+          <p:nvPr/>
+        </p:nvSpPr>
+        <p:spPr>
+          <a:xfrm>
+            <a:off x="621792" y="4279392"/>
+            <a:ext cx="457200" cy="457200"/>
+          </a:xfrm>
+          <a:prstGeom prst="rect">
+            <a:avLst/>
+          </a:prstGeom>
+          <a:noFill/>
+        </p:spPr>
+        <p:txBody>
+          <a:bodyPr wrap="square" lIns="0" rIns="0" tIns="0" bIns="0" anchor="t">
+            <a:spAutoFit/>
+          </a:bodyPr>
+          <a:lstStyle/>
+          <a:p>
+            <a:pPr algn="l">
+              <a:spcBef>
+                <a:spcPts val="0"/>
+              </a:spcBef>
+              <a:spcAft>
+                <a:spcPts val="0"/>
+              </a:spcAft>
+            </a:pPr>
+            <a:r>
+              <a:rPr sz="2400" b="1" i="0">
+                <a:solidFill>
+                  <a:srgbClr val="D5FB00"/>
+                </a:solidFill>
+                <a:latin typeface="Segoe UI"/>
+              </a:rPr>
+              <a:t>O</a:t>
+            </a:r>
+          </a:p>
+        </p:txBody>
+      </p:sp>
+      <p:sp>
+        <p:nvSpPr>
           <p:cNvPr id="15" name="TextBox 14"/>
           <p:cNvSpPr txBox="1"/>
           <p:nvPr/>
         </p:nvSpPr>
         <p:spPr>
           <a:xfrm>
-            <a:off x="621792" y="4279392"/>
-            <a:ext cx="457200" cy="457200"/>
+            <a:off x="1143000" y="4315968"/>
+            <a:ext cx="5943600" cy="320040"/>
           </a:xfrm>
           <a:prstGeom prst="rect">
             <a:avLst/>
@@ -18213,13 +18198,13 @@
               </a:spcAft>
             </a:pPr>
             <a:r>
-              <a:rPr sz="2400" b="1" i="0">
-                <a:solidFill>
-                  <a:srgbClr val="D5FB00"/>
+              <a:rPr sz="1400" b="0" i="0">
+                <a:solidFill>
+                  <a:srgbClr val="FFFFFF"/>
                 </a:solidFill>
                 <a:latin typeface="Segoe UI"/>
               </a:rPr>
-              <a:t>O</a:t>
+              <a:t>Solve problems, share what I learn, keep improving.</a:t>
             </a:r>
           </a:p>
         </p:txBody>
@@ -18232,8 +18217,8 @@
         </p:nvSpPr>
         <p:spPr>
           <a:xfrm>
-            <a:off x="1143000" y="4315968"/>
-            <a:ext cx="5943600" cy="320040"/>
+            <a:off x="1143000" y="4645152"/>
+            <a:ext cx="5943600" cy="274320"/>
           </a:xfrm>
           <a:prstGeom prst="rect">
             <a:avLst/>
@@ -18255,48 +18240,6 @@
               </a:spcAft>
             </a:pPr>
             <a:r>
-              <a:rPr sz="1400" b="0" i="0">
-                <a:solidFill>
-                  <a:srgbClr val="FFFFFF"/>
-                </a:solidFill>
-                <a:latin typeface="Segoe UI"/>
-              </a:rPr>
-              <a:t>Solve problems, share what I learn, keep improving.</a:t>
-            </a:r>
-          </a:p>
-        </p:txBody>
-      </p:sp>
-      <p:sp>
-        <p:nvSpPr>
-          <p:cNvPr id="17" name="TextBox 16"/>
-          <p:cNvSpPr txBox="1"/>
-          <p:nvPr/>
-        </p:nvSpPr>
-        <p:spPr>
-          <a:xfrm>
-            <a:off x="1143000" y="4645152"/>
-            <a:ext cx="5943600" cy="274320"/>
-          </a:xfrm>
-          <a:prstGeom prst="rect">
-            <a:avLst/>
-          </a:prstGeom>
-          <a:noFill/>
-        </p:spPr>
-        <p:txBody>
-          <a:bodyPr wrap="square" lIns="0" rIns="0" tIns="0" bIns="0" anchor="t">
-            <a:spAutoFit/>
-          </a:bodyPr>
-          <a:lstStyle/>
-          <a:p>
-            <a:pPr algn="l">
-              <a:spcBef>
-                <a:spcPts val="0"/>
-              </a:spcBef>
-              <a:spcAft>
-                <a:spcPts val="0"/>
-              </a:spcAft>
-            </a:pPr>
-            <a:r>
               <a:rPr sz="1200" b="0" i="0">
                 <a:solidFill>
                   <a:srgbClr val="C6CDD1"/>
@@ -18308,22 +18251,12 @@
           </a:p>
         </p:txBody>
       </p:sp>
-      <p:pic>
-        <p:nvPicPr>
-          <p:cNvPr id="18" name="!! Glass B" descr="Decorative glass panel"/>
-          <p:cNvPicPr>
-            <a:picLocks noChangeAspect="1"/>
-          </p:cNvPicPr>
+      <p:sp>
+        <p:nvSpPr>
+          <p:cNvPr id="17" name="!! Glass B"/>
+          <p:cNvSpPr/>
           <p:nvPr/>
-        </p:nvPicPr>
-        <p:blipFill>
-          <a:blip r:embed="rId3">
-            <a:alphaModFix amt="50000"/>
-          </a:blip>
-          <a:stretch>
-            <a:fillRect/>
-          </a:stretch>
-        </p:blipFill>
+        </p:nvSpPr>
         <p:spPr>
           <a:xfrm>
             <a:off x="7818120" y="1600200"/>
@@ -18332,23 +18265,14 @@
           <a:prstGeom prst="rect">
             <a:avLst/>
           </a:prstGeom>
-        </p:spPr>
-      </p:pic>
-      <p:sp>
-        <p:nvSpPr>
-          <p:cNvPr id="19" name="!! Glass B rim"/>
-          <p:cNvSpPr/>
-          <p:nvPr/>
-        </p:nvSpPr>
-        <p:spPr>
-          <a:xfrm>
-            <a:off x="7818120" y="1600200"/>
-            <a:ext cx="4114800" cy="3886200"/>
-          </a:xfrm>
-          <a:prstGeom prst="rect">
-            <a:avLst/>
-          </a:prstGeom>
-          <a:noFill/>
+          <a:blipFill rotWithShape="1">
+            <a:blip r:embed="rId3">
+              <a:alphaModFix amt="50000"/>
+            </a:blip>
+            <a:stretch>
+              <a:fillRect/>
+            </a:stretch>
+          </a:blipFill>
           <a:ln w="9525">
             <a:solidFill>
               <a:srgbClr val="FFFFFF">
@@ -18367,7 +18291,7 @@
       </p:sp>
       <p:sp>
         <p:nvSpPr>
-          <p:cNvPr id="20" name="TextBox 19"/>
+          <p:cNvPr id="18" name="TextBox 17"/>
           <p:cNvSpPr txBox="1"/>
           <p:nvPr/>
         </p:nvSpPr>
@@ -18409,7 +18333,7 @@
       </p:sp>
       <p:sp>
         <p:nvSpPr>
-          <p:cNvPr id="21" name="Chevron 20"/>
+          <p:cNvPr id="19" name="Chevron 18"/>
           <p:cNvSpPr/>
           <p:nvPr/>
         </p:nvSpPr>
@@ -18438,7 +18362,7 @@
       </p:sp>
       <p:sp>
         <p:nvSpPr>
-          <p:cNvPr id="22" name="TextBox 21"/>
+          <p:cNvPr id="20" name="TextBox 19"/>
           <p:cNvSpPr txBox="1"/>
           <p:nvPr/>
         </p:nvSpPr>
@@ -18480,7 +18404,7 @@
       </p:sp>
       <p:sp>
         <p:nvSpPr>
-          <p:cNvPr id="23" name="Chevron 22"/>
+          <p:cNvPr id="21" name="Chevron 20"/>
           <p:cNvSpPr/>
           <p:nvPr/>
         </p:nvSpPr>
@@ -18509,7 +18433,7 @@
       </p:sp>
       <p:sp>
         <p:nvSpPr>
-          <p:cNvPr id="24" name="TextBox 23"/>
+          <p:cNvPr id="22" name="TextBox 21"/>
           <p:cNvSpPr txBox="1"/>
           <p:nvPr/>
         </p:nvSpPr>
@@ -18551,7 +18475,7 @@
       </p:sp>
       <p:sp>
         <p:nvSpPr>
-          <p:cNvPr id="25" name="Chevron 24"/>
+          <p:cNvPr id="23" name="Chevron 22"/>
           <p:cNvSpPr/>
           <p:nvPr/>
         </p:nvSpPr>
@@ -18580,7 +18504,7 @@
       </p:sp>
       <p:sp>
         <p:nvSpPr>
-          <p:cNvPr id="26" name="TextBox 25"/>
+          <p:cNvPr id="24" name="TextBox 23"/>
           <p:cNvSpPr txBox="1"/>
           <p:nvPr/>
         </p:nvSpPr>
@@ -19296,22 +19220,12 @@
         <p:nvPr/>
       </p:nvGrpSpPr>
       <p:grpSpPr/>
-      <p:pic>
-        <p:nvPicPr>
-          <p:cNvPr id="2" name="!! Glass A" descr="Decorative glass panel"/>
-          <p:cNvPicPr>
-            <a:picLocks noChangeAspect="1"/>
-          </p:cNvPicPr>
+      <p:sp>
+        <p:nvSpPr>
+          <p:cNvPr id="2" name="!! Glass A"/>
+          <p:cNvSpPr/>
           <p:nvPr/>
-        </p:nvPicPr>
-        <p:blipFill>
-          <a:blip r:embed="rId2">
-            <a:alphaModFix amt="50000"/>
-          </a:blip>
-          <a:stretch>
-            <a:fillRect/>
-          </a:stretch>
-        </p:blipFill>
+        </p:nvSpPr>
         <p:spPr>
           <a:xfrm>
             <a:off x="841248" y="1828800"/>
@@ -19320,23 +19234,14 @@
           <a:prstGeom prst="rect">
             <a:avLst/>
           </a:prstGeom>
-        </p:spPr>
-      </p:pic>
-      <p:sp>
-        <p:nvSpPr>
-          <p:cNvPr id="3" name="!! Glass A rim"/>
-          <p:cNvSpPr/>
-          <p:nvPr/>
-        </p:nvSpPr>
-        <p:spPr>
-          <a:xfrm>
-            <a:off x="841248" y="1828800"/>
-            <a:ext cx="10515600" cy="3657600"/>
-          </a:xfrm>
-          <a:prstGeom prst="rect">
-            <a:avLst/>
-          </a:prstGeom>
-          <a:noFill/>
+          <a:blipFill rotWithShape="1">
+            <a:blip r:embed="rId2">
+              <a:alphaModFix amt="50000"/>
+            </a:blip>
+            <a:stretch>
+              <a:fillRect/>
+            </a:stretch>
+          </a:blipFill>
           <a:ln w="9525">
             <a:solidFill>
               <a:srgbClr val="FFFFFF">
@@ -19355,7 +19260,7 @@
       </p:sp>
       <p:sp>
         <p:nvSpPr>
-          <p:cNvPr id="4" name="TextBox 3"/>
+          <p:cNvPr id="3" name="TextBox 2"/>
           <p:cNvSpPr txBox="1"/>
           <p:nvPr/>
         </p:nvSpPr>
@@ -19397,7 +19302,7 @@
       </p:sp>
       <p:sp>
         <p:nvSpPr>
-          <p:cNvPr id="5" name="!! Title 1"/>
+          <p:cNvPr id="4" name="!! Title 1"/>
           <p:cNvSpPr txBox="1"/>
           <p:nvPr/>
         </p:nvSpPr>
@@ -19439,7 +19344,7 @@
       </p:sp>
       <p:sp>
         <p:nvSpPr>
-          <p:cNvPr id="6" name="Rectangle 5"/>
+          <p:cNvPr id="5" name="Rectangle 4"/>
           <p:cNvSpPr/>
           <p:nvPr/>
         </p:nvSpPr>
@@ -19468,7 +19373,7 @@
       </p:sp>
       <p:sp>
         <p:nvSpPr>
-          <p:cNvPr id="7" name="TextBox 6"/>
+          <p:cNvPr id="6" name="TextBox 5"/>
           <p:cNvSpPr txBox="1"/>
           <p:nvPr/>
         </p:nvSpPr>
@@ -20144,22 +20049,12 @@
           </a:p>
         </p:txBody>
       </p:sp>
-      <p:pic>
-        <p:nvPicPr>
-          <p:cNvPr id="4" name="!! Card 1" descr="Decorative glass panel"/>
-          <p:cNvPicPr>
-            <a:picLocks noChangeAspect="1"/>
-          </p:cNvPicPr>
+      <p:sp>
+        <p:nvSpPr>
+          <p:cNvPr id="4" name="!! Glass A"/>
+          <p:cNvSpPr/>
           <p:nvPr/>
-        </p:nvPicPr>
-        <p:blipFill>
-          <a:blip r:embed="rId2">
-            <a:alphaModFix amt="50000"/>
-          </a:blip>
-          <a:stretch>
-            <a:fillRect/>
-          </a:stretch>
-        </p:blipFill>
+        </p:nvSpPr>
         <p:spPr>
           <a:xfrm>
             <a:off x="256032" y="1691640"/>
@@ -20168,23 +20063,14 @@
           <a:prstGeom prst="rect">
             <a:avLst/>
           </a:prstGeom>
-        </p:spPr>
-      </p:pic>
-      <p:sp>
-        <p:nvSpPr>
-          <p:cNvPr id="5" name="!! Card 1 rim"/>
-          <p:cNvSpPr/>
-          <p:nvPr/>
-        </p:nvSpPr>
-        <p:spPr>
-          <a:xfrm>
-            <a:off x="256032" y="1691640"/>
-            <a:ext cx="2715768" cy="3063240"/>
-          </a:xfrm>
-          <a:prstGeom prst="rect">
-            <a:avLst/>
-          </a:prstGeom>
-          <a:noFill/>
+          <a:blipFill rotWithShape="1">
+            <a:blip r:embed="rId2">
+              <a:alphaModFix amt="50000"/>
+            </a:blip>
+            <a:stretch>
+              <a:fillRect/>
+            </a:stretch>
+          </a:blipFill>
           <a:ln w="9525">
             <a:solidFill>
               <a:srgbClr val="FFFFFF">
@@ -20203,14 +20089,56 @@
       </p:sp>
       <p:sp>
         <p:nvSpPr>
+          <p:cNvPr id="5" name="TextBox 4"/>
+          <p:cNvSpPr txBox="1"/>
+          <p:nvPr/>
+        </p:nvSpPr>
+        <p:spPr>
+          <a:xfrm>
+            <a:off x="566928" y="1965960"/>
+            <a:ext cx="2167128" cy="548640"/>
+          </a:xfrm>
+          <a:prstGeom prst="rect">
+            <a:avLst/>
+          </a:prstGeom>
+          <a:noFill/>
+        </p:spPr>
+        <p:txBody>
+          <a:bodyPr wrap="square" lIns="0" rIns="0" tIns="0" bIns="0" anchor="t">
+            <a:spAutoFit/>
+          </a:bodyPr>
+          <a:lstStyle/>
+          <a:p>
+            <a:pPr algn="l">
+              <a:spcBef>
+                <a:spcPts val="0"/>
+              </a:spcBef>
+              <a:spcAft>
+                <a:spcPts val="0"/>
+              </a:spcAft>
+            </a:pPr>
+            <a:r>
+              <a:rPr sz="3000" b="1" i="0">
+                <a:solidFill>
+                  <a:srgbClr val="D5FB00"/>
+                </a:solidFill>
+                <a:latin typeface="Segoe UI"/>
+              </a:rPr>
+              <a:t>I</a:t>
+            </a:r>
+          </a:p>
+        </p:txBody>
+      </p:sp>
+      <p:sp>
+        <p:nvSpPr>
           <p:cNvPr id="6" name="TextBox 5"/>
           <p:cNvSpPr txBox="1"/>
           <p:nvPr/>
         </p:nvSpPr>
         <p:spPr>
           <a:xfrm>
-            <a:off x="566928" y="1965960"/>
-            <a:ext cx="2167128" cy="548640"/>
+            <a:off x="566928" y="2651760"/>
+            <a:ext cx="2167128" cy="640080"/>
           </a:xfrm>
           <a:prstGeom prst="rect">
             <a:avLst/>
@@ -20232,48 +20160,6 @@
               </a:spcAft>
             </a:pPr>
             <a:r>
-              <a:rPr sz="3000" b="1" i="0">
-                <a:solidFill>
-                  <a:srgbClr val="D5FB00"/>
-                </a:solidFill>
-                <a:latin typeface="Segoe UI"/>
-              </a:rPr>
-              <a:t>I</a:t>
-            </a:r>
-          </a:p>
-        </p:txBody>
-      </p:sp>
-      <p:sp>
-        <p:nvSpPr>
-          <p:cNvPr id="7" name="TextBox 6"/>
-          <p:cNvSpPr txBox="1"/>
-          <p:nvPr/>
-        </p:nvSpPr>
-        <p:spPr>
-          <a:xfrm>
-            <a:off x="566928" y="2651760"/>
-            <a:ext cx="2167128" cy="640080"/>
-          </a:xfrm>
-          <a:prstGeom prst="rect">
-            <a:avLst/>
-          </a:prstGeom>
-          <a:noFill/>
-        </p:spPr>
-        <p:txBody>
-          <a:bodyPr wrap="square" lIns="0" rIns="0" tIns="0" bIns="0" anchor="t">
-            <a:spAutoFit/>
-          </a:bodyPr>
-          <a:lstStyle/>
-          <a:p>
-            <a:pPr algn="l">
-              <a:spcBef>
-                <a:spcPts val="0"/>
-              </a:spcBef>
-              <a:spcAft>
-                <a:spcPts val="0"/>
-              </a:spcAft>
-            </a:pPr>
-            <a:r>
               <a:rPr sz="1600" b="1" i="0">
                 <a:solidFill>
                   <a:srgbClr val="FFFFFF"/>
@@ -20287,7 +20173,7 @@
       </p:sp>
       <p:sp>
         <p:nvSpPr>
-          <p:cNvPr id="8" name="TextBox 7"/>
+          <p:cNvPr id="7" name="TextBox 6"/>
           <p:cNvSpPr txBox="1"/>
           <p:nvPr/>
         </p:nvSpPr>
@@ -20330,22 +20216,12 @@
           </a:p>
         </p:txBody>
       </p:sp>
-      <p:pic>
-        <p:nvPicPr>
-          <p:cNvPr id="9" name="!! Card 2" descr="Decorative glass panel"/>
-          <p:cNvPicPr>
-            <a:picLocks noChangeAspect="1"/>
-          </p:cNvPicPr>
+      <p:sp>
+        <p:nvSpPr>
+          <p:cNvPr id="8" name="!! Card 2"/>
+          <p:cNvSpPr/>
           <p:nvPr/>
-        </p:nvPicPr>
-        <p:blipFill>
-          <a:blip r:embed="rId3">
-            <a:alphaModFix amt="50000"/>
-          </a:blip>
-          <a:stretch>
-            <a:fillRect/>
-          </a:stretch>
-        </p:blipFill>
+        </p:nvSpPr>
         <p:spPr>
           <a:xfrm>
             <a:off x="3246120" y="1691640"/>
@@ -20354,23 +20230,14 @@
           <a:prstGeom prst="rect">
             <a:avLst/>
           </a:prstGeom>
-        </p:spPr>
-      </p:pic>
-      <p:sp>
-        <p:nvSpPr>
-          <p:cNvPr id="10" name="!! Card 2 rim"/>
-          <p:cNvSpPr/>
-          <p:nvPr/>
-        </p:nvSpPr>
-        <p:spPr>
-          <a:xfrm>
-            <a:off x="3246120" y="1691640"/>
-            <a:ext cx="2715768" cy="3063240"/>
-          </a:xfrm>
-          <a:prstGeom prst="rect">
-            <a:avLst/>
-          </a:prstGeom>
-          <a:noFill/>
+          <a:blipFill rotWithShape="1">
+            <a:blip r:embed="rId3">
+              <a:alphaModFix amt="50000"/>
+            </a:blip>
+            <a:stretch>
+              <a:fillRect/>
+            </a:stretch>
+          </a:blipFill>
           <a:ln w="9525">
             <a:solidFill>
               <a:srgbClr val="FFFFFF">
@@ -20389,7 +20256,7 @@
       </p:sp>
       <p:sp>
         <p:nvSpPr>
-          <p:cNvPr id="11" name="TextBox 10"/>
+          <p:cNvPr id="9" name="TextBox 8"/>
           <p:cNvSpPr txBox="1"/>
           <p:nvPr/>
         </p:nvSpPr>
@@ -20431,7 +20298,7 @@
       </p:sp>
       <p:sp>
         <p:nvSpPr>
-          <p:cNvPr id="12" name="TextBox 11"/>
+          <p:cNvPr id="10" name="TextBox 9"/>
           <p:cNvSpPr txBox="1"/>
           <p:nvPr/>
         </p:nvSpPr>
@@ -20473,7 +20340,7 @@
       </p:sp>
       <p:sp>
         <p:nvSpPr>
-          <p:cNvPr id="13" name="TextBox 12"/>
+          <p:cNvPr id="11" name="TextBox 10"/>
           <p:cNvSpPr txBox="1"/>
           <p:nvPr/>
         </p:nvSpPr>
@@ -20516,22 +20383,12 @@
           </a:p>
         </p:txBody>
       </p:sp>
-      <p:pic>
-        <p:nvPicPr>
-          <p:cNvPr id="14" name="!! Card 3" descr="Decorative glass panel"/>
-          <p:cNvPicPr>
-            <a:picLocks noChangeAspect="1"/>
-          </p:cNvPicPr>
+      <p:sp>
+        <p:nvSpPr>
+          <p:cNvPr id="12" name="!! Card 3"/>
+          <p:cNvSpPr/>
           <p:nvPr/>
-        </p:nvPicPr>
-        <p:blipFill>
-          <a:blip r:embed="rId4">
-            <a:alphaModFix amt="50000"/>
-          </a:blip>
-          <a:stretch>
-            <a:fillRect/>
-          </a:stretch>
-        </p:blipFill>
+        </p:nvSpPr>
         <p:spPr>
           <a:xfrm>
             <a:off x="6236208" y="1691640"/>
@@ -20540,23 +20397,14 @@
           <a:prstGeom prst="rect">
             <a:avLst/>
           </a:prstGeom>
-        </p:spPr>
-      </p:pic>
-      <p:sp>
-        <p:nvSpPr>
-          <p:cNvPr id="15" name="!! Card 3 rim"/>
-          <p:cNvSpPr/>
-          <p:nvPr/>
-        </p:nvSpPr>
-        <p:spPr>
-          <a:xfrm>
-            <a:off x="6236208" y="1691640"/>
-            <a:ext cx="2715768" cy="3063240"/>
-          </a:xfrm>
-          <a:prstGeom prst="rect">
-            <a:avLst/>
-          </a:prstGeom>
-          <a:noFill/>
+          <a:blipFill rotWithShape="1">
+            <a:blip r:embed="rId4">
+              <a:alphaModFix amt="50000"/>
+            </a:blip>
+            <a:stretch>
+              <a:fillRect/>
+            </a:stretch>
+          </a:blipFill>
           <a:ln w="9525">
             <a:solidFill>
               <a:srgbClr val="FFFFFF">
@@ -20575,7 +20423,7 @@
       </p:sp>
       <p:sp>
         <p:nvSpPr>
-          <p:cNvPr id="16" name="TextBox 15"/>
+          <p:cNvPr id="13" name="TextBox 12"/>
           <p:cNvSpPr txBox="1"/>
           <p:nvPr/>
         </p:nvSpPr>
@@ -20617,7 +20465,7 @@
       </p:sp>
       <p:sp>
         <p:nvSpPr>
-          <p:cNvPr id="17" name="TextBox 16"/>
+          <p:cNvPr id="14" name="TextBox 13"/>
           <p:cNvSpPr txBox="1"/>
           <p:nvPr/>
         </p:nvSpPr>
@@ -20659,7 +20507,7 @@
       </p:sp>
       <p:sp>
         <p:nvSpPr>
-          <p:cNvPr id="18" name="TextBox 17"/>
+          <p:cNvPr id="15" name="TextBox 14"/>
           <p:cNvSpPr txBox="1"/>
           <p:nvPr/>
         </p:nvSpPr>
@@ -20702,22 +20550,12 @@
           </a:p>
         </p:txBody>
       </p:sp>
-      <p:pic>
-        <p:nvPicPr>
-          <p:cNvPr id="19" name="!! Card 4" descr="Decorative glass panel"/>
-          <p:cNvPicPr>
-            <a:picLocks noChangeAspect="1"/>
-          </p:cNvPicPr>
+      <p:sp>
+        <p:nvSpPr>
+          <p:cNvPr id="16" name="!! Glass B"/>
+          <p:cNvSpPr/>
           <p:nvPr/>
-        </p:nvPicPr>
-        <p:blipFill>
-          <a:blip r:embed="rId5">
-            <a:alphaModFix amt="50000"/>
-          </a:blip>
-          <a:stretch>
-            <a:fillRect/>
-          </a:stretch>
-        </p:blipFill>
+        </p:nvSpPr>
         <p:spPr>
           <a:xfrm>
             <a:off x="9226296" y="1691640"/>
@@ -20726,23 +20564,14 @@
           <a:prstGeom prst="rect">
             <a:avLst/>
           </a:prstGeom>
-        </p:spPr>
-      </p:pic>
-      <p:sp>
-        <p:nvSpPr>
-          <p:cNvPr id="20" name="!! Card 4 rim"/>
-          <p:cNvSpPr/>
-          <p:nvPr/>
-        </p:nvSpPr>
-        <p:spPr>
-          <a:xfrm>
-            <a:off x="9226296" y="1691640"/>
-            <a:ext cx="2715768" cy="3063240"/>
-          </a:xfrm>
-          <a:prstGeom prst="rect">
-            <a:avLst/>
-          </a:prstGeom>
-          <a:noFill/>
+          <a:blipFill rotWithShape="1">
+            <a:blip r:embed="rId5">
+              <a:alphaModFix amt="50000"/>
+            </a:blip>
+            <a:stretch>
+              <a:fillRect/>
+            </a:stretch>
+          </a:blipFill>
           <a:ln w="9525">
             <a:solidFill>
               <a:srgbClr val="FFFFFF">
@@ -20761,7 +20590,7 @@
       </p:sp>
       <p:sp>
         <p:nvSpPr>
-          <p:cNvPr id="21" name="TextBox 20"/>
+          <p:cNvPr id="17" name="TextBox 16"/>
           <p:cNvSpPr txBox="1"/>
           <p:nvPr/>
         </p:nvSpPr>
@@ -20803,7 +20632,7 @@
       </p:sp>
       <p:sp>
         <p:nvSpPr>
-          <p:cNvPr id="22" name="TextBox 21"/>
+          <p:cNvPr id="18" name="TextBox 17"/>
           <p:cNvSpPr txBox="1"/>
           <p:nvPr/>
         </p:nvSpPr>
@@ -20845,7 +20674,7 @@
       </p:sp>
       <p:sp>
         <p:nvSpPr>
-          <p:cNvPr id="23" name="TextBox 22"/>
+          <p:cNvPr id="19" name="TextBox 18"/>
           <p:cNvSpPr txBox="1"/>
           <p:nvPr/>
         </p:nvSpPr>
@@ -20888,22 +20717,12 @@
           </a:p>
         </p:txBody>
       </p:sp>
-      <p:pic>
-        <p:nvPicPr>
-          <p:cNvPr id="24" name="!! Strip" descr="Decorative glass panel"/>
-          <p:cNvPicPr>
-            <a:picLocks noChangeAspect="1"/>
-          </p:cNvPicPr>
+      <p:sp>
+        <p:nvSpPr>
+          <p:cNvPr id="20" name="!! Strip"/>
+          <p:cNvSpPr/>
           <p:nvPr/>
-        </p:nvPicPr>
-        <p:blipFill>
-          <a:blip r:embed="rId6">
-            <a:alphaModFix amt="50000"/>
-          </a:blip>
-          <a:stretch>
-            <a:fillRect/>
-          </a:stretch>
-        </p:blipFill>
+        </p:nvSpPr>
         <p:spPr>
           <a:xfrm>
             <a:off x="256032" y="4956048"/>
@@ -20912,23 +20731,14 @@
           <a:prstGeom prst="rect">
             <a:avLst/>
           </a:prstGeom>
-        </p:spPr>
-      </p:pic>
-      <p:sp>
-        <p:nvSpPr>
-          <p:cNvPr id="25" name="!! Strip rim"/>
-          <p:cNvSpPr/>
-          <p:nvPr/>
-        </p:nvSpPr>
-        <p:spPr>
-          <a:xfrm>
-            <a:off x="256032" y="4956048"/>
-            <a:ext cx="11676888" cy="566928"/>
-          </a:xfrm>
-          <a:prstGeom prst="rect">
-            <a:avLst/>
-          </a:prstGeom>
-          <a:noFill/>
+          <a:blipFill rotWithShape="1">
+            <a:blip r:embed="rId6">
+              <a:alphaModFix amt="50000"/>
+            </a:blip>
+            <a:stretch>
+              <a:fillRect/>
+            </a:stretch>
+          </a:blipFill>
           <a:ln w="9525">
             <a:solidFill>
               <a:srgbClr val="FFFFFF">
@@ -20947,7 +20757,7 @@
       </p:sp>
       <p:sp>
         <p:nvSpPr>
-          <p:cNvPr id="26" name="TextBox 25"/>
+          <p:cNvPr id="21" name="TextBox 20"/>
           <p:cNvSpPr txBox="1"/>
           <p:nvPr/>
         </p:nvSpPr>
@@ -20989,7 +20799,7 @@
       </p:sp>
       <p:sp>
         <p:nvSpPr>
-          <p:cNvPr id="27" name="TextBox 26"/>
+          <p:cNvPr id="22" name="TextBox 21"/>
           <p:cNvSpPr txBox="1"/>
           <p:nvPr/>
         </p:nvSpPr>
@@ -21857,22 +21667,12 @@
           </a:p>
         </p:txBody>
       </p:sp>
-      <p:pic>
-        <p:nvPicPr>
-          <p:cNvPr id="4" name="!! Glass A" descr="Decorative glass panel"/>
-          <p:cNvPicPr>
-            <a:picLocks noChangeAspect="1"/>
-          </p:cNvPicPr>
+      <p:sp>
+        <p:nvSpPr>
+          <p:cNvPr id="4" name="!! Glass A"/>
+          <p:cNvSpPr/>
           <p:nvPr/>
-        </p:nvPicPr>
-        <p:blipFill>
-          <a:blip r:embed="rId2">
-            <a:alphaModFix amt="50000"/>
-          </a:blip>
-          <a:stretch>
-            <a:fillRect/>
-          </a:stretch>
-        </p:blipFill>
+        </p:nvSpPr>
         <p:spPr>
           <a:xfrm>
             <a:off x="256032" y="1600200"/>
@@ -21881,23 +21681,14 @@
           <a:prstGeom prst="rect">
             <a:avLst/>
           </a:prstGeom>
-        </p:spPr>
-      </p:pic>
-      <p:sp>
-        <p:nvSpPr>
-          <p:cNvPr id="5" name="!! Glass A rim"/>
-          <p:cNvSpPr/>
-          <p:nvPr/>
-        </p:nvSpPr>
-        <p:spPr>
-          <a:xfrm>
-            <a:off x="256032" y="1600200"/>
-            <a:ext cx="7223760" cy="3886200"/>
-          </a:xfrm>
-          <a:prstGeom prst="rect">
-            <a:avLst/>
-          </a:prstGeom>
-          <a:noFill/>
+          <a:blipFill rotWithShape="1">
+            <a:blip r:embed="rId2">
+              <a:alphaModFix amt="50000"/>
+            </a:blip>
+            <a:stretch>
+              <a:fillRect/>
+            </a:stretch>
+          </a:blipFill>
           <a:ln w="9525">
             <a:solidFill>
               <a:srgbClr val="FFFFFF">
@@ -21916,14 +21707,56 @@
       </p:sp>
       <p:sp>
         <p:nvSpPr>
+          <p:cNvPr id="5" name="TextBox 4"/>
+          <p:cNvSpPr txBox="1"/>
+          <p:nvPr/>
+        </p:nvSpPr>
+        <p:spPr>
+          <a:xfrm>
+            <a:off x="621792" y="1901952"/>
+            <a:ext cx="5486400" cy="274320"/>
+          </a:xfrm>
+          <a:prstGeom prst="rect">
+            <a:avLst/>
+          </a:prstGeom>
+          <a:noFill/>
+        </p:spPr>
+        <p:txBody>
+          <a:bodyPr wrap="square" lIns="0" rIns="0" tIns="0" bIns="0" anchor="t">
+            <a:spAutoFit/>
+          </a:bodyPr>
+          <a:lstStyle/>
+          <a:p>
+            <a:pPr algn="l">
+              <a:spcBef>
+                <a:spcPts val="0"/>
+              </a:spcBef>
+              <a:spcAft>
+                <a:spcPts val="0"/>
+              </a:spcAft>
+            </a:pPr>
+            <a:r>
+              <a:rPr sz="1600" b="1" i="0">
+                <a:solidFill>
+                  <a:srgbClr val="D5FB00"/>
+                </a:solidFill>
+                <a:latin typeface="Segoe UI"/>
+              </a:rPr>
+              <a:t>FIVE TOPICS</a:t>
+            </a:r>
+          </a:p>
+        </p:txBody>
+      </p:sp>
+      <p:sp>
+        <p:nvSpPr>
           <p:cNvPr id="6" name="TextBox 5"/>
           <p:cNvSpPr txBox="1"/>
           <p:nvPr/>
         </p:nvSpPr>
         <p:spPr>
           <a:xfrm>
-            <a:off x="621792" y="1901952"/>
-            <a:ext cx="5486400" cy="274320"/>
+            <a:off x="621792" y="2359152"/>
+            <a:ext cx="2011680" cy="320040"/>
           </a:xfrm>
           <a:prstGeom prst="rect">
             <a:avLst/>
@@ -21945,13 +21778,13 @@
               </a:spcAft>
             </a:pPr>
             <a:r>
-              <a:rPr sz="1600" b="1" i="0">
-                <a:solidFill>
-                  <a:srgbClr val="D5FB00"/>
+              <a:rPr sz="1400" b="1" i="0">
+                <a:solidFill>
+                  <a:srgbClr val="FFFFFF"/>
                 </a:solidFill>
                 <a:latin typeface="Segoe UI"/>
               </a:rPr>
-              <a:t>FIVE TOPICS</a:t>
+              <a:t>Safety</a:t>
             </a:r>
           </a:p>
         </p:txBody>
@@ -21964,8 +21797,8 @@
         </p:nvSpPr>
         <p:spPr>
           <a:xfrm>
-            <a:off x="621792" y="2359152"/>
-            <a:ext cx="2011680" cy="320040"/>
+            <a:off x="2697480" y="2368296"/>
+            <a:ext cx="4526280" cy="320040"/>
           </a:xfrm>
           <a:prstGeom prst="rect">
             <a:avLst/>
@@ -21987,48 +21820,6 @@
               </a:spcAft>
             </a:pPr>
             <a:r>
-              <a:rPr sz="1400" b="1" i="0">
-                <a:solidFill>
-                  <a:srgbClr val="FFFFFF"/>
-                </a:solidFill>
-                <a:latin typeface="Segoe UI"/>
-              </a:rPr>
-              <a:t>Safety</a:t>
-            </a:r>
-          </a:p>
-        </p:txBody>
-      </p:sp>
-      <p:sp>
-        <p:nvSpPr>
-          <p:cNvPr id="8" name="TextBox 7"/>
-          <p:cNvSpPr txBox="1"/>
-          <p:nvPr/>
-        </p:nvSpPr>
-        <p:spPr>
-          <a:xfrm>
-            <a:off x="2697480" y="2368296"/>
-            <a:ext cx="4526280" cy="320040"/>
-          </a:xfrm>
-          <a:prstGeom prst="rect">
-            <a:avLst/>
-          </a:prstGeom>
-          <a:noFill/>
-        </p:spPr>
-        <p:txBody>
-          <a:bodyPr wrap="square" lIns="0" rIns="0" tIns="0" bIns="0" anchor="t">
-            <a:spAutoFit/>
-          </a:bodyPr>
-          <a:lstStyle/>
-          <a:p>
-            <a:pPr algn="l">
-              <a:spcBef>
-                <a:spcPts val="0"/>
-              </a:spcBef>
-              <a:spcAft>
-                <a:spcPts val="0"/>
-              </a:spcAft>
-            </a:pPr>
-            <a:r>
               <a:rPr sz="1300" b="0" i="0">
                 <a:solidFill>
                   <a:srgbClr val="C6CDD1"/>
@@ -22042,7 +21833,7 @@
       </p:sp>
       <p:sp>
         <p:nvSpPr>
-          <p:cNvPr id="9" name="Rectangle 8"/>
+          <p:cNvPr id="8" name="Rectangle 7"/>
           <p:cNvSpPr/>
           <p:nvPr/>
         </p:nvSpPr>
@@ -22073,14 +21864,56 @@
       </p:sp>
       <p:sp>
         <p:nvSpPr>
+          <p:cNvPr id="9" name="TextBox 8"/>
+          <p:cNvSpPr txBox="1"/>
+          <p:nvPr/>
+        </p:nvSpPr>
+        <p:spPr>
+          <a:xfrm>
+            <a:off x="621792" y="2962656"/>
+            <a:ext cx="2011680" cy="320040"/>
+          </a:xfrm>
+          <a:prstGeom prst="rect">
+            <a:avLst/>
+          </a:prstGeom>
+          <a:noFill/>
+        </p:spPr>
+        <p:txBody>
+          <a:bodyPr wrap="square" lIns="0" rIns="0" tIns="0" bIns="0" anchor="t">
+            <a:spAutoFit/>
+          </a:bodyPr>
+          <a:lstStyle/>
+          <a:p>
+            <a:pPr algn="l">
+              <a:spcBef>
+                <a:spcPts val="0"/>
+              </a:spcBef>
+              <a:spcAft>
+                <a:spcPts val="0"/>
+              </a:spcAft>
+            </a:pPr>
+            <a:r>
+              <a:rPr sz="1400" b="1" i="0">
+                <a:solidFill>
+                  <a:srgbClr val="FFFFFF"/>
+                </a:solidFill>
+                <a:latin typeface="Segoe UI"/>
+              </a:rPr>
+              <a:t>GMAW welding</a:t>
+            </a:r>
+          </a:p>
+        </p:txBody>
+      </p:sp>
+      <p:sp>
+        <p:nvSpPr>
           <p:cNvPr id="10" name="TextBox 9"/>
           <p:cNvSpPr txBox="1"/>
           <p:nvPr/>
         </p:nvSpPr>
         <p:spPr>
           <a:xfrm>
-            <a:off x="621792" y="2962656"/>
-            <a:ext cx="2011680" cy="320040"/>
+            <a:off x="2697480" y="2971800"/>
+            <a:ext cx="4526280" cy="320040"/>
           </a:xfrm>
           <a:prstGeom prst="rect">
             <a:avLst/>
@@ -22102,48 +21935,6 @@
               </a:spcAft>
             </a:pPr>
             <a:r>
-              <a:rPr sz="1400" b="1" i="0">
-                <a:solidFill>
-                  <a:srgbClr val="FFFFFF"/>
-                </a:solidFill>
-                <a:latin typeface="Segoe UI"/>
-              </a:rPr>
-              <a:t>GMAW welding</a:t>
-            </a:r>
-          </a:p>
-        </p:txBody>
-      </p:sp>
-      <p:sp>
-        <p:nvSpPr>
-          <p:cNvPr id="11" name="TextBox 10"/>
-          <p:cNvSpPr txBox="1"/>
-          <p:nvPr/>
-        </p:nvSpPr>
-        <p:spPr>
-          <a:xfrm>
-            <a:off x="2697480" y="2971800"/>
-            <a:ext cx="4526280" cy="320040"/>
-          </a:xfrm>
-          <a:prstGeom prst="rect">
-            <a:avLst/>
-          </a:prstGeom>
-          <a:noFill/>
-        </p:spPr>
-        <p:txBody>
-          <a:bodyPr wrap="square" lIns="0" rIns="0" tIns="0" bIns="0" anchor="t">
-            <a:spAutoFit/>
-          </a:bodyPr>
-          <a:lstStyle/>
-          <a:p>
-            <a:pPr algn="l">
-              <a:spcBef>
-                <a:spcPts val="0"/>
-              </a:spcBef>
-              <a:spcAft>
-                <a:spcPts val="0"/>
-              </a:spcAft>
-            </a:pPr>
-            <a:r>
               <a:rPr sz="1300" b="0" i="0">
                 <a:solidFill>
                   <a:srgbClr val="C6CDD1"/>
@@ -22157,7 +21948,7 @@
       </p:sp>
       <p:sp>
         <p:nvSpPr>
-          <p:cNvPr id="12" name="Rectangle 11"/>
+          <p:cNvPr id="11" name="Rectangle 10"/>
           <p:cNvSpPr/>
           <p:nvPr/>
         </p:nvSpPr>
@@ -22188,14 +21979,56 @@
       </p:sp>
       <p:sp>
         <p:nvSpPr>
+          <p:cNvPr id="12" name="TextBox 11"/>
+          <p:cNvSpPr txBox="1"/>
+          <p:nvPr/>
+        </p:nvSpPr>
+        <p:spPr>
+          <a:xfrm>
+            <a:off x="621792" y="3566160"/>
+            <a:ext cx="2011680" cy="320040"/>
+          </a:xfrm>
+          <a:prstGeom prst="rect">
+            <a:avLst/>
+          </a:prstGeom>
+          <a:noFill/>
+        </p:spPr>
+        <p:txBody>
+          <a:bodyPr wrap="square" lIns="0" rIns="0" tIns="0" bIns="0" anchor="t">
+            <a:spAutoFit/>
+          </a:bodyPr>
+          <a:lstStyle/>
+          <a:p>
+            <a:pPr algn="l">
+              <a:spcBef>
+                <a:spcPts val="0"/>
+              </a:spcBef>
+              <a:spcAft>
+                <a:spcPts val="0"/>
+              </a:spcAft>
+            </a:pPr>
+            <a:r>
+              <a:rPr sz="1400" b="1" i="0">
+                <a:solidFill>
+                  <a:srgbClr val="FFFFFF"/>
+                </a:solidFill>
+                <a:latin typeface="Segoe UI"/>
+              </a:rPr>
+              <a:t>The WPS</a:t>
+            </a:r>
+          </a:p>
+        </p:txBody>
+      </p:sp>
+      <p:sp>
+        <p:nvSpPr>
           <p:cNvPr id="13" name="TextBox 12"/>
           <p:cNvSpPr txBox="1"/>
           <p:nvPr/>
         </p:nvSpPr>
         <p:spPr>
           <a:xfrm>
-            <a:off x="621792" y="3566160"/>
-            <a:ext cx="2011680" cy="320040"/>
+            <a:off x="2697480" y="3575304"/>
+            <a:ext cx="4526280" cy="320040"/>
           </a:xfrm>
           <a:prstGeom prst="rect">
             <a:avLst/>
@@ -22217,48 +22050,6 @@
               </a:spcAft>
             </a:pPr>
             <a:r>
-              <a:rPr sz="1400" b="1" i="0">
-                <a:solidFill>
-                  <a:srgbClr val="FFFFFF"/>
-                </a:solidFill>
-                <a:latin typeface="Segoe UI"/>
-              </a:rPr>
-              <a:t>The WPS</a:t>
-            </a:r>
-          </a:p>
-        </p:txBody>
-      </p:sp>
-      <p:sp>
-        <p:nvSpPr>
-          <p:cNvPr id="14" name="TextBox 13"/>
-          <p:cNvSpPr txBox="1"/>
-          <p:nvPr/>
-        </p:nvSpPr>
-        <p:spPr>
-          <a:xfrm>
-            <a:off x="2697480" y="3575304"/>
-            <a:ext cx="4526280" cy="320040"/>
-          </a:xfrm>
-          <a:prstGeom prst="rect">
-            <a:avLst/>
-          </a:prstGeom>
-          <a:noFill/>
-        </p:spPr>
-        <p:txBody>
-          <a:bodyPr wrap="square" lIns="0" rIns="0" tIns="0" bIns="0" anchor="t">
-            <a:spAutoFit/>
-          </a:bodyPr>
-          <a:lstStyle/>
-          <a:p>
-            <a:pPr algn="l">
-              <a:spcBef>
-                <a:spcPts val="0"/>
-              </a:spcBef>
-              <a:spcAft>
-                <a:spcPts val="0"/>
-              </a:spcAft>
-            </a:pPr>
-            <a:r>
               <a:rPr sz="1300" b="0" i="0">
                 <a:solidFill>
                   <a:srgbClr val="C6CDD1"/>
@@ -22272,7 +22063,7 @@
       </p:sp>
       <p:sp>
         <p:nvSpPr>
-          <p:cNvPr id="15" name="Rectangle 14"/>
+          <p:cNvPr id="14" name="Rectangle 13"/>
           <p:cNvSpPr/>
           <p:nvPr/>
         </p:nvSpPr>
@@ -22303,14 +22094,56 @@
       </p:sp>
       <p:sp>
         <p:nvSpPr>
+          <p:cNvPr id="15" name="TextBox 14"/>
+          <p:cNvSpPr txBox="1"/>
+          <p:nvPr/>
+        </p:nvSpPr>
+        <p:spPr>
+          <a:xfrm>
+            <a:off x="621792" y="4169664"/>
+            <a:ext cx="2011680" cy="320040"/>
+          </a:xfrm>
+          <a:prstGeom prst="rect">
+            <a:avLst/>
+          </a:prstGeom>
+          <a:noFill/>
+        </p:spPr>
+        <p:txBody>
+          <a:bodyPr wrap="square" lIns="0" rIns="0" tIns="0" bIns="0" anchor="t">
+            <a:spAutoFit/>
+          </a:bodyPr>
+          <a:lstStyle/>
+          <a:p>
+            <a:pPr algn="l">
+              <a:spcBef>
+                <a:spcPts val="0"/>
+              </a:spcBef>
+              <a:spcAft>
+                <a:spcPts val="0"/>
+              </a:spcAft>
+            </a:pPr>
+            <a:r>
+              <a:rPr sz="1400" b="1" i="0">
+                <a:solidFill>
+                  <a:srgbClr val="FFFFFF"/>
+                </a:solidFill>
+                <a:latin typeface="Segoe UI"/>
+              </a:rPr>
+              <a:t>Defects</a:t>
+            </a:r>
+          </a:p>
+        </p:txBody>
+      </p:sp>
+      <p:sp>
+        <p:nvSpPr>
           <p:cNvPr id="16" name="TextBox 15"/>
           <p:cNvSpPr txBox="1"/>
           <p:nvPr/>
         </p:nvSpPr>
         <p:spPr>
           <a:xfrm>
-            <a:off x="621792" y="4169664"/>
-            <a:ext cx="2011680" cy="320040"/>
+            <a:off x="2697480" y="4178808"/>
+            <a:ext cx="4526280" cy="320040"/>
           </a:xfrm>
           <a:prstGeom prst="rect">
             <a:avLst/>
@@ -22332,48 +22165,6 @@
               </a:spcAft>
             </a:pPr>
             <a:r>
-              <a:rPr sz="1400" b="1" i="0">
-                <a:solidFill>
-                  <a:srgbClr val="FFFFFF"/>
-                </a:solidFill>
-                <a:latin typeface="Segoe UI"/>
-              </a:rPr>
-              <a:t>Defects</a:t>
-            </a:r>
-          </a:p>
-        </p:txBody>
-      </p:sp>
-      <p:sp>
-        <p:nvSpPr>
-          <p:cNvPr id="17" name="TextBox 16"/>
-          <p:cNvSpPr txBox="1"/>
-          <p:nvPr/>
-        </p:nvSpPr>
-        <p:spPr>
-          <a:xfrm>
-            <a:off x="2697480" y="4178808"/>
-            <a:ext cx="4526280" cy="320040"/>
-          </a:xfrm>
-          <a:prstGeom prst="rect">
-            <a:avLst/>
-          </a:prstGeom>
-          <a:noFill/>
-        </p:spPr>
-        <p:txBody>
-          <a:bodyPr wrap="square" lIns="0" rIns="0" tIns="0" bIns="0" anchor="t">
-            <a:spAutoFit/>
-          </a:bodyPr>
-          <a:lstStyle/>
-          <a:p>
-            <a:pPr algn="l">
-              <a:spcBef>
-                <a:spcPts val="0"/>
-              </a:spcBef>
-              <a:spcAft>
-                <a:spcPts val="0"/>
-              </a:spcAft>
-            </a:pPr>
-            <a:r>
               <a:rPr sz="1300" b="0" i="0">
                 <a:solidFill>
                   <a:srgbClr val="C6CDD1"/>
@@ -22387,7 +22178,7 @@
       </p:sp>
       <p:sp>
         <p:nvSpPr>
-          <p:cNvPr id="18" name="Rectangle 17"/>
+          <p:cNvPr id="17" name="Rectangle 16"/>
           <p:cNvSpPr/>
           <p:nvPr/>
         </p:nvSpPr>
@@ -22418,14 +22209,56 @@
       </p:sp>
       <p:sp>
         <p:nvSpPr>
+          <p:cNvPr id="18" name="TextBox 17"/>
+          <p:cNvSpPr txBox="1"/>
+          <p:nvPr/>
+        </p:nvSpPr>
+        <p:spPr>
+          <a:xfrm>
+            <a:off x="621792" y="4773168"/>
+            <a:ext cx="2011680" cy="320040"/>
+          </a:xfrm>
+          <a:prstGeom prst="rect">
+            <a:avLst/>
+          </a:prstGeom>
+          <a:noFill/>
+        </p:spPr>
+        <p:txBody>
+          <a:bodyPr wrap="square" lIns="0" rIns="0" tIns="0" bIns="0" anchor="t">
+            <a:spAutoFit/>
+          </a:bodyPr>
+          <a:lstStyle/>
+          <a:p>
+            <a:pPr algn="l">
+              <a:spcBef>
+                <a:spcPts val="0"/>
+              </a:spcBef>
+              <a:spcAft>
+                <a:spcPts val="0"/>
+              </a:spcAft>
+            </a:pPr>
+            <a:r>
+              <a:rPr sz="1400" b="1" i="0">
+                <a:solidFill>
+                  <a:srgbClr val="FFFFFF"/>
+                </a:solidFill>
+                <a:latin typeface="Segoe UI"/>
+              </a:rPr>
+              <a:t>Parameters</a:t>
+            </a:r>
+          </a:p>
+        </p:txBody>
+      </p:sp>
+      <p:sp>
+        <p:nvSpPr>
           <p:cNvPr id="19" name="TextBox 18"/>
           <p:cNvSpPr txBox="1"/>
           <p:nvPr/>
         </p:nvSpPr>
         <p:spPr>
           <a:xfrm>
-            <a:off x="621792" y="4773168"/>
-            <a:ext cx="2011680" cy="320040"/>
+            <a:off x="2697480" y="4782312"/>
+            <a:ext cx="4526280" cy="320040"/>
           </a:xfrm>
           <a:prstGeom prst="rect">
             <a:avLst/>
@@ -22447,48 +22280,6 @@
               </a:spcAft>
             </a:pPr>
             <a:r>
-              <a:rPr sz="1400" b="1" i="0">
-                <a:solidFill>
-                  <a:srgbClr val="FFFFFF"/>
-                </a:solidFill>
-                <a:latin typeface="Segoe UI"/>
-              </a:rPr>
-              <a:t>Parameters</a:t>
-            </a:r>
-          </a:p>
-        </p:txBody>
-      </p:sp>
-      <p:sp>
-        <p:nvSpPr>
-          <p:cNvPr id="20" name="TextBox 19"/>
-          <p:cNvSpPr txBox="1"/>
-          <p:nvPr/>
-        </p:nvSpPr>
-        <p:spPr>
-          <a:xfrm>
-            <a:off x="2697480" y="4782312"/>
-            <a:ext cx="4526280" cy="320040"/>
-          </a:xfrm>
-          <a:prstGeom prst="rect">
-            <a:avLst/>
-          </a:prstGeom>
-          <a:noFill/>
-        </p:spPr>
-        <p:txBody>
-          <a:bodyPr wrap="square" lIns="0" rIns="0" tIns="0" bIns="0" anchor="t">
-            <a:spAutoFit/>
-          </a:bodyPr>
-          <a:lstStyle/>
-          <a:p>
-            <a:pPr algn="l">
-              <a:spcBef>
-                <a:spcPts val="0"/>
-              </a:spcBef>
-              <a:spcAft>
-                <a:spcPts val="0"/>
-              </a:spcAft>
-            </a:pPr>
-            <a:r>
               <a:rPr sz="1300" b="0" i="0">
                 <a:solidFill>
                   <a:srgbClr val="C6CDD1"/>
@@ -22500,22 +22291,12 @@
           </a:p>
         </p:txBody>
       </p:sp>
-      <p:pic>
-        <p:nvPicPr>
-          <p:cNvPr id="21" name="!! Glass B" descr="Decorative glass panel"/>
-          <p:cNvPicPr>
-            <a:picLocks noChangeAspect="1"/>
-          </p:cNvPicPr>
+      <p:sp>
+        <p:nvSpPr>
+          <p:cNvPr id="20" name="!! Glass B"/>
+          <p:cNvSpPr/>
           <p:nvPr/>
-        </p:nvPicPr>
-        <p:blipFill>
-          <a:blip r:embed="rId3">
-            <a:alphaModFix amt="50000"/>
-          </a:blip>
-          <a:stretch>
-            <a:fillRect/>
-          </a:stretch>
-        </p:blipFill>
+        </p:nvSpPr>
         <p:spPr>
           <a:xfrm>
             <a:off x="7818120" y="1600200"/>
@@ -22524,23 +22305,14 @@
           <a:prstGeom prst="rect">
             <a:avLst/>
           </a:prstGeom>
-        </p:spPr>
-      </p:pic>
-      <p:sp>
-        <p:nvSpPr>
-          <p:cNvPr id="22" name="!! Glass B rim"/>
-          <p:cNvSpPr/>
-          <p:nvPr/>
-        </p:nvSpPr>
-        <p:spPr>
-          <a:xfrm>
-            <a:off x="7818120" y="1600200"/>
-            <a:ext cx="4114800" cy="3886200"/>
-          </a:xfrm>
-          <a:prstGeom prst="rect">
-            <a:avLst/>
-          </a:prstGeom>
-          <a:noFill/>
+          <a:blipFill rotWithShape="1">
+            <a:blip r:embed="rId3">
+              <a:alphaModFix amt="50000"/>
+            </a:blip>
+            <a:stretch>
+              <a:fillRect/>
+            </a:stretch>
+          </a:blipFill>
           <a:ln w="9525">
             <a:solidFill>
               <a:srgbClr val="FFFFFF">
@@ -22559,14 +22331,98 @@
       </p:sp>
       <p:sp>
         <p:nvSpPr>
+          <p:cNvPr id="21" name="TextBox 20"/>
+          <p:cNvSpPr txBox="1"/>
+          <p:nvPr/>
+        </p:nvSpPr>
+        <p:spPr>
+          <a:xfrm>
+            <a:off x="8183879" y="1901952"/>
+            <a:ext cx="5486400" cy="274320"/>
+          </a:xfrm>
+          <a:prstGeom prst="rect">
+            <a:avLst/>
+          </a:prstGeom>
+          <a:noFill/>
+        </p:spPr>
+        <p:txBody>
+          <a:bodyPr wrap="square" lIns="0" rIns="0" tIns="0" bIns="0" anchor="t">
+            <a:spAutoFit/>
+          </a:bodyPr>
+          <a:lstStyle/>
+          <a:p>
+            <a:pPr algn="l">
+              <a:spcBef>
+                <a:spcPts val="0"/>
+              </a:spcBef>
+              <a:spcAft>
+                <a:spcPts val="0"/>
+              </a:spcAft>
+            </a:pPr>
+            <a:r>
+              <a:rPr sz="1600" b="1" i="0">
+                <a:solidFill>
+                  <a:srgbClr val="D5FB00"/>
+                </a:solidFill>
+                <a:latin typeface="Segoe UI"/>
+              </a:rPr>
+              <a:t>HOW I LEARNED IT</a:t>
+            </a:r>
+          </a:p>
+        </p:txBody>
+      </p:sp>
+      <p:sp>
+        <p:nvSpPr>
+          <p:cNvPr id="22" name="TextBox 21"/>
+          <p:cNvSpPr txBox="1"/>
+          <p:nvPr/>
+        </p:nvSpPr>
+        <p:spPr>
+          <a:xfrm>
+            <a:off x="8183879" y="2331720"/>
+            <a:ext cx="3474720" cy="457200"/>
+          </a:xfrm>
+          <a:prstGeom prst="rect">
+            <a:avLst/>
+          </a:prstGeom>
+          <a:noFill/>
+        </p:spPr>
+        <p:txBody>
+          <a:bodyPr wrap="square" lIns="0" rIns="0" tIns="0" bIns="0" anchor="t">
+            <a:spAutoFit/>
+          </a:bodyPr>
+          <a:lstStyle/>
+          <a:p>
+            <a:pPr algn="l">
+              <a:spcBef>
+                <a:spcPts val="0"/>
+              </a:spcBef>
+              <a:spcAft>
+                <a:spcPts val="0"/>
+              </a:spcAft>
+            </a:pPr>
+            <a:r>
+              <a:rPr sz="2600" b="1" i="0">
+                <a:solidFill>
+                  <a:srgbClr val="D5FB00"/>
+                </a:solidFill>
+                <a:latin typeface="Segoe UI"/>
+              </a:rPr>
+              <a:t>616</a:t>
+            </a:r>
+          </a:p>
+        </p:txBody>
+      </p:sp>
+      <p:sp>
+        <p:nvSpPr>
           <p:cNvPr id="23" name="TextBox 22"/>
           <p:cNvSpPr txBox="1"/>
           <p:nvPr/>
         </p:nvSpPr>
         <p:spPr>
           <a:xfrm>
-            <a:off x="8183879" y="1901952"/>
-            <a:ext cx="5486400" cy="274320"/>
+            <a:off x="8183879" y="2788920"/>
+            <a:ext cx="3429000" cy="457200"/>
           </a:xfrm>
           <a:prstGeom prst="rect">
             <a:avLst/>
@@ -22588,13 +22444,13 @@
               </a:spcAft>
             </a:pPr>
             <a:r>
-              <a:rPr sz="1600" b="1" i="0">
-                <a:solidFill>
-                  <a:srgbClr val="D5FB00"/>
+              <a:rPr sz="1200" b="0" i="0">
+                <a:solidFill>
+                  <a:srgbClr val="C6CDD1"/>
                 </a:solidFill>
                 <a:latin typeface="Segoe UI"/>
               </a:rPr>
-              <a:t>HOW I LEARNED IT</a:t>
+              <a:t>pages of training manual and customer standard, read page by page.</a:t>
             </a:r>
           </a:p>
         </p:txBody>
@@ -22607,7 +22463,7 @@
         </p:nvSpPr>
         <p:spPr>
           <a:xfrm>
-            <a:off x="8183879" y="2331720"/>
+            <a:off x="8183879" y="3337560"/>
             <a:ext cx="3474720" cy="457200"/>
           </a:xfrm>
           <a:prstGeom prst="rect">
@@ -22636,7 +22492,7 @@
                 </a:solidFill>
                 <a:latin typeface="Segoe UI"/>
               </a:rPr>
-              <a:t>616</a:t>
+              <a:t>Daily</a:t>
             </a:r>
           </a:p>
         </p:txBody>
@@ -22649,7 +22505,7 @@
         </p:nvSpPr>
         <p:spPr>
           <a:xfrm>
-            <a:off x="8183879" y="2788920"/>
+            <a:off x="8183879" y="3794760"/>
             <a:ext cx="3429000" cy="457200"/>
           </a:xfrm>
           <a:prstGeom prst="rect">
@@ -22678,7 +22534,7 @@
                 </a:solidFill>
                 <a:latin typeface="Segoe UI"/>
               </a:rPr>
-              <a:t>pages of training manual and customer standard, read page by page.</a:t>
+              <a:t>at the cells, attending robot stops with the technicians.</a:t>
             </a:r>
           </a:p>
         </p:txBody>
@@ -22691,7 +22547,7 @@
         </p:nvSpPr>
         <p:spPr>
           <a:xfrm>
-            <a:off x="8183879" y="3337560"/>
+            <a:off x="8183879" y="4343400"/>
             <a:ext cx="3474720" cy="457200"/>
           </a:xfrm>
           <a:prstGeom prst="rect">
@@ -22720,7 +22576,7 @@
                 </a:solidFill>
                 <a:latin typeface="Segoe UI"/>
               </a:rPr>
-              <a:t>Daily</a:t>
+              <a:t>25</a:t>
             </a:r>
           </a:p>
         </p:txBody>
@@ -22728,90 +22584,6 @@
       <p:sp>
         <p:nvSpPr>
           <p:cNvPr id="27" name="TextBox 26"/>
-          <p:cNvSpPr txBox="1"/>
-          <p:nvPr/>
-        </p:nvSpPr>
-        <p:spPr>
-          <a:xfrm>
-            <a:off x="8183879" y="3794760"/>
-            <a:ext cx="3429000" cy="457200"/>
-          </a:xfrm>
-          <a:prstGeom prst="rect">
-            <a:avLst/>
-          </a:prstGeom>
-          <a:noFill/>
-        </p:spPr>
-        <p:txBody>
-          <a:bodyPr wrap="square" lIns="0" rIns="0" tIns="0" bIns="0" anchor="t">
-            <a:spAutoFit/>
-          </a:bodyPr>
-          <a:lstStyle/>
-          <a:p>
-            <a:pPr algn="l">
-              <a:spcBef>
-                <a:spcPts val="0"/>
-              </a:spcBef>
-              <a:spcAft>
-                <a:spcPts val="0"/>
-              </a:spcAft>
-            </a:pPr>
-            <a:r>
-              <a:rPr sz="1200" b="0" i="0">
-                <a:solidFill>
-                  <a:srgbClr val="C6CDD1"/>
-                </a:solidFill>
-                <a:latin typeface="Segoe UI"/>
-              </a:rPr>
-              <a:t>at the cells, attending robot stops with the technicians.</a:t>
-            </a:r>
-          </a:p>
-        </p:txBody>
-      </p:sp>
-      <p:sp>
-        <p:nvSpPr>
-          <p:cNvPr id="28" name="TextBox 27"/>
-          <p:cNvSpPr txBox="1"/>
-          <p:nvPr/>
-        </p:nvSpPr>
-        <p:spPr>
-          <a:xfrm>
-            <a:off x="8183879" y="4343400"/>
-            <a:ext cx="3474720" cy="457200"/>
-          </a:xfrm>
-          <a:prstGeom prst="rect">
-            <a:avLst/>
-          </a:prstGeom>
-          <a:noFill/>
-        </p:spPr>
-        <p:txBody>
-          <a:bodyPr wrap="square" lIns="0" rIns="0" tIns="0" bIns="0" anchor="t">
-            <a:spAutoFit/>
-          </a:bodyPr>
-          <a:lstStyle/>
-          <a:p>
-            <a:pPr algn="l">
-              <a:spcBef>
-                <a:spcPts val="0"/>
-              </a:spcBef>
-              <a:spcAft>
-                <a:spcPts val="0"/>
-              </a:spcAft>
-            </a:pPr>
-            <a:r>
-              <a:rPr sz="2600" b="1" i="0">
-                <a:solidFill>
-                  <a:srgbClr val="D5FB00"/>
-                </a:solidFill>
-                <a:latin typeface="Segoe UI"/>
-              </a:rPr>
-              <a:t>25</a:t>
-            </a:r>
-          </a:p>
-        </p:txBody>
-      </p:sp>
-      <p:sp>
-        <p:nvSpPr>
-          <p:cNvPr id="29" name="TextBox 28"/>
           <p:cNvSpPr txBox="1"/>
           <p:nvPr/>
         </p:nvSpPr>
@@ -24911,22 +24683,12 @@
           </a:p>
         </p:txBody>
       </p:sp>
-      <p:pic>
-        <p:nvPicPr>
-          <p:cNvPr id="4" name="!! Glass A" descr="Decorative glass panel"/>
-          <p:cNvPicPr>
-            <a:picLocks noChangeAspect="1"/>
-          </p:cNvPicPr>
+      <p:sp>
+        <p:nvSpPr>
+          <p:cNvPr id="4" name="!! Glass A"/>
+          <p:cNvSpPr/>
           <p:nvPr/>
-        </p:nvPicPr>
-        <p:blipFill>
-          <a:blip r:embed="rId2">
-            <a:alphaModFix amt="50000"/>
-          </a:blip>
-          <a:stretch>
-            <a:fillRect/>
-          </a:stretch>
-        </p:blipFill>
+        </p:nvSpPr>
         <p:spPr>
           <a:xfrm>
             <a:off x="256032" y="1600200"/>
@@ -24935,23 +24697,14 @@
           <a:prstGeom prst="rect">
             <a:avLst/>
           </a:prstGeom>
-        </p:spPr>
-      </p:pic>
-      <p:sp>
-        <p:nvSpPr>
-          <p:cNvPr id="5" name="!! Glass A rim"/>
-          <p:cNvSpPr/>
-          <p:nvPr/>
-        </p:nvSpPr>
-        <p:spPr>
-          <a:xfrm>
-            <a:off x="256032" y="1600200"/>
-            <a:ext cx="4754880" cy="3886200"/>
-          </a:xfrm>
-          <a:prstGeom prst="rect">
-            <a:avLst/>
-          </a:prstGeom>
-          <a:noFill/>
+          <a:blipFill rotWithShape="1">
+            <a:blip r:embed="rId2">
+              <a:alphaModFix amt="50000"/>
+            </a:blip>
+            <a:stretch>
+              <a:fillRect/>
+            </a:stretch>
+          </a:blipFill>
           <a:ln w="9525">
             <a:solidFill>
               <a:srgbClr val="FFFFFF">
@@ -24970,14 +24723,56 @@
       </p:sp>
       <p:sp>
         <p:nvSpPr>
+          <p:cNvPr id="5" name="TextBox 4"/>
+          <p:cNvSpPr txBox="1"/>
+          <p:nvPr/>
+        </p:nvSpPr>
+        <p:spPr>
+          <a:xfrm>
+            <a:off x="621792" y="1828800"/>
+            <a:ext cx="4023360" cy="822960"/>
+          </a:xfrm>
+          <a:prstGeom prst="rect">
+            <a:avLst/>
+          </a:prstGeom>
+          <a:noFill/>
+        </p:spPr>
+        <p:txBody>
+          <a:bodyPr wrap="square" lIns="0" rIns="0" tIns="0" bIns="0" anchor="t">
+            <a:spAutoFit/>
+          </a:bodyPr>
+          <a:lstStyle/>
+          <a:p>
+            <a:pPr algn="l">
+              <a:spcBef>
+                <a:spcPts val="0"/>
+              </a:spcBef>
+              <a:spcAft>
+                <a:spcPts val="0"/>
+              </a:spcAft>
+            </a:pPr>
+            <a:r>
+              <a:rPr sz="5400" b="1" i="0">
+                <a:solidFill>
+                  <a:srgbClr val="D5FB00"/>
+                </a:solidFill>
+                <a:latin typeface="Segoe UI"/>
+              </a:rPr>
+              <a:t>60%</a:t>
+            </a:r>
+          </a:p>
+        </p:txBody>
+      </p:sp>
+      <p:sp>
+        <p:nvSpPr>
           <p:cNvPr id="6" name="TextBox 5"/>
           <p:cNvSpPr txBox="1"/>
           <p:nvPr/>
         </p:nvSpPr>
         <p:spPr>
           <a:xfrm>
-            <a:off x="621792" y="1828800"/>
-            <a:ext cx="4023360" cy="822960"/>
+            <a:off x="621792" y="2697480"/>
+            <a:ext cx="4023360" cy="548640"/>
           </a:xfrm>
           <a:prstGeom prst="rect">
             <a:avLst/>
@@ -24999,48 +24794,6 @@
               </a:spcAft>
             </a:pPr>
             <a:r>
-              <a:rPr sz="5400" b="1" i="0">
-                <a:solidFill>
-                  <a:srgbClr val="D5FB00"/>
-                </a:solidFill>
-                <a:latin typeface="Segoe UI"/>
-              </a:rPr>
-              <a:t>60%</a:t>
-            </a:r>
-          </a:p>
-        </p:txBody>
-      </p:sp>
-      <p:sp>
-        <p:nvSpPr>
-          <p:cNvPr id="7" name="TextBox 6"/>
-          <p:cNvSpPr txBox="1"/>
-          <p:nvPr/>
-        </p:nvSpPr>
-        <p:spPr>
-          <a:xfrm>
-            <a:off x="621792" y="2697480"/>
-            <a:ext cx="4023360" cy="548640"/>
-          </a:xfrm>
-          <a:prstGeom prst="rect">
-            <a:avLst/>
-          </a:prstGeom>
-          <a:noFill/>
-        </p:spPr>
-        <p:txBody>
-          <a:bodyPr wrap="square" lIns="0" rIns="0" tIns="0" bIns="0" anchor="t">
-            <a:spAutoFit/>
-          </a:bodyPr>
-          <a:lstStyle/>
-          <a:p>
-            <a:pPr algn="l">
-              <a:spcBef>
-                <a:spcPts val="0"/>
-              </a:spcBef>
-              <a:spcAft>
-                <a:spcPts val="0"/>
-              </a:spcAft>
-            </a:pPr>
-            <a:r>
               <a:rPr sz="1400" b="1" i="0">
                 <a:solidFill>
                   <a:srgbClr val="FFFFFF"/>
@@ -25054,7 +24807,7 @@
       </p:sp>
       <p:sp>
         <p:nvSpPr>
-          <p:cNvPr id="8" name="Rectangle 7"/>
+          <p:cNvPr id="7" name="Rectangle 6"/>
           <p:cNvSpPr/>
           <p:nvPr/>
         </p:nvSpPr>
@@ -25085,7 +24838,7 @@
       </p:sp>
       <p:sp>
         <p:nvSpPr>
-          <p:cNvPr id="9" name="Rectangle 8"/>
+          <p:cNvPr id="8" name="Rectangle 7"/>
           <p:cNvSpPr/>
           <p:nvPr/>
         </p:nvSpPr>
@@ -25114,14 +24867,56 @@
       </p:sp>
       <p:sp>
         <p:nvSpPr>
+          <p:cNvPr id="9" name="TextBox 8"/>
+          <p:cNvSpPr txBox="1"/>
+          <p:nvPr/>
+        </p:nvSpPr>
+        <p:spPr>
+          <a:xfrm>
+            <a:off x="621792" y="3886200"/>
+            <a:ext cx="4023360" cy="548640"/>
+          </a:xfrm>
+          <a:prstGeom prst="rect">
+            <a:avLst/>
+          </a:prstGeom>
+          <a:noFill/>
+        </p:spPr>
+        <p:txBody>
+          <a:bodyPr wrap="square" lIns="0" rIns="0" tIns="0" bIns="0" anchor="t">
+            <a:spAutoFit/>
+          </a:bodyPr>
+          <a:lstStyle/>
+          <a:p>
+            <a:pPr algn="l">
+              <a:spcBef>
+                <a:spcPts val="0"/>
+              </a:spcBef>
+              <a:spcAft>
+                <a:spcPts val="0"/>
+              </a:spcAft>
+            </a:pPr>
+            <a:r>
+              <a:rPr sz="3000" b="1" i="0">
+                <a:solidFill>
+                  <a:srgbClr val="FFFFFF"/>
+                </a:solidFill>
+                <a:latin typeface="Segoe UI"/>
+              </a:rPr>
+              <a:t>40%</a:t>
+            </a:r>
+          </a:p>
+        </p:txBody>
+      </p:sp>
+      <p:sp>
+        <p:nvSpPr>
           <p:cNvPr id="10" name="TextBox 9"/>
           <p:cNvSpPr txBox="1"/>
           <p:nvPr/>
         </p:nvSpPr>
         <p:spPr>
           <a:xfrm>
-            <a:off x="621792" y="3886200"/>
-            <a:ext cx="4023360" cy="548640"/>
+            <a:off x="621792" y="4434840"/>
+            <a:ext cx="4023360" cy="822960"/>
           </a:xfrm>
           <a:prstGeom prst="rect">
             <a:avLst/>
@@ -25143,48 +24938,6 @@
               </a:spcAft>
             </a:pPr>
             <a:r>
-              <a:rPr sz="3000" b="1" i="0">
-                <a:solidFill>
-                  <a:srgbClr val="FFFFFF"/>
-                </a:solidFill>
-                <a:latin typeface="Segoe UI"/>
-              </a:rPr>
-              <a:t>40%</a:t>
-            </a:r>
-          </a:p>
-        </p:txBody>
-      </p:sp>
-      <p:sp>
-        <p:nvSpPr>
-          <p:cNvPr id="11" name="TextBox 10"/>
-          <p:cNvSpPr txBox="1"/>
-          <p:nvPr/>
-        </p:nvSpPr>
-        <p:spPr>
-          <a:xfrm>
-            <a:off x="621792" y="4434840"/>
-            <a:ext cx="4023360" cy="822960"/>
-          </a:xfrm>
-          <a:prstGeom prst="rect">
-            <a:avLst/>
-          </a:prstGeom>
-          <a:noFill/>
-        </p:spPr>
-        <p:txBody>
-          <a:bodyPr wrap="square" lIns="0" rIns="0" tIns="0" bIns="0" anchor="t">
-            <a:spAutoFit/>
-          </a:bodyPr>
-          <a:lstStyle/>
-          <a:p>
-            <a:pPr algn="l">
-              <a:spcBef>
-                <a:spcPts val="0"/>
-              </a:spcBef>
-              <a:spcAft>
-                <a:spcPts val="0"/>
-              </a:spcAft>
-            </a:pPr>
-            <a:r>
               <a:rPr sz="1200" b="0" i="0">
                 <a:solidFill>
                   <a:srgbClr val="C6CDD1"/>
@@ -25196,22 +24949,12 @@
           </a:p>
         </p:txBody>
       </p:sp>
-      <p:pic>
-        <p:nvPicPr>
-          <p:cNvPr id="12" name="!! Glass B" descr="Decorative glass panel"/>
-          <p:cNvPicPr>
-            <a:picLocks noChangeAspect="1"/>
-          </p:cNvPicPr>
+      <p:sp>
+        <p:nvSpPr>
+          <p:cNvPr id="11" name="!! Glass B"/>
+          <p:cNvSpPr/>
           <p:nvPr/>
-        </p:nvPicPr>
-        <p:blipFill>
-          <a:blip r:embed="rId3">
-            <a:alphaModFix amt="50000"/>
-          </a:blip>
-          <a:stretch>
-            <a:fillRect/>
-          </a:stretch>
-        </p:blipFill>
+        </p:nvSpPr>
         <p:spPr>
           <a:xfrm>
             <a:off x="5303520" y="1600200"/>
@@ -25220,23 +24963,14 @@
           <a:prstGeom prst="rect">
             <a:avLst/>
           </a:prstGeom>
-        </p:spPr>
-      </p:pic>
-      <p:sp>
-        <p:nvSpPr>
-          <p:cNvPr id="13" name="!! Glass B rim"/>
-          <p:cNvSpPr/>
-          <p:nvPr/>
-        </p:nvSpPr>
-        <p:spPr>
-          <a:xfrm>
-            <a:off x="5303520" y="1600200"/>
-            <a:ext cx="6629400" cy="3886200"/>
-          </a:xfrm>
-          <a:prstGeom prst="rect">
-            <a:avLst/>
-          </a:prstGeom>
-          <a:noFill/>
+          <a:blipFill rotWithShape="1">
+            <a:blip r:embed="rId3">
+              <a:alphaModFix amt="50000"/>
+            </a:blip>
+            <a:stretch>
+              <a:fillRect/>
+            </a:stretch>
+          </a:blipFill>
           <a:ln w="9525">
             <a:solidFill>
               <a:srgbClr val="FFFFFF">
@@ -25255,7 +24989,7 @@
       </p:sp>
       <p:sp>
         <p:nvSpPr>
-          <p:cNvPr id="14" name="TextBox 13"/>
+          <p:cNvPr id="12" name="TextBox 11"/>
           <p:cNvSpPr txBox="1"/>
           <p:nvPr/>
         </p:nvSpPr>
@@ -25297,7 +25031,7 @@
       </p:sp>
       <p:sp>
         <p:nvSpPr>
-          <p:cNvPr id="15" name="TextBox 14"/>
+          <p:cNvPr id="13" name="TextBox 12"/>
           <p:cNvSpPr txBox="1"/>
           <p:nvPr/>
         </p:nvSpPr>
@@ -25342,7 +25076,7 @@
       </p:sp>
       <p:sp>
         <p:nvSpPr>
-          <p:cNvPr id="16" name="Rectangle 15"/>
+          <p:cNvPr id="14" name="Rectangle 13"/>
           <p:cNvSpPr/>
           <p:nvPr/>
         </p:nvSpPr>
@@ -25371,7 +25105,7 @@
       </p:sp>
       <p:sp>
         <p:nvSpPr>
-          <p:cNvPr id="17" name="TextBox 16"/>
+          <p:cNvPr id="15" name="TextBox 14"/>
           <p:cNvSpPr txBox="1"/>
           <p:nvPr/>
         </p:nvSpPr>
@@ -25413,7 +25147,7 @@
       </p:sp>
       <p:sp>
         <p:nvSpPr>
-          <p:cNvPr id="18" name="TextBox 17"/>
+          <p:cNvPr id="16" name="TextBox 15"/>
           <p:cNvSpPr txBox="1"/>
           <p:nvPr/>
         </p:nvSpPr>

</xml_diff>